<commit_message>
Pushed last changes from Data Scotland presentation
</commit_message>
<xml_diff>
--- a/temporal-tables/slides/temporal-tables.pptx
+++ b/temporal-tables/slides/temporal-tables.pptx
@@ -13,12 +13,13 @@
     <p:sldId id="257" r:id="rId7"/>
     <p:sldId id="262" r:id="rId8"/>
     <p:sldId id="265" r:id="rId9"/>
-    <p:sldId id="263" r:id="rId10"/>
-    <p:sldId id="264" r:id="rId11"/>
-    <p:sldId id="266" r:id="rId12"/>
-    <p:sldId id="258" r:id="rId13"/>
-    <p:sldId id="267" r:id="rId14"/>
-    <p:sldId id="268" r:id="rId15"/>
+    <p:sldId id="269" r:id="rId10"/>
+    <p:sldId id="263" r:id="rId11"/>
+    <p:sldId id="264" r:id="rId12"/>
+    <p:sldId id="266" r:id="rId13"/>
+    <p:sldId id="258" r:id="rId14"/>
+    <p:sldId id="267" r:id="rId15"/>
+    <p:sldId id="268" r:id="rId16"/>
   </p:sldIdLst>
   <p:sldSz cx="12192000" cy="6858000"/>
   <p:notesSz cx="6858000" cy="9144000"/>
@@ -11481,6 +11482,72 @@
       </p:grpSpPr>
       <p:pic>
         <p:nvPicPr>
+          <p:cNvPr id="3" name="Picture 2" descr="A group of logos on a white background&#10;&#10;AI-generated content may be incorrect.">
+            <a:extLst>
+              <a:ext uri="{FF2B5EF4-FFF2-40B4-BE49-F238E27FC236}">
+                <a16:creationId xmlns:a16="http://schemas.microsoft.com/office/drawing/2014/main" id="{A078A602-BC7E-9251-368C-903E58F03BC6}"/>
+              </a:ext>
+            </a:extLst>
+          </p:cNvPr>
+          <p:cNvPicPr>
+            <a:picLocks noChangeAspect="1"/>
+          </p:cNvPicPr>
+          <p:nvPr/>
+        </p:nvPicPr>
+        <p:blipFill>
+          <a:blip r:embed="rId2">
+            <a:extLst>
+              <a:ext uri="{28A0092B-C50C-407E-A947-70E740481C1C}">
+                <a14:useLocalDpi xmlns:a14="http://schemas.microsoft.com/office/drawing/2010/main" val="0"/>
+              </a:ext>
+            </a:extLst>
+          </a:blip>
+          <a:stretch>
+            <a:fillRect/>
+          </a:stretch>
+        </p:blipFill>
+        <p:spPr>
+          <a:xfrm>
+            <a:off x="0" y="0"/>
+            <a:ext cx="12192000" cy="6858000"/>
+          </a:xfrm>
+          <a:prstGeom prst="rect">
+            <a:avLst/>
+          </a:prstGeom>
+        </p:spPr>
+      </p:pic>
+    </p:spTree>
+    <p:extLst>
+      <p:ext uri="{BB962C8B-B14F-4D97-AF65-F5344CB8AC3E}">
+        <p14:creationId xmlns:p14="http://schemas.microsoft.com/office/powerpoint/2010/main" val="360305890"/>
+      </p:ext>
+    </p:extLst>
+  </p:cSld>
+  <p:clrMapOvr>
+    <a:masterClrMapping/>
+  </p:clrMapOvr>
+</p:sld>
+</file>
+
+<file path=ppt/slides/slide11.xml><?xml version="1.0" encoding="utf-8"?>
+<p:sld xmlns:a="http://schemas.openxmlformats.org/drawingml/2006/main" xmlns:r="http://schemas.openxmlformats.org/officeDocument/2006/relationships" xmlns:p="http://schemas.openxmlformats.org/presentationml/2006/main">
+  <p:cSld>
+    <p:spTree>
+      <p:nvGrpSpPr>
+        <p:cNvPr id="1" name=""/>
+        <p:cNvGrpSpPr/>
+        <p:nvPr/>
+      </p:nvGrpSpPr>
+      <p:grpSpPr>
+        <a:xfrm>
+          <a:off x="0" y="0"/>
+          <a:ext cx="0" cy="0"/>
+          <a:chOff x="0" y="0"/>
+          <a:chExt cx="0" cy="0"/>
+        </a:xfrm>
+      </p:grpSpPr>
+      <p:pic>
+        <p:nvPicPr>
           <p:cNvPr id="10" name="Picture 9" descr="A cow wearing sunglasses&#10;&#10;AI-generated content may be incorrect.">
             <a:extLst>
               <a:ext uri="{FF2B5EF4-FFF2-40B4-BE49-F238E27FC236}">
@@ -11528,7 +11595,7 @@
 </p:sld>
 </file>
 
-<file path=ppt/slides/slide11.xml><?xml version="1.0" encoding="utf-8"?>
+<file path=ppt/slides/slide12.xml><?xml version="1.0" encoding="utf-8"?>
 <p:sld xmlns:a="http://schemas.openxmlformats.org/drawingml/2006/main" xmlns:r="http://schemas.openxmlformats.org/officeDocument/2006/relationships" xmlns:p="http://schemas.openxmlformats.org/presentationml/2006/main">
   <p:cSld>
     <p:spTree>
@@ -11594,7 +11661,7 @@
 </p:sld>
 </file>
 
-<file path=ppt/slides/slide12.xml><?xml version="1.0" encoding="utf-8"?>
+<file path=ppt/slides/slide13.xml><?xml version="1.0" encoding="utf-8"?>
 <p:sld xmlns:a="http://schemas.openxmlformats.org/drawingml/2006/main" xmlns:r="http://schemas.openxmlformats.org/officeDocument/2006/relationships" xmlns:p="http://schemas.openxmlformats.org/presentationml/2006/main">
   <p:cSld>
     <p:spTree>
@@ -13086,7 +13153,7 @@
           <p:cNvPr id="2" name="Title 1">
             <a:extLst>
               <a:ext uri="{FF2B5EF4-FFF2-40B4-BE49-F238E27FC236}">
-                <a16:creationId xmlns:a16="http://schemas.microsoft.com/office/drawing/2014/main" id="{CB8A1E9D-B2EF-967E-E277-90525DD93FE1}"/>
+                <a16:creationId xmlns:a16="http://schemas.microsoft.com/office/drawing/2014/main" id="{D2FA1F3D-EE82-F800-E95F-B6F4B48C007C}"/>
               </a:ext>
             </a:extLst>
           </p:cNvPr>
@@ -13104,7 +13171,7 @@
           <a:p>
             <a:r>
               <a:rPr lang="en-GB" dirty="0"/>
-              <a:t>How does it work?</a:t>
+              <a:t>Gotchas</a:t>
             </a:r>
             <a:endParaRPr lang="LID4096" dirty="0"/>
           </a:p>
@@ -13115,7 +13182,7 @@
           <p:cNvPr id="3" name="Content Placeholder 2">
             <a:extLst>
               <a:ext uri="{FF2B5EF4-FFF2-40B4-BE49-F238E27FC236}">
-                <a16:creationId xmlns:a16="http://schemas.microsoft.com/office/drawing/2014/main" id="{D41930CA-9BC4-3C7B-0266-4EAD77066D04}"/>
+                <a16:creationId xmlns:a16="http://schemas.microsoft.com/office/drawing/2014/main" id="{B55B0A67-E132-A29C-7302-D99065A7C9D2}"/>
               </a:ext>
             </a:extLst>
           </p:cNvPr>
@@ -13128,43 +13195,371 @@
         </p:nvSpPr>
         <p:spPr/>
         <p:txBody>
-          <a:bodyPr>
-            <a:normAutofit/>
-          </a:bodyPr>
-          <a:lstStyle/>
-          <a:p>
-            <a:pPr marL="0" indent="0">
-              <a:buNone/>
-            </a:pPr>
-            <a:r>
-              <a:rPr lang="en-GB" sz="8000" dirty="0"/>
-              <a:t>Demo</a:t>
-            </a:r>
-          </a:p>
-          <a:p>
-            <a:pPr marL="0" indent="0">
-              <a:buNone/>
-            </a:pPr>
-            <a:endParaRPr lang="en-GB" sz="8000" dirty="0"/>
-          </a:p>
-          <a:p>
-            <a:pPr marL="0" indent="0">
-              <a:buNone/>
-            </a:pPr>
-            <a:endParaRPr lang="LID4096" sz="4000" dirty="0"/>
+          <a:bodyPr/>
+          <a:lstStyle/>
+          <a:p>
+            <a:r>
+              <a:rPr lang="en-GB" dirty="0"/>
+              <a:t>Selecting historical records means accessing both the “current” and the history table.</a:t>
+            </a:r>
+          </a:p>
+          <a:p>
+            <a:pPr lvl="1"/>
+            <a:r>
+              <a:rPr lang="en-GB" dirty="0"/>
+              <a:t>Look at execution plans, figure out indexing patterns for your history table</a:t>
+            </a:r>
+          </a:p>
+          <a:p>
+            <a:r>
+              <a:rPr lang="en-GB" dirty="0"/>
+              <a:t>Everything is duplicated. The whole row, not just the changes.</a:t>
+            </a:r>
+          </a:p>
+          <a:p>
+            <a:pPr lvl="1"/>
+            <a:r>
+              <a:rPr lang="en-GB" dirty="0"/>
+              <a:t>80 columns in a table, two or three columns that can ever change =&gt; Probably worth reworking your data model</a:t>
+            </a:r>
+          </a:p>
+          <a:p>
+            <a:r>
+              <a:rPr lang="en-GB" dirty="0"/>
+              <a:t>Purging historical records</a:t>
+            </a:r>
+          </a:p>
+          <a:p>
+            <a:pPr lvl="1"/>
+            <a:r>
+              <a:rPr lang="en-GB" dirty="0"/>
+              <a:t>Set HISTORY_RETENTION_PERIOD when you enable system versioning</a:t>
+            </a:r>
+          </a:p>
+          <a:p>
+            <a:pPr lvl="1"/>
+            <a:r>
+              <a:rPr lang="en-GB" dirty="0"/>
+              <a:t>Or (probably more effective for you) – partition the history table and switch out the oldest partition in a scheduled job</a:t>
+            </a:r>
+            <a:endParaRPr lang="LID4096" dirty="0"/>
           </a:p>
         </p:txBody>
       </p:sp>
     </p:spTree>
     <p:extLst>
       <p:ext uri="{BB962C8B-B14F-4D97-AF65-F5344CB8AC3E}">
-        <p14:creationId xmlns:p14="http://schemas.microsoft.com/office/powerpoint/2010/main" val="476182960"/>
+        <p14:creationId xmlns:p14="http://schemas.microsoft.com/office/powerpoint/2010/main" val="1077638215"/>
       </p:ext>
     </p:extLst>
   </p:cSld>
   <p:clrMapOvr>
     <a:masterClrMapping/>
   </p:clrMapOvr>
+  <p:timing>
+    <p:tnLst>
+      <p:par>
+        <p:cTn id="1" dur="indefinite" restart="never" nodeType="tmRoot">
+          <p:childTnLst>
+            <p:seq concurrent="1" nextAc="seek">
+              <p:cTn id="2" dur="indefinite" nodeType="mainSeq">
+                <p:childTnLst>
+                  <p:par>
+                    <p:cTn id="3" fill="hold">
+                      <p:stCondLst>
+                        <p:cond delay="indefinite"/>
+                      </p:stCondLst>
+                      <p:childTnLst>
+                        <p:par>
+                          <p:cTn id="4" fill="hold">
+                            <p:stCondLst>
+                              <p:cond delay="0"/>
+                            </p:stCondLst>
+                            <p:childTnLst>
+                              <p:par>
+                                <p:cTn id="5" presetID="1" presetClass="entr" presetSubtype="0" fill="hold" grpId="0" nodeType="clickEffect">
+                                  <p:stCondLst>
+                                    <p:cond delay="0"/>
+                                  </p:stCondLst>
+                                  <p:childTnLst>
+                                    <p:set>
+                                      <p:cBhvr>
+                                        <p:cTn id="6" dur="1" fill="hold">
+                                          <p:stCondLst>
+                                            <p:cond delay="0"/>
+                                          </p:stCondLst>
+                                        </p:cTn>
+                                        <p:tgtEl>
+                                          <p:spTgt spid="3">
+                                            <p:txEl>
+                                              <p:pRg st="0" end="0"/>
+                                            </p:txEl>
+                                          </p:spTgt>
+                                        </p:tgtEl>
+                                        <p:attrNameLst>
+                                          <p:attrName>style.visibility</p:attrName>
+                                        </p:attrNameLst>
+                                      </p:cBhvr>
+                                      <p:to>
+                                        <p:strVal val="visible"/>
+                                      </p:to>
+                                    </p:set>
+                                  </p:childTnLst>
+                                </p:cTn>
+                              </p:par>
+                              <p:par>
+                                <p:cTn id="7" presetID="1" presetClass="entr" presetSubtype="0" fill="hold" grpId="0" nodeType="withEffect">
+                                  <p:stCondLst>
+                                    <p:cond delay="0"/>
+                                  </p:stCondLst>
+                                  <p:childTnLst>
+                                    <p:set>
+                                      <p:cBhvr>
+                                        <p:cTn id="8" dur="1" fill="hold">
+                                          <p:stCondLst>
+                                            <p:cond delay="0"/>
+                                          </p:stCondLst>
+                                        </p:cTn>
+                                        <p:tgtEl>
+                                          <p:spTgt spid="3">
+                                            <p:txEl>
+                                              <p:pRg st="1" end="1"/>
+                                            </p:txEl>
+                                          </p:spTgt>
+                                        </p:tgtEl>
+                                        <p:attrNameLst>
+                                          <p:attrName>style.visibility</p:attrName>
+                                        </p:attrNameLst>
+                                      </p:cBhvr>
+                                      <p:to>
+                                        <p:strVal val="visible"/>
+                                      </p:to>
+                                    </p:set>
+                                  </p:childTnLst>
+                                </p:cTn>
+                              </p:par>
+                            </p:childTnLst>
+                          </p:cTn>
+                        </p:par>
+                      </p:childTnLst>
+                    </p:cTn>
+                  </p:par>
+                  <p:par>
+                    <p:cTn id="9" fill="hold">
+                      <p:stCondLst>
+                        <p:cond delay="indefinite"/>
+                      </p:stCondLst>
+                      <p:childTnLst>
+                        <p:par>
+                          <p:cTn id="10" fill="hold">
+                            <p:stCondLst>
+                              <p:cond delay="0"/>
+                            </p:stCondLst>
+                            <p:childTnLst>
+                              <p:par>
+                                <p:cTn id="11" presetID="1" presetClass="entr" presetSubtype="0" fill="hold" grpId="0" nodeType="clickEffect">
+                                  <p:stCondLst>
+                                    <p:cond delay="0"/>
+                                  </p:stCondLst>
+                                  <p:childTnLst>
+                                    <p:set>
+                                      <p:cBhvr>
+                                        <p:cTn id="12" dur="1" fill="hold">
+                                          <p:stCondLst>
+                                            <p:cond delay="0"/>
+                                          </p:stCondLst>
+                                        </p:cTn>
+                                        <p:tgtEl>
+                                          <p:spTgt spid="3">
+                                            <p:txEl>
+                                              <p:pRg st="2" end="2"/>
+                                            </p:txEl>
+                                          </p:spTgt>
+                                        </p:tgtEl>
+                                        <p:attrNameLst>
+                                          <p:attrName>style.visibility</p:attrName>
+                                        </p:attrNameLst>
+                                      </p:cBhvr>
+                                      <p:to>
+                                        <p:strVal val="visible"/>
+                                      </p:to>
+                                    </p:set>
+                                  </p:childTnLst>
+                                </p:cTn>
+                              </p:par>
+                              <p:par>
+                                <p:cTn id="13" presetID="1" presetClass="entr" presetSubtype="0" fill="hold" grpId="0" nodeType="withEffect">
+                                  <p:stCondLst>
+                                    <p:cond delay="0"/>
+                                  </p:stCondLst>
+                                  <p:childTnLst>
+                                    <p:set>
+                                      <p:cBhvr>
+                                        <p:cTn id="14" dur="1" fill="hold">
+                                          <p:stCondLst>
+                                            <p:cond delay="0"/>
+                                          </p:stCondLst>
+                                        </p:cTn>
+                                        <p:tgtEl>
+                                          <p:spTgt spid="3">
+                                            <p:txEl>
+                                              <p:pRg st="3" end="3"/>
+                                            </p:txEl>
+                                          </p:spTgt>
+                                        </p:tgtEl>
+                                        <p:attrNameLst>
+                                          <p:attrName>style.visibility</p:attrName>
+                                        </p:attrNameLst>
+                                      </p:cBhvr>
+                                      <p:to>
+                                        <p:strVal val="visible"/>
+                                      </p:to>
+                                    </p:set>
+                                  </p:childTnLst>
+                                </p:cTn>
+                              </p:par>
+                            </p:childTnLst>
+                          </p:cTn>
+                        </p:par>
+                      </p:childTnLst>
+                    </p:cTn>
+                  </p:par>
+                  <p:par>
+                    <p:cTn id="15" fill="hold">
+                      <p:stCondLst>
+                        <p:cond delay="indefinite"/>
+                      </p:stCondLst>
+                      <p:childTnLst>
+                        <p:par>
+                          <p:cTn id="16" fill="hold">
+                            <p:stCondLst>
+                              <p:cond delay="0"/>
+                            </p:stCondLst>
+                            <p:childTnLst>
+                              <p:par>
+                                <p:cTn id="17" presetID="1" presetClass="entr" presetSubtype="0" fill="hold" grpId="0" nodeType="clickEffect">
+                                  <p:stCondLst>
+                                    <p:cond delay="0"/>
+                                  </p:stCondLst>
+                                  <p:childTnLst>
+                                    <p:set>
+                                      <p:cBhvr>
+                                        <p:cTn id="18" dur="1" fill="hold">
+                                          <p:stCondLst>
+                                            <p:cond delay="0"/>
+                                          </p:stCondLst>
+                                        </p:cTn>
+                                        <p:tgtEl>
+                                          <p:spTgt spid="3">
+                                            <p:txEl>
+                                              <p:pRg st="4" end="4"/>
+                                            </p:txEl>
+                                          </p:spTgt>
+                                        </p:tgtEl>
+                                        <p:attrNameLst>
+                                          <p:attrName>style.visibility</p:attrName>
+                                        </p:attrNameLst>
+                                      </p:cBhvr>
+                                      <p:to>
+                                        <p:strVal val="visible"/>
+                                      </p:to>
+                                    </p:set>
+                                  </p:childTnLst>
+                                </p:cTn>
+                              </p:par>
+                              <p:par>
+                                <p:cTn id="19" presetID="1" presetClass="entr" presetSubtype="0" fill="hold" grpId="0" nodeType="withEffect">
+                                  <p:stCondLst>
+                                    <p:cond delay="0"/>
+                                  </p:stCondLst>
+                                  <p:childTnLst>
+                                    <p:set>
+                                      <p:cBhvr>
+                                        <p:cTn id="20" dur="1" fill="hold">
+                                          <p:stCondLst>
+                                            <p:cond delay="0"/>
+                                          </p:stCondLst>
+                                        </p:cTn>
+                                        <p:tgtEl>
+                                          <p:spTgt spid="3">
+                                            <p:txEl>
+                                              <p:pRg st="5" end="5"/>
+                                            </p:txEl>
+                                          </p:spTgt>
+                                        </p:tgtEl>
+                                        <p:attrNameLst>
+                                          <p:attrName>style.visibility</p:attrName>
+                                        </p:attrNameLst>
+                                      </p:cBhvr>
+                                      <p:to>
+                                        <p:strVal val="visible"/>
+                                      </p:to>
+                                    </p:set>
+                                  </p:childTnLst>
+                                </p:cTn>
+                              </p:par>
+                              <p:par>
+                                <p:cTn id="21" presetID="1" presetClass="entr" presetSubtype="0" fill="hold" grpId="0" nodeType="withEffect">
+                                  <p:stCondLst>
+                                    <p:cond delay="0"/>
+                                  </p:stCondLst>
+                                  <p:childTnLst>
+                                    <p:set>
+                                      <p:cBhvr>
+                                        <p:cTn id="22" dur="1" fill="hold">
+                                          <p:stCondLst>
+                                            <p:cond delay="0"/>
+                                          </p:stCondLst>
+                                        </p:cTn>
+                                        <p:tgtEl>
+                                          <p:spTgt spid="3">
+                                            <p:txEl>
+                                              <p:pRg st="6" end="6"/>
+                                            </p:txEl>
+                                          </p:spTgt>
+                                        </p:tgtEl>
+                                        <p:attrNameLst>
+                                          <p:attrName>style.visibility</p:attrName>
+                                        </p:attrNameLst>
+                                      </p:cBhvr>
+                                      <p:to>
+                                        <p:strVal val="visible"/>
+                                      </p:to>
+                                    </p:set>
+                                  </p:childTnLst>
+                                </p:cTn>
+                              </p:par>
+                            </p:childTnLst>
+                          </p:cTn>
+                        </p:par>
+                      </p:childTnLst>
+                    </p:cTn>
+                  </p:par>
+                </p:childTnLst>
+              </p:cTn>
+              <p:prevCondLst>
+                <p:cond evt="onPrev" delay="0">
+                  <p:tgtEl>
+                    <p:sldTgt/>
+                  </p:tgtEl>
+                </p:cond>
+              </p:prevCondLst>
+              <p:nextCondLst>
+                <p:cond evt="onNext" delay="0">
+                  <p:tgtEl>
+                    <p:sldTgt/>
+                  </p:tgtEl>
+                </p:cond>
+              </p:nextCondLst>
+            </p:seq>
+          </p:childTnLst>
+        </p:cTn>
+      </p:par>
+    </p:tnLst>
+    <p:bldLst>
+      <p:bldP spid="3" grpId="0" build="p"/>
+    </p:bldLst>
+  </p:timing>
 </p:sld>
 </file>
 
@@ -13190,7 +13585,7 @@
           <p:cNvPr id="2" name="Title 1">
             <a:extLst>
               <a:ext uri="{FF2B5EF4-FFF2-40B4-BE49-F238E27FC236}">
-                <a16:creationId xmlns:a16="http://schemas.microsoft.com/office/drawing/2014/main" id="{8BAB9DF0-068F-382F-D987-12A02A3C0C80}"/>
+                <a16:creationId xmlns:a16="http://schemas.microsoft.com/office/drawing/2014/main" id="{CB8A1E9D-B2EF-967E-E277-90525DD93FE1}"/>
               </a:ext>
             </a:extLst>
           </p:cNvPr>
@@ -13208,7 +13603,7 @@
           <a:p>
             <a:r>
               <a:rPr lang="en-GB" dirty="0"/>
-              <a:t>How about business-time?</a:t>
+              <a:t>How does it work?</a:t>
             </a:r>
             <a:endParaRPr lang="LID4096" dirty="0"/>
           </a:p>
@@ -13219,7 +13614,7 @@
           <p:cNvPr id="3" name="Content Placeholder 2">
             <a:extLst>
               <a:ext uri="{FF2B5EF4-FFF2-40B4-BE49-F238E27FC236}">
-                <a16:creationId xmlns:a16="http://schemas.microsoft.com/office/drawing/2014/main" id="{0CD5D623-1F3C-437C-D3A0-CEF6E919D443}"/>
+                <a16:creationId xmlns:a16="http://schemas.microsoft.com/office/drawing/2014/main" id="{D41930CA-9BC4-3C7B-0266-4EAD77066D04}"/>
               </a:ext>
             </a:extLst>
           </p:cNvPr>
@@ -13232,54 +13627,37 @@
         </p:nvSpPr>
         <p:spPr/>
         <p:txBody>
-          <a:bodyPr/>
-          <a:lstStyle/>
-          <a:p>
-            <a:r>
-              <a:rPr lang="en-GB" dirty="0"/>
-              <a:t>Business time dimension</a:t>
-            </a:r>
-          </a:p>
-          <a:p>
-            <a:pPr lvl="1"/>
-            <a:r>
-              <a:rPr lang="en-GB" dirty="0"/>
-              <a:t>Price is updated. But </a:t>
-            </a:r>
-            <a:r>
-              <a:rPr lang="en-GB" dirty="0" err="1"/>
-              <a:t>ValidFrom</a:t>
-            </a:r>
-            <a:r>
-              <a:rPr lang="en-GB" dirty="0"/>
-              <a:t> is not when the row was physically changed</a:t>
-            </a:r>
-          </a:p>
-          <a:p>
-            <a:r>
-              <a:rPr lang="en-GB" dirty="0"/>
-              <a:t>DB/2 has had this since long</a:t>
-            </a:r>
-          </a:p>
-          <a:p>
-            <a:r>
-              <a:rPr lang="en-GB" dirty="0"/>
-              <a:t>Would be more useful for SCD2</a:t>
-            </a:r>
-          </a:p>
-          <a:p>
-            <a:pPr lvl="1"/>
-            <a:r>
-              <a:rPr lang="en-GB" dirty="0"/>
-              <a:t>… and lots of other scenarios</a:t>
-            </a:r>
+          <a:bodyPr>
+            <a:normAutofit/>
+          </a:bodyPr>
+          <a:lstStyle/>
+          <a:p>
+            <a:pPr marL="0" indent="0">
+              <a:buNone/>
+            </a:pPr>
+            <a:r>
+              <a:rPr lang="en-GB" sz="8000" dirty="0"/>
+              <a:t>Demo</a:t>
+            </a:r>
+          </a:p>
+          <a:p>
+            <a:pPr marL="0" indent="0">
+              <a:buNone/>
+            </a:pPr>
+            <a:endParaRPr lang="en-GB" sz="8000" dirty="0"/>
+          </a:p>
+          <a:p>
+            <a:pPr marL="0" indent="0">
+              <a:buNone/>
+            </a:pPr>
+            <a:endParaRPr lang="LID4096" sz="4000" dirty="0"/>
           </a:p>
         </p:txBody>
       </p:sp>
     </p:spTree>
     <p:extLst>
       <p:ext uri="{BB962C8B-B14F-4D97-AF65-F5344CB8AC3E}">
-        <p14:creationId xmlns:p14="http://schemas.microsoft.com/office/powerpoint/2010/main" val="1727796725"/>
+        <p14:creationId xmlns:p14="http://schemas.microsoft.com/office/powerpoint/2010/main" val="476182960"/>
       </p:ext>
     </p:extLst>
   </p:cSld>
@@ -13306,46 +13684,101 @@
           <a:chExt cx="0" cy="0"/>
         </a:xfrm>
       </p:grpSpPr>
-      <p:pic>
-        <p:nvPicPr>
-          <p:cNvPr id="3" name="Picture 2" descr="A group of logos on a white background&#10;&#10;AI-generated content may be incorrect.">
-            <a:extLst>
-              <a:ext uri="{FF2B5EF4-FFF2-40B4-BE49-F238E27FC236}">
-                <a16:creationId xmlns:a16="http://schemas.microsoft.com/office/drawing/2014/main" id="{A078A602-BC7E-9251-368C-903E58F03BC6}"/>
-              </a:ext>
-            </a:extLst>
-          </p:cNvPr>
-          <p:cNvPicPr>
-            <a:picLocks noChangeAspect="1"/>
-          </p:cNvPicPr>
-          <p:nvPr/>
-        </p:nvPicPr>
-        <p:blipFill>
-          <a:blip r:embed="rId2">
-            <a:extLst>
-              <a:ext uri="{28A0092B-C50C-407E-A947-70E740481C1C}">
-                <a14:useLocalDpi xmlns:a14="http://schemas.microsoft.com/office/drawing/2010/main" val="0"/>
-              </a:ext>
-            </a:extLst>
-          </a:blip>
-          <a:stretch>
-            <a:fillRect/>
-          </a:stretch>
-        </p:blipFill>
-        <p:spPr>
-          <a:xfrm>
-            <a:off x="0" y="0"/>
-            <a:ext cx="12192000" cy="6858000"/>
-          </a:xfrm>
-          <a:prstGeom prst="rect">
-            <a:avLst/>
-          </a:prstGeom>
-        </p:spPr>
-      </p:pic>
+      <p:sp>
+        <p:nvSpPr>
+          <p:cNvPr id="2" name="Title 1">
+            <a:extLst>
+              <a:ext uri="{FF2B5EF4-FFF2-40B4-BE49-F238E27FC236}">
+                <a16:creationId xmlns:a16="http://schemas.microsoft.com/office/drawing/2014/main" id="{8BAB9DF0-068F-382F-D987-12A02A3C0C80}"/>
+              </a:ext>
+            </a:extLst>
+          </p:cNvPr>
+          <p:cNvSpPr>
+            <a:spLocks noGrp="1"/>
+          </p:cNvSpPr>
+          <p:nvPr>
+            <p:ph type="title"/>
+          </p:nvPr>
+        </p:nvSpPr>
+        <p:spPr/>
+        <p:txBody>
+          <a:bodyPr/>
+          <a:lstStyle/>
+          <a:p>
+            <a:r>
+              <a:rPr lang="en-GB" dirty="0"/>
+              <a:t>How about business-time?</a:t>
+            </a:r>
+            <a:endParaRPr lang="LID4096" dirty="0"/>
+          </a:p>
+        </p:txBody>
+      </p:sp>
+      <p:sp>
+        <p:nvSpPr>
+          <p:cNvPr id="3" name="Content Placeholder 2">
+            <a:extLst>
+              <a:ext uri="{FF2B5EF4-FFF2-40B4-BE49-F238E27FC236}">
+                <a16:creationId xmlns:a16="http://schemas.microsoft.com/office/drawing/2014/main" id="{0CD5D623-1F3C-437C-D3A0-CEF6E919D443}"/>
+              </a:ext>
+            </a:extLst>
+          </p:cNvPr>
+          <p:cNvSpPr>
+            <a:spLocks noGrp="1"/>
+          </p:cNvSpPr>
+          <p:nvPr>
+            <p:ph idx="1"/>
+          </p:nvPr>
+        </p:nvSpPr>
+        <p:spPr/>
+        <p:txBody>
+          <a:bodyPr/>
+          <a:lstStyle/>
+          <a:p>
+            <a:r>
+              <a:rPr lang="en-GB" dirty="0"/>
+              <a:t>Business time dimension</a:t>
+            </a:r>
+          </a:p>
+          <a:p>
+            <a:pPr lvl="1"/>
+            <a:r>
+              <a:rPr lang="en-GB" dirty="0"/>
+              <a:t>Price is updated. But </a:t>
+            </a:r>
+            <a:r>
+              <a:rPr lang="en-GB" dirty="0" err="1"/>
+              <a:t>ValidFrom</a:t>
+            </a:r>
+            <a:r>
+              <a:rPr lang="en-GB" dirty="0"/>
+              <a:t> is not when the row was physically changed</a:t>
+            </a:r>
+          </a:p>
+          <a:p>
+            <a:r>
+              <a:rPr lang="en-GB" dirty="0"/>
+              <a:t>DB/2 has had this since long</a:t>
+            </a:r>
+          </a:p>
+          <a:p>
+            <a:r>
+              <a:rPr lang="en-GB" dirty="0"/>
+              <a:t>Would be more useful for SCD2</a:t>
+            </a:r>
+          </a:p>
+          <a:p>
+            <a:pPr lvl="1"/>
+            <a:r>
+              <a:rPr lang="en-GB" dirty="0"/>
+              <a:t>… and lots of other scenarios</a:t>
+            </a:r>
+          </a:p>
+        </p:txBody>
+      </p:sp>
     </p:spTree>
     <p:extLst>
       <p:ext uri="{BB962C8B-B14F-4D97-AF65-F5344CB8AC3E}">
-        <p14:creationId xmlns:p14="http://schemas.microsoft.com/office/powerpoint/2010/main" val="360305890"/>
+        <p14:creationId xmlns:p14="http://schemas.microsoft.com/office/powerpoint/2010/main" val="1727796725"/>
       </p:ext>
     </p:extLst>
   </p:cSld>

</xml_diff>

<commit_message>
After SQLBits 2026. Restructured demos to multiple files
</commit_message>
<xml_diff>
--- a/temporal-tables/slides/temporal-tables.pptx
+++ b/temporal-tables/slides/temporal-tables.pptx
@@ -4,22 +4,16 @@
   <p:sldMasterIdLst>
     <p:sldMasterId id="2147483648" r:id="rId1"/>
     <p:sldMasterId id="2147483660" r:id="rId2"/>
-    <p:sldMasterId id="2147483677" r:id="rId3"/>
   </p:sldMasterIdLst>
   <p:sldIdLst>
-    <p:sldId id="260" r:id="rId4"/>
-    <p:sldId id="261" r:id="rId5"/>
-    <p:sldId id="259" r:id="rId6"/>
-    <p:sldId id="257" r:id="rId7"/>
-    <p:sldId id="262" r:id="rId8"/>
-    <p:sldId id="265" r:id="rId9"/>
-    <p:sldId id="269" r:id="rId10"/>
-    <p:sldId id="263" r:id="rId11"/>
-    <p:sldId id="264" r:id="rId12"/>
-    <p:sldId id="266" r:id="rId13"/>
-    <p:sldId id="258" r:id="rId14"/>
-    <p:sldId id="267" r:id="rId15"/>
-    <p:sldId id="268" r:id="rId16"/>
+    <p:sldId id="260" r:id="rId3"/>
+    <p:sldId id="261" r:id="rId4"/>
+    <p:sldId id="257" r:id="rId5"/>
+    <p:sldId id="262" r:id="rId6"/>
+    <p:sldId id="265" r:id="rId7"/>
+    <p:sldId id="269" r:id="rId8"/>
+    <p:sldId id="263" r:id="rId9"/>
+    <p:sldId id="264" r:id="rId10"/>
   </p:sldIdLst>
   <p:sldSz cx="12192000" cy="6858000"/>
   <p:notesSz cx="6858000" cy="9144000"/>
@@ -275,7 +269,7 @@
           <a:p>
             <a:fld id="{DF89F9ED-2410-4CD1-B5CD-D275AA293E22}" type="datetimeFigureOut">
               <a:rPr lang="LID4096" smtClean="0"/>
-              <a:t>09/12/2025</a:t>
+              <a:t>04/20/2026</a:t>
             </a:fld>
             <a:endParaRPr lang="LID4096"/>
           </a:p>
@@ -475,7 +469,7 @@
           <a:p>
             <a:fld id="{DF89F9ED-2410-4CD1-B5CD-D275AA293E22}" type="datetimeFigureOut">
               <a:rPr lang="LID4096" smtClean="0"/>
-              <a:t>09/12/2025</a:t>
+              <a:t>04/20/2026</a:t>
             </a:fld>
             <a:endParaRPr lang="LID4096"/>
           </a:p>
@@ -685,7 +679,7 @@
           <a:p>
             <a:fld id="{DF89F9ED-2410-4CD1-B5CD-D275AA293E22}" type="datetimeFigureOut">
               <a:rPr lang="LID4096" smtClean="0"/>
-              <a:t>09/12/2025</a:t>
+              <a:t>04/20/2026</a:t>
             </a:fld>
             <a:endParaRPr lang="LID4096"/>
           </a:p>
@@ -951,7 +945,7 @@
             <a:fld id="{B61BEF0D-F0BB-DE4B-95CE-6DB70DBA9567}" type="datetimeFigureOut">
               <a:rPr lang="en-US"/>
               <a:pPr/>
-              <a:t>9/12/2025</a:t>
+              <a:t>4/20/2026</a:t>
             </a:fld>
             <a:endParaRPr lang="en-US"/>
           </a:p>
@@ -1015,10 +1009,10 @@
           <p:nvPr userDrawn="1"/>
         </p:nvPicPr>
         <p:blipFill>
-          <a:blip r:embed="rId2">
+          <a:blip>
             <a:extLst>
               <a:ext uri="{96DAC541-7B7A-43D3-8B79-37D633B846F1}">
-                <asvg:svgBlip xmlns:asvg="http://schemas.microsoft.com/office/drawing/2016/SVG/main" r:embed="rId3"/>
+                <asvg:svgBlip xmlns:asvg="http://schemas.microsoft.com/office/drawing/2016/SVG/main" r:embed="rId2"/>
               </a:ext>
             </a:extLst>
           </a:blip>
@@ -1165,7 +1159,7 @@
             <a:fld id="{B61BEF0D-F0BB-DE4B-95CE-6DB70DBA9567}" type="datetimeFigureOut">
               <a:rPr lang="en-US"/>
               <a:pPr/>
-              <a:t>9/12/2025</a:t>
+              <a:t>4/20/2026</a:t>
             </a:fld>
             <a:endParaRPr lang="en-US"/>
           </a:p>
@@ -1414,7 +1408,7 @@
             <a:fld id="{B61BEF0D-F0BB-DE4B-95CE-6DB70DBA9567}" type="datetimeFigureOut">
               <a:rPr lang="en-US"/>
               <a:pPr/>
-              <a:t>9/12/2025</a:t>
+              <a:t>4/20/2026</a:t>
             </a:fld>
             <a:endParaRPr lang="en-US"/>
           </a:p>
@@ -1647,7 +1641,7 @@
           <a:p>
             <a:fld id="{EB712588-04B1-427B-82EE-E8DB90309F08}" type="datetimeFigureOut">
               <a:rPr lang="en-US"/>
-              <a:t>9/12/2025</a:t>
+              <a:t>4/20/2026</a:t>
             </a:fld>
             <a:endParaRPr lang="en-US"/>
           </a:p>
@@ -2022,7 +2016,7 @@
             <a:fld id="{B61BEF0D-F0BB-DE4B-95CE-6DB70DBA9567}" type="datetimeFigureOut">
               <a:rPr lang="en-US"/>
               <a:pPr/>
-              <a:t>9/12/2025</a:t>
+              <a:t>4/20/2026</a:t>
             </a:fld>
             <a:endParaRPr lang="en-US"/>
           </a:p>
@@ -2147,7 +2141,7 @@
             <a:fld id="{B61BEF0D-F0BB-DE4B-95CE-6DB70DBA9567}" type="datetimeFigureOut">
               <a:rPr lang="en-US"/>
               <a:pPr/>
-              <a:t>9/12/2025</a:t>
+              <a:t>4/20/2026</a:t>
             </a:fld>
             <a:endParaRPr lang="en-US"/>
           </a:p>
@@ -2244,7 +2238,7 @@
             <a:fld id="{B61BEF0D-F0BB-DE4B-95CE-6DB70DBA9567}" type="datetimeFigureOut">
               <a:rPr lang="en-US"/>
               <a:pPr/>
-              <a:t>9/12/2025</a:t>
+              <a:t>4/20/2026</a:t>
             </a:fld>
             <a:endParaRPr lang="en-US"/>
           </a:p>
@@ -2500,7 +2494,7 @@
           <a:p>
             <a:fld id="{42A54C80-263E-416B-A8E0-580EDEADCBDC}" type="datetimeFigureOut">
               <a:rPr lang="en-US"/>
-              <a:t>9/12/2025</a:t>
+              <a:t>4/20/2026</a:t>
             </a:fld>
             <a:endParaRPr lang="en-US"/>
           </a:p>
@@ -2688,7 +2682,7 @@
           <a:p>
             <a:fld id="{DF89F9ED-2410-4CD1-B5CD-D275AA293E22}" type="datetimeFigureOut">
               <a:rPr lang="LID4096" smtClean="0"/>
-              <a:t>09/12/2025</a:t>
+              <a:t>04/20/2026</a:t>
             </a:fld>
             <a:endParaRPr lang="LID4096"/>
           </a:p>
@@ -2964,7 +2958,7 @@
             <a:fld id="{B61BEF0D-F0BB-DE4B-95CE-6DB70DBA9567}" type="datetimeFigureOut">
               <a:rPr lang="en-US"/>
               <a:pPr/>
-              <a:t>9/12/2025</a:t>
+              <a:t>4/20/2026</a:t>
             </a:fld>
             <a:endParaRPr lang="en-US"/>
           </a:p>
@@ -3217,7 +3211,7 @@
             <a:fld id="{B61BEF0D-F0BB-DE4B-95CE-6DB70DBA9567}" type="datetimeFigureOut">
               <a:rPr lang="en-US"/>
               <a:pPr/>
-              <a:t>9/12/2025</a:t>
+              <a:t>4/20/2026</a:t>
             </a:fld>
             <a:endParaRPr lang="en-US"/>
           </a:p>
@@ -3533,7 +3527,7 @@
             <a:fld id="{B61BEF0D-F0BB-DE4B-95CE-6DB70DBA9567}" type="datetimeFigureOut">
               <a:rPr lang="en-US"/>
               <a:pPr/>
-              <a:t>9/12/2025</a:t>
+              <a:t>4/20/2026</a:t>
             </a:fld>
             <a:endParaRPr lang="en-US"/>
           </a:p>
@@ -3876,7 +3870,7 @@
             <a:fld id="{B61BEF0D-F0BB-DE4B-95CE-6DB70DBA9567}" type="datetimeFigureOut">
               <a:rPr lang="en-US"/>
               <a:pPr/>
-              <a:t>9/12/2025</a:t>
+              <a:t>4/20/2026</a:t>
             </a:fld>
             <a:endParaRPr lang="en-US"/>
           </a:p>
@@ -4192,7 +4186,7 @@
             <a:fld id="{B61BEF0D-F0BB-DE4B-95CE-6DB70DBA9567}" type="datetimeFigureOut">
               <a:rPr lang="en-US"/>
               <a:pPr/>
-              <a:t>9/12/2025</a:t>
+              <a:t>4/20/2026</a:t>
             </a:fld>
             <a:endParaRPr lang="en-US"/>
           </a:p>
@@ -4587,7 +4581,7 @@
             <a:fld id="{B61BEF0D-F0BB-DE4B-95CE-6DB70DBA9567}" type="datetimeFigureOut">
               <a:rPr lang="en-US"/>
               <a:pPr/>
-              <a:t>9/12/2025</a:t>
+              <a:t>4/20/2026</a:t>
             </a:fld>
             <a:endParaRPr lang="en-US"/>
           </a:p>
@@ -4758,7 +4752,7 @@
           <a:p>
             <a:fld id="{55C6B4A9-1611-4792-9094-5F34BCA07E0B}" type="datetimeFigureOut">
               <a:rPr lang="en-US"/>
-              <a:t>9/12/2025</a:t>
+              <a:t>4/20/2026</a:t>
             </a:fld>
             <a:endParaRPr lang="en-US"/>
           </a:p>
@@ -4939,7 +4933,7 @@
             <a:fld id="{B61BEF0D-F0BB-DE4B-95CE-6DB70DBA9567}" type="datetimeFigureOut">
               <a:rPr lang="en-US"/>
               <a:pPr/>
-              <a:t>9/12/2025</a:t>
+              <a:t>4/20/2026</a:t>
             </a:fld>
             <a:endParaRPr lang="en-US"/>
           </a:p>
@@ -4992,428 +4986,6 @@
     <p:extLst>
       <p:ext uri="{BB962C8B-B14F-4D97-AF65-F5344CB8AC3E}">
         <p14:creationId xmlns:p14="http://schemas.microsoft.com/office/powerpoint/2010/main" val="1159434314"/>
-      </p:ext>
-    </p:extLst>
-  </p:cSld>
-  <p:clrMapOvr>
-    <a:masterClrMapping/>
-  </p:clrMapOvr>
-</p:sldLayout>
-</file>
-
-<file path=ppt/slideLayouts/slideLayout28.xml><?xml version="1.0" encoding="utf-8"?>
-<p:sldLayout xmlns:a="http://schemas.openxmlformats.org/drawingml/2006/main" xmlns:r="http://schemas.openxmlformats.org/officeDocument/2006/relationships" xmlns:p="http://schemas.openxmlformats.org/presentationml/2006/main" type="title" preserve="1">
-  <p:cSld name="Title Slide">
-    <p:spTree>
-      <p:nvGrpSpPr>
-        <p:cNvPr id="1" name=""/>
-        <p:cNvGrpSpPr/>
-        <p:nvPr/>
-      </p:nvGrpSpPr>
-      <p:grpSpPr>
-        <a:xfrm>
-          <a:off x="0" y="0"/>
-          <a:ext cx="0" cy="0"/>
-          <a:chOff x="0" y="0"/>
-          <a:chExt cx="0" cy="0"/>
-        </a:xfrm>
-      </p:grpSpPr>
-      <p:sp>
-        <p:nvSpPr>
-          <p:cNvPr id="2" name="Title 1">
-            <a:extLst>
-              <a:ext uri="{FF2B5EF4-FFF2-40B4-BE49-F238E27FC236}">
-                <a16:creationId xmlns:a16="http://schemas.microsoft.com/office/drawing/2014/main" id="{4CD8BB35-7573-D613-269E-E95FBF1EB7A3}"/>
-              </a:ext>
-            </a:extLst>
-          </p:cNvPr>
-          <p:cNvSpPr>
-            <a:spLocks noGrp="1"/>
-          </p:cNvSpPr>
-          <p:nvPr>
-            <p:ph type="ctrTitle"/>
-          </p:nvPr>
-        </p:nvSpPr>
-        <p:spPr>
-          <a:xfrm>
-            <a:off x="1524000" y="1122363"/>
-            <a:ext cx="9144000" cy="2387600"/>
-          </a:xfrm>
-        </p:spPr>
-        <p:txBody>
-          <a:bodyPr anchor="b"/>
-          <a:lstStyle>
-            <a:lvl1pPr algn="ctr">
-              <a:defRPr sz="6000"/>
-            </a:lvl1pPr>
-          </a:lstStyle>
-          <a:p>
-            <a:r>
-              <a:rPr lang="en-US"/>
-              <a:t>Click to edit Master title style</a:t>
-            </a:r>
-            <a:endParaRPr lang="en-GB"/>
-          </a:p>
-        </p:txBody>
-      </p:sp>
-      <p:sp>
-        <p:nvSpPr>
-          <p:cNvPr id="3" name="Subtitle 2">
-            <a:extLst>
-              <a:ext uri="{FF2B5EF4-FFF2-40B4-BE49-F238E27FC236}">
-                <a16:creationId xmlns:a16="http://schemas.microsoft.com/office/drawing/2014/main" id="{57A5E402-5B59-FB17-56AB-DA58E3EAF606}"/>
-              </a:ext>
-            </a:extLst>
-          </p:cNvPr>
-          <p:cNvSpPr>
-            <a:spLocks noGrp="1"/>
-          </p:cNvSpPr>
-          <p:nvPr>
-            <p:ph type="subTitle" idx="1"/>
-          </p:nvPr>
-        </p:nvSpPr>
-        <p:spPr>
-          <a:xfrm>
-            <a:off x="1524000" y="3602038"/>
-            <a:ext cx="9144000" cy="1655762"/>
-          </a:xfrm>
-        </p:spPr>
-        <p:txBody>
-          <a:bodyPr/>
-          <a:lstStyle>
-            <a:lvl1pPr marL="0" indent="0" algn="ctr">
-              <a:buNone/>
-              <a:defRPr sz="2400"/>
-            </a:lvl1pPr>
-            <a:lvl2pPr marL="457200" indent="0" algn="ctr">
-              <a:buNone/>
-              <a:defRPr sz="2000"/>
-            </a:lvl2pPr>
-            <a:lvl3pPr marL="914400" indent="0" algn="ctr">
-              <a:buNone/>
-              <a:defRPr sz="1800"/>
-            </a:lvl3pPr>
-            <a:lvl4pPr marL="1371600" indent="0" algn="ctr">
-              <a:buNone/>
-              <a:defRPr sz="1600"/>
-            </a:lvl4pPr>
-            <a:lvl5pPr marL="1828800" indent="0" algn="ctr">
-              <a:buNone/>
-              <a:defRPr sz="1600"/>
-            </a:lvl5pPr>
-            <a:lvl6pPr marL="2286000" indent="0" algn="ctr">
-              <a:buNone/>
-              <a:defRPr sz="1600"/>
-            </a:lvl6pPr>
-            <a:lvl7pPr marL="2743200" indent="0" algn="ctr">
-              <a:buNone/>
-              <a:defRPr sz="1600"/>
-            </a:lvl7pPr>
-            <a:lvl8pPr marL="3200400" indent="0" algn="ctr">
-              <a:buNone/>
-              <a:defRPr sz="1600"/>
-            </a:lvl8pPr>
-            <a:lvl9pPr marL="3657600" indent="0" algn="ctr">
-              <a:buNone/>
-              <a:defRPr sz="1600"/>
-            </a:lvl9pPr>
-          </a:lstStyle>
-          <a:p>
-            <a:r>
-              <a:rPr lang="en-US"/>
-              <a:t>Click to edit Master subtitle style</a:t>
-            </a:r>
-            <a:endParaRPr lang="en-GB"/>
-          </a:p>
-        </p:txBody>
-      </p:sp>
-      <p:sp>
-        <p:nvSpPr>
-          <p:cNvPr id="4" name="Date Placeholder 3">
-            <a:extLst>
-              <a:ext uri="{FF2B5EF4-FFF2-40B4-BE49-F238E27FC236}">
-                <a16:creationId xmlns:a16="http://schemas.microsoft.com/office/drawing/2014/main" id="{B185B88D-A3F9-414F-F76D-BFC653BDAA40}"/>
-              </a:ext>
-            </a:extLst>
-          </p:cNvPr>
-          <p:cNvSpPr>
-            <a:spLocks noGrp="1"/>
-          </p:cNvSpPr>
-          <p:nvPr>
-            <p:ph type="dt" sz="half" idx="10"/>
-          </p:nvPr>
-        </p:nvSpPr>
-        <p:spPr/>
-        <p:txBody>
-          <a:bodyPr/>
-          <a:lstStyle/>
-          <a:p>
-            <a:fld id="{36250D35-438B-41E9-BDE2-B658D3957A6D}" type="datetimeFigureOut">
-              <a:rPr lang="en-GB" smtClean="0"/>
-              <a:t>12/09/2025</a:t>
-            </a:fld>
-            <a:endParaRPr lang="en-GB"/>
-          </a:p>
-        </p:txBody>
-      </p:sp>
-      <p:sp>
-        <p:nvSpPr>
-          <p:cNvPr id="5" name="Footer Placeholder 4">
-            <a:extLst>
-              <a:ext uri="{FF2B5EF4-FFF2-40B4-BE49-F238E27FC236}">
-                <a16:creationId xmlns:a16="http://schemas.microsoft.com/office/drawing/2014/main" id="{254AE639-27AF-4356-4403-72D84D78E878}"/>
-              </a:ext>
-            </a:extLst>
-          </p:cNvPr>
-          <p:cNvSpPr>
-            <a:spLocks noGrp="1"/>
-          </p:cNvSpPr>
-          <p:nvPr>
-            <p:ph type="ftr" sz="quarter" idx="11"/>
-          </p:nvPr>
-        </p:nvSpPr>
-        <p:spPr/>
-        <p:txBody>
-          <a:bodyPr/>
-          <a:lstStyle/>
-          <a:p>
-            <a:endParaRPr lang="en-GB"/>
-          </a:p>
-        </p:txBody>
-      </p:sp>
-      <p:sp>
-        <p:nvSpPr>
-          <p:cNvPr id="6" name="Slide Number Placeholder 5">
-            <a:extLst>
-              <a:ext uri="{FF2B5EF4-FFF2-40B4-BE49-F238E27FC236}">
-                <a16:creationId xmlns:a16="http://schemas.microsoft.com/office/drawing/2014/main" id="{C4678243-FB3D-03F6-90CB-1FA557E75243}"/>
-              </a:ext>
-            </a:extLst>
-          </p:cNvPr>
-          <p:cNvSpPr>
-            <a:spLocks noGrp="1"/>
-          </p:cNvSpPr>
-          <p:nvPr>
-            <p:ph type="sldNum" sz="quarter" idx="12"/>
-          </p:nvPr>
-        </p:nvSpPr>
-        <p:spPr/>
-        <p:txBody>
-          <a:bodyPr/>
-          <a:lstStyle/>
-          <a:p>
-            <a:fld id="{882737FA-DC85-4AD9-8658-285F461F85AF}" type="slidenum">
-              <a:rPr lang="en-GB" smtClean="0"/>
-              <a:t>‹#›</a:t>
-            </a:fld>
-            <a:endParaRPr lang="en-GB"/>
-          </a:p>
-        </p:txBody>
-      </p:sp>
-    </p:spTree>
-    <p:extLst>
-      <p:ext uri="{BB962C8B-B14F-4D97-AF65-F5344CB8AC3E}">
-        <p14:creationId xmlns:p14="http://schemas.microsoft.com/office/powerpoint/2010/main" val="4213332072"/>
-      </p:ext>
-    </p:extLst>
-  </p:cSld>
-  <p:clrMapOvr>
-    <a:masterClrMapping/>
-  </p:clrMapOvr>
-</p:sldLayout>
-</file>
-
-<file path=ppt/slideLayouts/slideLayout29.xml><?xml version="1.0" encoding="utf-8"?>
-<p:sldLayout xmlns:a="http://schemas.openxmlformats.org/drawingml/2006/main" xmlns:r="http://schemas.openxmlformats.org/officeDocument/2006/relationships" xmlns:p="http://schemas.openxmlformats.org/presentationml/2006/main" type="obj" preserve="1">
-  <p:cSld name="Title and Content">
-    <p:spTree>
-      <p:nvGrpSpPr>
-        <p:cNvPr id="1" name=""/>
-        <p:cNvGrpSpPr/>
-        <p:nvPr/>
-      </p:nvGrpSpPr>
-      <p:grpSpPr>
-        <a:xfrm>
-          <a:off x="0" y="0"/>
-          <a:ext cx="0" cy="0"/>
-          <a:chOff x="0" y="0"/>
-          <a:chExt cx="0" cy="0"/>
-        </a:xfrm>
-      </p:grpSpPr>
-      <p:sp>
-        <p:nvSpPr>
-          <p:cNvPr id="2" name="Title 1">
-            <a:extLst>
-              <a:ext uri="{FF2B5EF4-FFF2-40B4-BE49-F238E27FC236}">
-                <a16:creationId xmlns:a16="http://schemas.microsoft.com/office/drawing/2014/main" id="{0EFEE410-8E10-79A0-1A5C-1B595AC406D0}"/>
-              </a:ext>
-            </a:extLst>
-          </p:cNvPr>
-          <p:cNvSpPr>
-            <a:spLocks noGrp="1"/>
-          </p:cNvSpPr>
-          <p:nvPr>
-            <p:ph type="title"/>
-          </p:nvPr>
-        </p:nvSpPr>
-        <p:spPr/>
-        <p:txBody>
-          <a:bodyPr/>
-          <a:lstStyle/>
-          <a:p>
-            <a:r>
-              <a:rPr lang="en-US"/>
-              <a:t>Click to edit Master title style</a:t>
-            </a:r>
-            <a:endParaRPr lang="en-GB"/>
-          </a:p>
-        </p:txBody>
-      </p:sp>
-      <p:sp>
-        <p:nvSpPr>
-          <p:cNvPr id="3" name="Content Placeholder 2">
-            <a:extLst>
-              <a:ext uri="{FF2B5EF4-FFF2-40B4-BE49-F238E27FC236}">
-                <a16:creationId xmlns:a16="http://schemas.microsoft.com/office/drawing/2014/main" id="{276E10EB-CC55-264F-E8B9-67B3EDFB3B84}"/>
-              </a:ext>
-            </a:extLst>
-          </p:cNvPr>
-          <p:cNvSpPr>
-            <a:spLocks noGrp="1"/>
-          </p:cNvSpPr>
-          <p:nvPr>
-            <p:ph idx="1"/>
-          </p:nvPr>
-        </p:nvSpPr>
-        <p:spPr/>
-        <p:txBody>
-          <a:bodyPr/>
-          <a:lstStyle/>
-          <a:p>
-            <a:pPr lvl="0"/>
-            <a:r>
-              <a:rPr lang="en-US"/>
-              <a:t>Click to edit Master text styles</a:t>
-            </a:r>
-          </a:p>
-          <a:p>
-            <a:pPr lvl="1"/>
-            <a:r>
-              <a:rPr lang="en-US"/>
-              <a:t>Second level</a:t>
-            </a:r>
-          </a:p>
-          <a:p>
-            <a:pPr lvl="2"/>
-            <a:r>
-              <a:rPr lang="en-US"/>
-              <a:t>Third level</a:t>
-            </a:r>
-          </a:p>
-          <a:p>
-            <a:pPr lvl="3"/>
-            <a:r>
-              <a:rPr lang="en-US"/>
-              <a:t>Fourth level</a:t>
-            </a:r>
-          </a:p>
-          <a:p>
-            <a:pPr lvl="4"/>
-            <a:r>
-              <a:rPr lang="en-US"/>
-              <a:t>Fifth level</a:t>
-            </a:r>
-            <a:endParaRPr lang="en-GB"/>
-          </a:p>
-        </p:txBody>
-      </p:sp>
-      <p:sp>
-        <p:nvSpPr>
-          <p:cNvPr id="4" name="Date Placeholder 3">
-            <a:extLst>
-              <a:ext uri="{FF2B5EF4-FFF2-40B4-BE49-F238E27FC236}">
-                <a16:creationId xmlns:a16="http://schemas.microsoft.com/office/drawing/2014/main" id="{42283E2C-D2DF-1769-53AD-C4EF521B7991}"/>
-              </a:ext>
-            </a:extLst>
-          </p:cNvPr>
-          <p:cNvSpPr>
-            <a:spLocks noGrp="1"/>
-          </p:cNvSpPr>
-          <p:nvPr>
-            <p:ph type="dt" sz="half" idx="10"/>
-          </p:nvPr>
-        </p:nvSpPr>
-        <p:spPr/>
-        <p:txBody>
-          <a:bodyPr/>
-          <a:lstStyle/>
-          <a:p>
-            <a:fld id="{36250D35-438B-41E9-BDE2-B658D3957A6D}" type="datetimeFigureOut">
-              <a:rPr lang="en-GB" smtClean="0"/>
-              <a:t>12/09/2025</a:t>
-            </a:fld>
-            <a:endParaRPr lang="en-GB"/>
-          </a:p>
-        </p:txBody>
-      </p:sp>
-      <p:sp>
-        <p:nvSpPr>
-          <p:cNvPr id="5" name="Footer Placeholder 4">
-            <a:extLst>
-              <a:ext uri="{FF2B5EF4-FFF2-40B4-BE49-F238E27FC236}">
-                <a16:creationId xmlns:a16="http://schemas.microsoft.com/office/drawing/2014/main" id="{ACF83EB9-AAC5-0584-68B7-A4A940736385}"/>
-              </a:ext>
-            </a:extLst>
-          </p:cNvPr>
-          <p:cNvSpPr>
-            <a:spLocks noGrp="1"/>
-          </p:cNvSpPr>
-          <p:nvPr>
-            <p:ph type="ftr" sz="quarter" idx="11"/>
-          </p:nvPr>
-        </p:nvSpPr>
-        <p:spPr/>
-        <p:txBody>
-          <a:bodyPr/>
-          <a:lstStyle/>
-          <a:p>
-            <a:endParaRPr lang="en-GB"/>
-          </a:p>
-        </p:txBody>
-      </p:sp>
-      <p:sp>
-        <p:nvSpPr>
-          <p:cNvPr id="6" name="Slide Number Placeholder 5">
-            <a:extLst>
-              <a:ext uri="{FF2B5EF4-FFF2-40B4-BE49-F238E27FC236}">
-                <a16:creationId xmlns:a16="http://schemas.microsoft.com/office/drawing/2014/main" id="{1B6B3742-E904-FED3-76E8-73B7B613324C}"/>
-              </a:ext>
-            </a:extLst>
-          </p:cNvPr>
-          <p:cNvSpPr>
-            <a:spLocks noGrp="1"/>
-          </p:cNvSpPr>
-          <p:nvPr>
-            <p:ph type="sldNum" sz="quarter" idx="12"/>
-          </p:nvPr>
-        </p:nvSpPr>
-        <p:spPr/>
-        <p:txBody>
-          <a:bodyPr/>
-          <a:lstStyle/>
-          <a:p>
-            <a:fld id="{882737FA-DC85-4AD9-8658-285F461F85AF}" type="slidenum">
-              <a:rPr lang="en-GB" smtClean="0"/>
-              <a:t>‹#›</a:t>
-            </a:fld>
-            <a:endParaRPr lang="en-GB"/>
-          </a:p>
-        </p:txBody>
-      </p:sp>
-    </p:spTree>
-    <p:extLst>
-      <p:ext uri="{BB962C8B-B14F-4D97-AF65-F5344CB8AC3E}">
-        <p14:creationId xmlns:p14="http://schemas.microsoft.com/office/powerpoint/2010/main" val="1758430260"/>
       </p:ext>
     </p:extLst>
   </p:cSld>
@@ -5626,7 +5198,7 @@
           <a:p>
             <a:fld id="{DF89F9ED-2410-4CD1-B5CD-D275AA293E22}" type="datetimeFigureOut">
               <a:rPr lang="LID4096" smtClean="0"/>
-              <a:t>09/12/2025</a:t>
+              <a:t>04/20/2026</a:t>
             </a:fld>
             <a:endParaRPr lang="LID4096"/>
           </a:p>
@@ -5690,2232 +5262,6 @@
     <p:extLst>
       <p:ext uri="{BB962C8B-B14F-4D97-AF65-F5344CB8AC3E}">
         <p14:creationId xmlns:p14="http://schemas.microsoft.com/office/powerpoint/2010/main" val="3818306204"/>
-      </p:ext>
-    </p:extLst>
-  </p:cSld>
-  <p:clrMapOvr>
-    <a:masterClrMapping/>
-  </p:clrMapOvr>
-</p:sldLayout>
-</file>
-
-<file path=ppt/slideLayouts/slideLayout30.xml><?xml version="1.0" encoding="utf-8"?>
-<p:sldLayout xmlns:a="http://schemas.openxmlformats.org/drawingml/2006/main" xmlns:r="http://schemas.openxmlformats.org/officeDocument/2006/relationships" xmlns:p="http://schemas.openxmlformats.org/presentationml/2006/main" type="secHead" preserve="1">
-  <p:cSld name="Section Header">
-    <p:spTree>
-      <p:nvGrpSpPr>
-        <p:cNvPr id="1" name=""/>
-        <p:cNvGrpSpPr/>
-        <p:nvPr/>
-      </p:nvGrpSpPr>
-      <p:grpSpPr>
-        <a:xfrm>
-          <a:off x="0" y="0"/>
-          <a:ext cx="0" cy="0"/>
-          <a:chOff x="0" y="0"/>
-          <a:chExt cx="0" cy="0"/>
-        </a:xfrm>
-      </p:grpSpPr>
-      <p:sp>
-        <p:nvSpPr>
-          <p:cNvPr id="2" name="Title 1">
-            <a:extLst>
-              <a:ext uri="{FF2B5EF4-FFF2-40B4-BE49-F238E27FC236}">
-                <a16:creationId xmlns:a16="http://schemas.microsoft.com/office/drawing/2014/main" id="{4FFF13C3-7AA8-4B09-15FF-04EE268C3CCB}"/>
-              </a:ext>
-            </a:extLst>
-          </p:cNvPr>
-          <p:cNvSpPr>
-            <a:spLocks noGrp="1"/>
-          </p:cNvSpPr>
-          <p:nvPr>
-            <p:ph type="title"/>
-          </p:nvPr>
-        </p:nvSpPr>
-        <p:spPr>
-          <a:xfrm>
-            <a:off x="831850" y="1709738"/>
-            <a:ext cx="10515600" cy="2852737"/>
-          </a:xfrm>
-        </p:spPr>
-        <p:txBody>
-          <a:bodyPr anchor="b"/>
-          <a:lstStyle>
-            <a:lvl1pPr>
-              <a:defRPr sz="6000"/>
-            </a:lvl1pPr>
-          </a:lstStyle>
-          <a:p>
-            <a:r>
-              <a:rPr lang="en-US"/>
-              <a:t>Click to edit Master title style</a:t>
-            </a:r>
-            <a:endParaRPr lang="en-GB"/>
-          </a:p>
-        </p:txBody>
-      </p:sp>
-      <p:sp>
-        <p:nvSpPr>
-          <p:cNvPr id="3" name="Text Placeholder 2">
-            <a:extLst>
-              <a:ext uri="{FF2B5EF4-FFF2-40B4-BE49-F238E27FC236}">
-                <a16:creationId xmlns:a16="http://schemas.microsoft.com/office/drawing/2014/main" id="{960DAD77-79F1-97C5-CF64-97C5A39F405E}"/>
-              </a:ext>
-            </a:extLst>
-          </p:cNvPr>
-          <p:cNvSpPr>
-            <a:spLocks noGrp="1"/>
-          </p:cNvSpPr>
-          <p:nvPr>
-            <p:ph type="body" idx="1"/>
-          </p:nvPr>
-        </p:nvSpPr>
-        <p:spPr>
-          <a:xfrm>
-            <a:off x="831850" y="4589463"/>
-            <a:ext cx="10515600" cy="1500187"/>
-          </a:xfrm>
-        </p:spPr>
-        <p:txBody>
-          <a:bodyPr/>
-          <a:lstStyle>
-            <a:lvl1pPr marL="0" indent="0">
-              <a:buNone/>
-              <a:defRPr sz="2400">
-                <a:solidFill>
-                  <a:schemeClr val="tx1">
-                    <a:tint val="82000"/>
-                  </a:schemeClr>
-                </a:solidFill>
-              </a:defRPr>
-            </a:lvl1pPr>
-            <a:lvl2pPr marL="457200" indent="0">
-              <a:buNone/>
-              <a:defRPr sz="2000">
-                <a:solidFill>
-                  <a:schemeClr val="tx1">
-                    <a:tint val="82000"/>
-                  </a:schemeClr>
-                </a:solidFill>
-              </a:defRPr>
-            </a:lvl2pPr>
-            <a:lvl3pPr marL="914400" indent="0">
-              <a:buNone/>
-              <a:defRPr sz="1800">
-                <a:solidFill>
-                  <a:schemeClr val="tx1">
-                    <a:tint val="82000"/>
-                  </a:schemeClr>
-                </a:solidFill>
-              </a:defRPr>
-            </a:lvl3pPr>
-            <a:lvl4pPr marL="1371600" indent="0">
-              <a:buNone/>
-              <a:defRPr sz="1600">
-                <a:solidFill>
-                  <a:schemeClr val="tx1">
-                    <a:tint val="82000"/>
-                  </a:schemeClr>
-                </a:solidFill>
-              </a:defRPr>
-            </a:lvl4pPr>
-            <a:lvl5pPr marL="1828800" indent="0">
-              <a:buNone/>
-              <a:defRPr sz="1600">
-                <a:solidFill>
-                  <a:schemeClr val="tx1">
-                    <a:tint val="82000"/>
-                  </a:schemeClr>
-                </a:solidFill>
-              </a:defRPr>
-            </a:lvl5pPr>
-            <a:lvl6pPr marL="2286000" indent="0">
-              <a:buNone/>
-              <a:defRPr sz="1600">
-                <a:solidFill>
-                  <a:schemeClr val="tx1">
-                    <a:tint val="82000"/>
-                  </a:schemeClr>
-                </a:solidFill>
-              </a:defRPr>
-            </a:lvl6pPr>
-            <a:lvl7pPr marL="2743200" indent="0">
-              <a:buNone/>
-              <a:defRPr sz="1600">
-                <a:solidFill>
-                  <a:schemeClr val="tx1">
-                    <a:tint val="82000"/>
-                  </a:schemeClr>
-                </a:solidFill>
-              </a:defRPr>
-            </a:lvl7pPr>
-            <a:lvl8pPr marL="3200400" indent="0">
-              <a:buNone/>
-              <a:defRPr sz="1600">
-                <a:solidFill>
-                  <a:schemeClr val="tx1">
-                    <a:tint val="82000"/>
-                  </a:schemeClr>
-                </a:solidFill>
-              </a:defRPr>
-            </a:lvl8pPr>
-            <a:lvl9pPr marL="3657600" indent="0">
-              <a:buNone/>
-              <a:defRPr sz="1600">
-                <a:solidFill>
-                  <a:schemeClr val="tx1">
-                    <a:tint val="82000"/>
-                  </a:schemeClr>
-                </a:solidFill>
-              </a:defRPr>
-            </a:lvl9pPr>
-          </a:lstStyle>
-          <a:p>
-            <a:pPr lvl="0"/>
-            <a:r>
-              <a:rPr lang="en-US"/>
-              <a:t>Click to edit Master text styles</a:t>
-            </a:r>
-          </a:p>
-        </p:txBody>
-      </p:sp>
-      <p:sp>
-        <p:nvSpPr>
-          <p:cNvPr id="4" name="Date Placeholder 3">
-            <a:extLst>
-              <a:ext uri="{FF2B5EF4-FFF2-40B4-BE49-F238E27FC236}">
-                <a16:creationId xmlns:a16="http://schemas.microsoft.com/office/drawing/2014/main" id="{77F1AC3C-BA9F-41D7-BB6F-D7FBC95B95C6}"/>
-              </a:ext>
-            </a:extLst>
-          </p:cNvPr>
-          <p:cNvSpPr>
-            <a:spLocks noGrp="1"/>
-          </p:cNvSpPr>
-          <p:nvPr>
-            <p:ph type="dt" sz="half" idx="10"/>
-          </p:nvPr>
-        </p:nvSpPr>
-        <p:spPr/>
-        <p:txBody>
-          <a:bodyPr/>
-          <a:lstStyle/>
-          <a:p>
-            <a:fld id="{36250D35-438B-41E9-BDE2-B658D3957A6D}" type="datetimeFigureOut">
-              <a:rPr lang="en-GB" smtClean="0"/>
-              <a:t>12/09/2025</a:t>
-            </a:fld>
-            <a:endParaRPr lang="en-GB"/>
-          </a:p>
-        </p:txBody>
-      </p:sp>
-      <p:sp>
-        <p:nvSpPr>
-          <p:cNvPr id="5" name="Footer Placeholder 4">
-            <a:extLst>
-              <a:ext uri="{FF2B5EF4-FFF2-40B4-BE49-F238E27FC236}">
-                <a16:creationId xmlns:a16="http://schemas.microsoft.com/office/drawing/2014/main" id="{BF938CDF-2A18-007D-C7A5-29F9E62C2A84}"/>
-              </a:ext>
-            </a:extLst>
-          </p:cNvPr>
-          <p:cNvSpPr>
-            <a:spLocks noGrp="1"/>
-          </p:cNvSpPr>
-          <p:nvPr>
-            <p:ph type="ftr" sz="quarter" idx="11"/>
-          </p:nvPr>
-        </p:nvSpPr>
-        <p:spPr/>
-        <p:txBody>
-          <a:bodyPr/>
-          <a:lstStyle/>
-          <a:p>
-            <a:endParaRPr lang="en-GB"/>
-          </a:p>
-        </p:txBody>
-      </p:sp>
-      <p:sp>
-        <p:nvSpPr>
-          <p:cNvPr id="6" name="Slide Number Placeholder 5">
-            <a:extLst>
-              <a:ext uri="{FF2B5EF4-FFF2-40B4-BE49-F238E27FC236}">
-                <a16:creationId xmlns:a16="http://schemas.microsoft.com/office/drawing/2014/main" id="{99ED7D41-7306-C857-CE9A-55F56842DFBC}"/>
-              </a:ext>
-            </a:extLst>
-          </p:cNvPr>
-          <p:cNvSpPr>
-            <a:spLocks noGrp="1"/>
-          </p:cNvSpPr>
-          <p:nvPr>
-            <p:ph type="sldNum" sz="quarter" idx="12"/>
-          </p:nvPr>
-        </p:nvSpPr>
-        <p:spPr/>
-        <p:txBody>
-          <a:bodyPr/>
-          <a:lstStyle/>
-          <a:p>
-            <a:fld id="{882737FA-DC85-4AD9-8658-285F461F85AF}" type="slidenum">
-              <a:rPr lang="en-GB" smtClean="0"/>
-              <a:t>‹#›</a:t>
-            </a:fld>
-            <a:endParaRPr lang="en-GB"/>
-          </a:p>
-        </p:txBody>
-      </p:sp>
-    </p:spTree>
-    <p:extLst>
-      <p:ext uri="{BB962C8B-B14F-4D97-AF65-F5344CB8AC3E}">
-        <p14:creationId xmlns:p14="http://schemas.microsoft.com/office/powerpoint/2010/main" val="2705467632"/>
-      </p:ext>
-    </p:extLst>
-  </p:cSld>
-  <p:clrMapOvr>
-    <a:masterClrMapping/>
-  </p:clrMapOvr>
-</p:sldLayout>
-</file>
-
-<file path=ppt/slideLayouts/slideLayout31.xml><?xml version="1.0" encoding="utf-8"?>
-<p:sldLayout xmlns:a="http://schemas.openxmlformats.org/drawingml/2006/main" xmlns:r="http://schemas.openxmlformats.org/officeDocument/2006/relationships" xmlns:p="http://schemas.openxmlformats.org/presentationml/2006/main" type="twoObj" preserve="1">
-  <p:cSld name="Two Content">
-    <p:spTree>
-      <p:nvGrpSpPr>
-        <p:cNvPr id="1" name=""/>
-        <p:cNvGrpSpPr/>
-        <p:nvPr/>
-      </p:nvGrpSpPr>
-      <p:grpSpPr>
-        <a:xfrm>
-          <a:off x="0" y="0"/>
-          <a:ext cx="0" cy="0"/>
-          <a:chOff x="0" y="0"/>
-          <a:chExt cx="0" cy="0"/>
-        </a:xfrm>
-      </p:grpSpPr>
-      <p:sp>
-        <p:nvSpPr>
-          <p:cNvPr id="2" name="Title 1">
-            <a:extLst>
-              <a:ext uri="{FF2B5EF4-FFF2-40B4-BE49-F238E27FC236}">
-                <a16:creationId xmlns:a16="http://schemas.microsoft.com/office/drawing/2014/main" id="{AAD2D143-45DD-7A5C-5541-BCC482E0AD02}"/>
-              </a:ext>
-            </a:extLst>
-          </p:cNvPr>
-          <p:cNvSpPr>
-            <a:spLocks noGrp="1"/>
-          </p:cNvSpPr>
-          <p:nvPr>
-            <p:ph type="title"/>
-          </p:nvPr>
-        </p:nvSpPr>
-        <p:spPr/>
-        <p:txBody>
-          <a:bodyPr/>
-          <a:lstStyle/>
-          <a:p>
-            <a:r>
-              <a:rPr lang="en-US"/>
-              <a:t>Click to edit Master title style</a:t>
-            </a:r>
-            <a:endParaRPr lang="en-GB"/>
-          </a:p>
-        </p:txBody>
-      </p:sp>
-      <p:sp>
-        <p:nvSpPr>
-          <p:cNvPr id="3" name="Content Placeholder 2">
-            <a:extLst>
-              <a:ext uri="{FF2B5EF4-FFF2-40B4-BE49-F238E27FC236}">
-                <a16:creationId xmlns:a16="http://schemas.microsoft.com/office/drawing/2014/main" id="{0B7F6DAB-44FF-8F4F-626A-31B3E097AEB2}"/>
-              </a:ext>
-            </a:extLst>
-          </p:cNvPr>
-          <p:cNvSpPr>
-            <a:spLocks noGrp="1"/>
-          </p:cNvSpPr>
-          <p:nvPr>
-            <p:ph sz="half" idx="1"/>
-          </p:nvPr>
-        </p:nvSpPr>
-        <p:spPr>
-          <a:xfrm>
-            <a:off x="838200" y="1825625"/>
-            <a:ext cx="5181600" cy="4351338"/>
-          </a:xfrm>
-        </p:spPr>
-        <p:txBody>
-          <a:bodyPr/>
-          <a:lstStyle/>
-          <a:p>
-            <a:pPr lvl="0"/>
-            <a:r>
-              <a:rPr lang="en-US"/>
-              <a:t>Click to edit Master text styles</a:t>
-            </a:r>
-          </a:p>
-          <a:p>
-            <a:pPr lvl="1"/>
-            <a:r>
-              <a:rPr lang="en-US"/>
-              <a:t>Second level</a:t>
-            </a:r>
-          </a:p>
-          <a:p>
-            <a:pPr lvl="2"/>
-            <a:r>
-              <a:rPr lang="en-US"/>
-              <a:t>Third level</a:t>
-            </a:r>
-          </a:p>
-          <a:p>
-            <a:pPr lvl="3"/>
-            <a:r>
-              <a:rPr lang="en-US"/>
-              <a:t>Fourth level</a:t>
-            </a:r>
-          </a:p>
-          <a:p>
-            <a:pPr lvl="4"/>
-            <a:r>
-              <a:rPr lang="en-US"/>
-              <a:t>Fifth level</a:t>
-            </a:r>
-            <a:endParaRPr lang="en-GB"/>
-          </a:p>
-        </p:txBody>
-      </p:sp>
-      <p:sp>
-        <p:nvSpPr>
-          <p:cNvPr id="4" name="Content Placeholder 3">
-            <a:extLst>
-              <a:ext uri="{FF2B5EF4-FFF2-40B4-BE49-F238E27FC236}">
-                <a16:creationId xmlns:a16="http://schemas.microsoft.com/office/drawing/2014/main" id="{E810D5AB-A64F-0E6E-A66B-9A49256C2F2B}"/>
-              </a:ext>
-            </a:extLst>
-          </p:cNvPr>
-          <p:cNvSpPr>
-            <a:spLocks noGrp="1"/>
-          </p:cNvSpPr>
-          <p:nvPr>
-            <p:ph sz="half" idx="2"/>
-          </p:nvPr>
-        </p:nvSpPr>
-        <p:spPr>
-          <a:xfrm>
-            <a:off x="6172200" y="1825625"/>
-            <a:ext cx="5181600" cy="4351338"/>
-          </a:xfrm>
-        </p:spPr>
-        <p:txBody>
-          <a:bodyPr/>
-          <a:lstStyle/>
-          <a:p>
-            <a:pPr lvl="0"/>
-            <a:r>
-              <a:rPr lang="en-US"/>
-              <a:t>Click to edit Master text styles</a:t>
-            </a:r>
-          </a:p>
-          <a:p>
-            <a:pPr lvl="1"/>
-            <a:r>
-              <a:rPr lang="en-US"/>
-              <a:t>Second level</a:t>
-            </a:r>
-          </a:p>
-          <a:p>
-            <a:pPr lvl="2"/>
-            <a:r>
-              <a:rPr lang="en-US"/>
-              <a:t>Third level</a:t>
-            </a:r>
-          </a:p>
-          <a:p>
-            <a:pPr lvl="3"/>
-            <a:r>
-              <a:rPr lang="en-US"/>
-              <a:t>Fourth level</a:t>
-            </a:r>
-          </a:p>
-          <a:p>
-            <a:pPr lvl="4"/>
-            <a:r>
-              <a:rPr lang="en-US"/>
-              <a:t>Fifth level</a:t>
-            </a:r>
-            <a:endParaRPr lang="en-GB"/>
-          </a:p>
-        </p:txBody>
-      </p:sp>
-      <p:sp>
-        <p:nvSpPr>
-          <p:cNvPr id="5" name="Date Placeholder 4">
-            <a:extLst>
-              <a:ext uri="{FF2B5EF4-FFF2-40B4-BE49-F238E27FC236}">
-                <a16:creationId xmlns:a16="http://schemas.microsoft.com/office/drawing/2014/main" id="{BA8F4756-6A0F-1824-22E6-A32C5ED46A77}"/>
-              </a:ext>
-            </a:extLst>
-          </p:cNvPr>
-          <p:cNvSpPr>
-            <a:spLocks noGrp="1"/>
-          </p:cNvSpPr>
-          <p:nvPr>
-            <p:ph type="dt" sz="half" idx="10"/>
-          </p:nvPr>
-        </p:nvSpPr>
-        <p:spPr/>
-        <p:txBody>
-          <a:bodyPr/>
-          <a:lstStyle/>
-          <a:p>
-            <a:fld id="{36250D35-438B-41E9-BDE2-B658D3957A6D}" type="datetimeFigureOut">
-              <a:rPr lang="en-GB" smtClean="0"/>
-              <a:t>12/09/2025</a:t>
-            </a:fld>
-            <a:endParaRPr lang="en-GB"/>
-          </a:p>
-        </p:txBody>
-      </p:sp>
-      <p:sp>
-        <p:nvSpPr>
-          <p:cNvPr id="6" name="Footer Placeholder 5">
-            <a:extLst>
-              <a:ext uri="{FF2B5EF4-FFF2-40B4-BE49-F238E27FC236}">
-                <a16:creationId xmlns:a16="http://schemas.microsoft.com/office/drawing/2014/main" id="{665A92E4-3D45-1ED8-3C67-C0B21148ED70}"/>
-              </a:ext>
-            </a:extLst>
-          </p:cNvPr>
-          <p:cNvSpPr>
-            <a:spLocks noGrp="1"/>
-          </p:cNvSpPr>
-          <p:nvPr>
-            <p:ph type="ftr" sz="quarter" idx="11"/>
-          </p:nvPr>
-        </p:nvSpPr>
-        <p:spPr/>
-        <p:txBody>
-          <a:bodyPr/>
-          <a:lstStyle/>
-          <a:p>
-            <a:endParaRPr lang="en-GB"/>
-          </a:p>
-        </p:txBody>
-      </p:sp>
-      <p:sp>
-        <p:nvSpPr>
-          <p:cNvPr id="7" name="Slide Number Placeholder 6">
-            <a:extLst>
-              <a:ext uri="{FF2B5EF4-FFF2-40B4-BE49-F238E27FC236}">
-                <a16:creationId xmlns:a16="http://schemas.microsoft.com/office/drawing/2014/main" id="{C1EF451C-C81A-606A-F0C5-8B336C8F278A}"/>
-              </a:ext>
-            </a:extLst>
-          </p:cNvPr>
-          <p:cNvSpPr>
-            <a:spLocks noGrp="1"/>
-          </p:cNvSpPr>
-          <p:nvPr>
-            <p:ph type="sldNum" sz="quarter" idx="12"/>
-          </p:nvPr>
-        </p:nvSpPr>
-        <p:spPr/>
-        <p:txBody>
-          <a:bodyPr/>
-          <a:lstStyle/>
-          <a:p>
-            <a:fld id="{882737FA-DC85-4AD9-8658-285F461F85AF}" type="slidenum">
-              <a:rPr lang="en-GB" smtClean="0"/>
-              <a:t>‹#›</a:t>
-            </a:fld>
-            <a:endParaRPr lang="en-GB"/>
-          </a:p>
-        </p:txBody>
-      </p:sp>
-    </p:spTree>
-    <p:extLst>
-      <p:ext uri="{BB962C8B-B14F-4D97-AF65-F5344CB8AC3E}">
-        <p14:creationId xmlns:p14="http://schemas.microsoft.com/office/powerpoint/2010/main" val="2841892203"/>
-      </p:ext>
-    </p:extLst>
-  </p:cSld>
-  <p:clrMapOvr>
-    <a:masterClrMapping/>
-  </p:clrMapOvr>
-</p:sldLayout>
-</file>
-
-<file path=ppt/slideLayouts/slideLayout32.xml><?xml version="1.0" encoding="utf-8"?>
-<p:sldLayout xmlns:a="http://schemas.openxmlformats.org/drawingml/2006/main" xmlns:r="http://schemas.openxmlformats.org/officeDocument/2006/relationships" xmlns:p="http://schemas.openxmlformats.org/presentationml/2006/main" type="twoTxTwoObj" preserve="1">
-  <p:cSld name="Comparison">
-    <p:spTree>
-      <p:nvGrpSpPr>
-        <p:cNvPr id="1" name=""/>
-        <p:cNvGrpSpPr/>
-        <p:nvPr/>
-      </p:nvGrpSpPr>
-      <p:grpSpPr>
-        <a:xfrm>
-          <a:off x="0" y="0"/>
-          <a:ext cx="0" cy="0"/>
-          <a:chOff x="0" y="0"/>
-          <a:chExt cx="0" cy="0"/>
-        </a:xfrm>
-      </p:grpSpPr>
-      <p:sp>
-        <p:nvSpPr>
-          <p:cNvPr id="2" name="Title 1">
-            <a:extLst>
-              <a:ext uri="{FF2B5EF4-FFF2-40B4-BE49-F238E27FC236}">
-                <a16:creationId xmlns:a16="http://schemas.microsoft.com/office/drawing/2014/main" id="{E4358E3B-0981-9900-D668-B34BC1998044}"/>
-              </a:ext>
-            </a:extLst>
-          </p:cNvPr>
-          <p:cNvSpPr>
-            <a:spLocks noGrp="1"/>
-          </p:cNvSpPr>
-          <p:nvPr>
-            <p:ph type="title"/>
-          </p:nvPr>
-        </p:nvSpPr>
-        <p:spPr>
-          <a:xfrm>
-            <a:off x="839788" y="365125"/>
-            <a:ext cx="10515600" cy="1325563"/>
-          </a:xfrm>
-        </p:spPr>
-        <p:txBody>
-          <a:bodyPr/>
-          <a:lstStyle/>
-          <a:p>
-            <a:r>
-              <a:rPr lang="en-US"/>
-              <a:t>Click to edit Master title style</a:t>
-            </a:r>
-            <a:endParaRPr lang="en-GB"/>
-          </a:p>
-        </p:txBody>
-      </p:sp>
-      <p:sp>
-        <p:nvSpPr>
-          <p:cNvPr id="3" name="Text Placeholder 2">
-            <a:extLst>
-              <a:ext uri="{FF2B5EF4-FFF2-40B4-BE49-F238E27FC236}">
-                <a16:creationId xmlns:a16="http://schemas.microsoft.com/office/drawing/2014/main" id="{2BE9BE5F-75EF-3217-DDC3-4ED492131FD5}"/>
-              </a:ext>
-            </a:extLst>
-          </p:cNvPr>
-          <p:cNvSpPr>
-            <a:spLocks noGrp="1"/>
-          </p:cNvSpPr>
-          <p:nvPr>
-            <p:ph type="body" idx="1"/>
-          </p:nvPr>
-        </p:nvSpPr>
-        <p:spPr>
-          <a:xfrm>
-            <a:off x="839788" y="1681163"/>
-            <a:ext cx="5157787" cy="823912"/>
-          </a:xfrm>
-        </p:spPr>
-        <p:txBody>
-          <a:bodyPr anchor="b"/>
-          <a:lstStyle>
-            <a:lvl1pPr marL="0" indent="0">
-              <a:buNone/>
-              <a:defRPr sz="2400" b="1"/>
-            </a:lvl1pPr>
-            <a:lvl2pPr marL="457200" indent="0">
-              <a:buNone/>
-              <a:defRPr sz="2000" b="1"/>
-            </a:lvl2pPr>
-            <a:lvl3pPr marL="914400" indent="0">
-              <a:buNone/>
-              <a:defRPr sz="1800" b="1"/>
-            </a:lvl3pPr>
-            <a:lvl4pPr marL="1371600" indent="0">
-              <a:buNone/>
-              <a:defRPr sz="1600" b="1"/>
-            </a:lvl4pPr>
-            <a:lvl5pPr marL="1828800" indent="0">
-              <a:buNone/>
-              <a:defRPr sz="1600" b="1"/>
-            </a:lvl5pPr>
-            <a:lvl6pPr marL="2286000" indent="0">
-              <a:buNone/>
-              <a:defRPr sz="1600" b="1"/>
-            </a:lvl6pPr>
-            <a:lvl7pPr marL="2743200" indent="0">
-              <a:buNone/>
-              <a:defRPr sz="1600" b="1"/>
-            </a:lvl7pPr>
-            <a:lvl8pPr marL="3200400" indent="0">
-              <a:buNone/>
-              <a:defRPr sz="1600" b="1"/>
-            </a:lvl8pPr>
-            <a:lvl9pPr marL="3657600" indent="0">
-              <a:buNone/>
-              <a:defRPr sz="1600" b="1"/>
-            </a:lvl9pPr>
-          </a:lstStyle>
-          <a:p>
-            <a:pPr lvl="0"/>
-            <a:r>
-              <a:rPr lang="en-US"/>
-              <a:t>Click to edit Master text styles</a:t>
-            </a:r>
-          </a:p>
-        </p:txBody>
-      </p:sp>
-      <p:sp>
-        <p:nvSpPr>
-          <p:cNvPr id="4" name="Content Placeholder 3">
-            <a:extLst>
-              <a:ext uri="{FF2B5EF4-FFF2-40B4-BE49-F238E27FC236}">
-                <a16:creationId xmlns:a16="http://schemas.microsoft.com/office/drawing/2014/main" id="{5751EC0A-53FD-B65C-6569-1C5B9B3FCCA8}"/>
-              </a:ext>
-            </a:extLst>
-          </p:cNvPr>
-          <p:cNvSpPr>
-            <a:spLocks noGrp="1"/>
-          </p:cNvSpPr>
-          <p:nvPr>
-            <p:ph sz="half" idx="2"/>
-          </p:nvPr>
-        </p:nvSpPr>
-        <p:spPr>
-          <a:xfrm>
-            <a:off x="839788" y="2505075"/>
-            <a:ext cx="5157787" cy="3684588"/>
-          </a:xfrm>
-        </p:spPr>
-        <p:txBody>
-          <a:bodyPr/>
-          <a:lstStyle/>
-          <a:p>
-            <a:pPr lvl="0"/>
-            <a:r>
-              <a:rPr lang="en-US"/>
-              <a:t>Click to edit Master text styles</a:t>
-            </a:r>
-          </a:p>
-          <a:p>
-            <a:pPr lvl="1"/>
-            <a:r>
-              <a:rPr lang="en-US"/>
-              <a:t>Second level</a:t>
-            </a:r>
-          </a:p>
-          <a:p>
-            <a:pPr lvl="2"/>
-            <a:r>
-              <a:rPr lang="en-US"/>
-              <a:t>Third level</a:t>
-            </a:r>
-          </a:p>
-          <a:p>
-            <a:pPr lvl="3"/>
-            <a:r>
-              <a:rPr lang="en-US"/>
-              <a:t>Fourth level</a:t>
-            </a:r>
-          </a:p>
-          <a:p>
-            <a:pPr lvl="4"/>
-            <a:r>
-              <a:rPr lang="en-US"/>
-              <a:t>Fifth level</a:t>
-            </a:r>
-            <a:endParaRPr lang="en-GB"/>
-          </a:p>
-        </p:txBody>
-      </p:sp>
-      <p:sp>
-        <p:nvSpPr>
-          <p:cNvPr id="5" name="Text Placeholder 4">
-            <a:extLst>
-              <a:ext uri="{FF2B5EF4-FFF2-40B4-BE49-F238E27FC236}">
-                <a16:creationId xmlns:a16="http://schemas.microsoft.com/office/drawing/2014/main" id="{609C7C81-906B-1C27-041A-1EE5EED0F685}"/>
-              </a:ext>
-            </a:extLst>
-          </p:cNvPr>
-          <p:cNvSpPr>
-            <a:spLocks noGrp="1"/>
-          </p:cNvSpPr>
-          <p:nvPr>
-            <p:ph type="body" sz="quarter" idx="3"/>
-          </p:nvPr>
-        </p:nvSpPr>
-        <p:spPr>
-          <a:xfrm>
-            <a:off x="6172200" y="1681163"/>
-            <a:ext cx="5183188" cy="823912"/>
-          </a:xfrm>
-        </p:spPr>
-        <p:txBody>
-          <a:bodyPr anchor="b"/>
-          <a:lstStyle>
-            <a:lvl1pPr marL="0" indent="0">
-              <a:buNone/>
-              <a:defRPr sz="2400" b="1"/>
-            </a:lvl1pPr>
-            <a:lvl2pPr marL="457200" indent="0">
-              <a:buNone/>
-              <a:defRPr sz="2000" b="1"/>
-            </a:lvl2pPr>
-            <a:lvl3pPr marL="914400" indent="0">
-              <a:buNone/>
-              <a:defRPr sz="1800" b="1"/>
-            </a:lvl3pPr>
-            <a:lvl4pPr marL="1371600" indent="0">
-              <a:buNone/>
-              <a:defRPr sz="1600" b="1"/>
-            </a:lvl4pPr>
-            <a:lvl5pPr marL="1828800" indent="0">
-              <a:buNone/>
-              <a:defRPr sz="1600" b="1"/>
-            </a:lvl5pPr>
-            <a:lvl6pPr marL="2286000" indent="0">
-              <a:buNone/>
-              <a:defRPr sz="1600" b="1"/>
-            </a:lvl6pPr>
-            <a:lvl7pPr marL="2743200" indent="0">
-              <a:buNone/>
-              <a:defRPr sz="1600" b="1"/>
-            </a:lvl7pPr>
-            <a:lvl8pPr marL="3200400" indent="0">
-              <a:buNone/>
-              <a:defRPr sz="1600" b="1"/>
-            </a:lvl8pPr>
-            <a:lvl9pPr marL="3657600" indent="0">
-              <a:buNone/>
-              <a:defRPr sz="1600" b="1"/>
-            </a:lvl9pPr>
-          </a:lstStyle>
-          <a:p>
-            <a:pPr lvl="0"/>
-            <a:r>
-              <a:rPr lang="en-US"/>
-              <a:t>Click to edit Master text styles</a:t>
-            </a:r>
-          </a:p>
-        </p:txBody>
-      </p:sp>
-      <p:sp>
-        <p:nvSpPr>
-          <p:cNvPr id="6" name="Content Placeholder 5">
-            <a:extLst>
-              <a:ext uri="{FF2B5EF4-FFF2-40B4-BE49-F238E27FC236}">
-                <a16:creationId xmlns:a16="http://schemas.microsoft.com/office/drawing/2014/main" id="{C1A789F8-0980-1D34-41E1-FEAABAA2685D}"/>
-              </a:ext>
-            </a:extLst>
-          </p:cNvPr>
-          <p:cNvSpPr>
-            <a:spLocks noGrp="1"/>
-          </p:cNvSpPr>
-          <p:nvPr>
-            <p:ph sz="quarter" idx="4"/>
-          </p:nvPr>
-        </p:nvSpPr>
-        <p:spPr>
-          <a:xfrm>
-            <a:off x="6172200" y="2505075"/>
-            <a:ext cx="5183188" cy="3684588"/>
-          </a:xfrm>
-        </p:spPr>
-        <p:txBody>
-          <a:bodyPr/>
-          <a:lstStyle/>
-          <a:p>
-            <a:pPr lvl="0"/>
-            <a:r>
-              <a:rPr lang="en-US"/>
-              <a:t>Click to edit Master text styles</a:t>
-            </a:r>
-          </a:p>
-          <a:p>
-            <a:pPr lvl="1"/>
-            <a:r>
-              <a:rPr lang="en-US"/>
-              <a:t>Second level</a:t>
-            </a:r>
-          </a:p>
-          <a:p>
-            <a:pPr lvl="2"/>
-            <a:r>
-              <a:rPr lang="en-US"/>
-              <a:t>Third level</a:t>
-            </a:r>
-          </a:p>
-          <a:p>
-            <a:pPr lvl="3"/>
-            <a:r>
-              <a:rPr lang="en-US"/>
-              <a:t>Fourth level</a:t>
-            </a:r>
-          </a:p>
-          <a:p>
-            <a:pPr lvl="4"/>
-            <a:r>
-              <a:rPr lang="en-US"/>
-              <a:t>Fifth level</a:t>
-            </a:r>
-            <a:endParaRPr lang="en-GB"/>
-          </a:p>
-        </p:txBody>
-      </p:sp>
-      <p:sp>
-        <p:nvSpPr>
-          <p:cNvPr id="7" name="Date Placeholder 6">
-            <a:extLst>
-              <a:ext uri="{FF2B5EF4-FFF2-40B4-BE49-F238E27FC236}">
-                <a16:creationId xmlns:a16="http://schemas.microsoft.com/office/drawing/2014/main" id="{1F2380E7-5C7D-7099-0AA4-FD8B6F22D3F4}"/>
-              </a:ext>
-            </a:extLst>
-          </p:cNvPr>
-          <p:cNvSpPr>
-            <a:spLocks noGrp="1"/>
-          </p:cNvSpPr>
-          <p:nvPr>
-            <p:ph type="dt" sz="half" idx="10"/>
-          </p:nvPr>
-        </p:nvSpPr>
-        <p:spPr/>
-        <p:txBody>
-          <a:bodyPr/>
-          <a:lstStyle/>
-          <a:p>
-            <a:fld id="{36250D35-438B-41E9-BDE2-B658D3957A6D}" type="datetimeFigureOut">
-              <a:rPr lang="en-GB" smtClean="0"/>
-              <a:t>12/09/2025</a:t>
-            </a:fld>
-            <a:endParaRPr lang="en-GB"/>
-          </a:p>
-        </p:txBody>
-      </p:sp>
-      <p:sp>
-        <p:nvSpPr>
-          <p:cNvPr id="8" name="Footer Placeholder 7">
-            <a:extLst>
-              <a:ext uri="{FF2B5EF4-FFF2-40B4-BE49-F238E27FC236}">
-                <a16:creationId xmlns:a16="http://schemas.microsoft.com/office/drawing/2014/main" id="{F829338F-0879-4BD7-32FB-AE4345443DF4}"/>
-              </a:ext>
-            </a:extLst>
-          </p:cNvPr>
-          <p:cNvSpPr>
-            <a:spLocks noGrp="1"/>
-          </p:cNvSpPr>
-          <p:nvPr>
-            <p:ph type="ftr" sz="quarter" idx="11"/>
-          </p:nvPr>
-        </p:nvSpPr>
-        <p:spPr/>
-        <p:txBody>
-          <a:bodyPr/>
-          <a:lstStyle/>
-          <a:p>
-            <a:endParaRPr lang="en-GB"/>
-          </a:p>
-        </p:txBody>
-      </p:sp>
-      <p:sp>
-        <p:nvSpPr>
-          <p:cNvPr id="9" name="Slide Number Placeholder 8">
-            <a:extLst>
-              <a:ext uri="{FF2B5EF4-FFF2-40B4-BE49-F238E27FC236}">
-                <a16:creationId xmlns:a16="http://schemas.microsoft.com/office/drawing/2014/main" id="{41254E4D-D8D5-70DD-A4D7-827830AA4FD2}"/>
-              </a:ext>
-            </a:extLst>
-          </p:cNvPr>
-          <p:cNvSpPr>
-            <a:spLocks noGrp="1"/>
-          </p:cNvSpPr>
-          <p:nvPr>
-            <p:ph type="sldNum" sz="quarter" idx="12"/>
-          </p:nvPr>
-        </p:nvSpPr>
-        <p:spPr/>
-        <p:txBody>
-          <a:bodyPr/>
-          <a:lstStyle/>
-          <a:p>
-            <a:fld id="{882737FA-DC85-4AD9-8658-285F461F85AF}" type="slidenum">
-              <a:rPr lang="en-GB" smtClean="0"/>
-              <a:t>‹#›</a:t>
-            </a:fld>
-            <a:endParaRPr lang="en-GB"/>
-          </a:p>
-        </p:txBody>
-      </p:sp>
-    </p:spTree>
-    <p:extLst>
-      <p:ext uri="{BB962C8B-B14F-4D97-AF65-F5344CB8AC3E}">
-        <p14:creationId xmlns:p14="http://schemas.microsoft.com/office/powerpoint/2010/main" val="2998469546"/>
-      </p:ext>
-    </p:extLst>
-  </p:cSld>
-  <p:clrMapOvr>
-    <a:masterClrMapping/>
-  </p:clrMapOvr>
-</p:sldLayout>
-</file>
-
-<file path=ppt/slideLayouts/slideLayout33.xml><?xml version="1.0" encoding="utf-8"?>
-<p:sldLayout xmlns:a="http://schemas.openxmlformats.org/drawingml/2006/main" xmlns:r="http://schemas.openxmlformats.org/officeDocument/2006/relationships" xmlns:p="http://schemas.openxmlformats.org/presentationml/2006/main" type="titleOnly" preserve="1">
-  <p:cSld name="Title Only">
-    <p:spTree>
-      <p:nvGrpSpPr>
-        <p:cNvPr id="1" name=""/>
-        <p:cNvGrpSpPr/>
-        <p:nvPr/>
-      </p:nvGrpSpPr>
-      <p:grpSpPr>
-        <a:xfrm>
-          <a:off x="0" y="0"/>
-          <a:ext cx="0" cy="0"/>
-          <a:chOff x="0" y="0"/>
-          <a:chExt cx="0" cy="0"/>
-        </a:xfrm>
-      </p:grpSpPr>
-      <p:sp>
-        <p:nvSpPr>
-          <p:cNvPr id="2" name="Title 1">
-            <a:extLst>
-              <a:ext uri="{FF2B5EF4-FFF2-40B4-BE49-F238E27FC236}">
-                <a16:creationId xmlns:a16="http://schemas.microsoft.com/office/drawing/2014/main" id="{1AF75A34-9E1A-42A4-CB10-B805F9E06583}"/>
-              </a:ext>
-            </a:extLst>
-          </p:cNvPr>
-          <p:cNvSpPr>
-            <a:spLocks noGrp="1"/>
-          </p:cNvSpPr>
-          <p:nvPr>
-            <p:ph type="title"/>
-          </p:nvPr>
-        </p:nvSpPr>
-        <p:spPr/>
-        <p:txBody>
-          <a:bodyPr/>
-          <a:lstStyle/>
-          <a:p>
-            <a:r>
-              <a:rPr lang="en-US"/>
-              <a:t>Click to edit Master title style</a:t>
-            </a:r>
-            <a:endParaRPr lang="en-GB"/>
-          </a:p>
-        </p:txBody>
-      </p:sp>
-      <p:sp>
-        <p:nvSpPr>
-          <p:cNvPr id="3" name="Date Placeholder 2">
-            <a:extLst>
-              <a:ext uri="{FF2B5EF4-FFF2-40B4-BE49-F238E27FC236}">
-                <a16:creationId xmlns:a16="http://schemas.microsoft.com/office/drawing/2014/main" id="{B6FD11EE-7982-46CA-CE88-6ADA2F5E3334}"/>
-              </a:ext>
-            </a:extLst>
-          </p:cNvPr>
-          <p:cNvSpPr>
-            <a:spLocks noGrp="1"/>
-          </p:cNvSpPr>
-          <p:nvPr>
-            <p:ph type="dt" sz="half" idx="10"/>
-          </p:nvPr>
-        </p:nvSpPr>
-        <p:spPr/>
-        <p:txBody>
-          <a:bodyPr/>
-          <a:lstStyle/>
-          <a:p>
-            <a:fld id="{36250D35-438B-41E9-BDE2-B658D3957A6D}" type="datetimeFigureOut">
-              <a:rPr lang="en-GB" smtClean="0"/>
-              <a:t>12/09/2025</a:t>
-            </a:fld>
-            <a:endParaRPr lang="en-GB"/>
-          </a:p>
-        </p:txBody>
-      </p:sp>
-      <p:sp>
-        <p:nvSpPr>
-          <p:cNvPr id="4" name="Footer Placeholder 3">
-            <a:extLst>
-              <a:ext uri="{FF2B5EF4-FFF2-40B4-BE49-F238E27FC236}">
-                <a16:creationId xmlns:a16="http://schemas.microsoft.com/office/drawing/2014/main" id="{6DE66C81-FD12-5CE5-3511-98E342189AF6}"/>
-              </a:ext>
-            </a:extLst>
-          </p:cNvPr>
-          <p:cNvSpPr>
-            <a:spLocks noGrp="1"/>
-          </p:cNvSpPr>
-          <p:nvPr>
-            <p:ph type="ftr" sz="quarter" idx="11"/>
-          </p:nvPr>
-        </p:nvSpPr>
-        <p:spPr/>
-        <p:txBody>
-          <a:bodyPr/>
-          <a:lstStyle/>
-          <a:p>
-            <a:endParaRPr lang="en-GB"/>
-          </a:p>
-        </p:txBody>
-      </p:sp>
-      <p:sp>
-        <p:nvSpPr>
-          <p:cNvPr id="5" name="Slide Number Placeholder 4">
-            <a:extLst>
-              <a:ext uri="{FF2B5EF4-FFF2-40B4-BE49-F238E27FC236}">
-                <a16:creationId xmlns:a16="http://schemas.microsoft.com/office/drawing/2014/main" id="{CEF82604-49B2-0B7F-5554-F32C0061FDAB}"/>
-              </a:ext>
-            </a:extLst>
-          </p:cNvPr>
-          <p:cNvSpPr>
-            <a:spLocks noGrp="1"/>
-          </p:cNvSpPr>
-          <p:nvPr>
-            <p:ph type="sldNum" sz="quarter" idx="12"/>
-          </p:nvPr>
-        </p:nvSpPr>
-        <p:spPr/>
-        <p:txBody>
-          <a:bodyPr/>
-          <a:lstStyle/>
-          <a:p>
-            <a:fld id="{882737FA-DC85-4AD9-8658-285F461F85AF}" type="slidenum">
-              <a:rPr lang="en-GB" smtClean="0"/>
-              <a:t>‹#›</a:t>
-            </a:fld>
-            <a:endParaRPr lang="en-GB"/>
-          </a:p>
-        </p:txBody>
-      </p:sp>
-    </p:spTree>
-    <p:extLst>
-      <p:ext uri="{BB962C8B-B14F-4D97-AF65-F5344CB8AC3E}">
-        <p14:creationId xmlns:p14="http://schemas.microsoft.com/office/powerpoint/2010/main" val="3818997978"/>
-      </p:ext>
-    </p:extLst>
-  </p:cSld>
-  <p:clrMapOvr>
-    <a:masterClrMapping/>
-  </p:clrMapOvr>
-</p:sldLayout>
-</file>
-
-<file path=ppt/slideLayouts/slideLayout34.xml><?xml version="1.0" encoding="utf-8"?>
-<p:sldLayout xmlns:a="http://schemas.openxmlformats.org/drawingml/2006/main" xmlns:r="http://schemas.openxmlformats.org/officeDocument/2006/relationships" xmlns:p="http://schemas.openxmlformats.org/presentationml/2006/main" type="blank" preserve="1">
-  <p:cSld name="Blank">
-    <p:spTree>
-      <p:nvGrpSpPr>
-        <p:cNvPr id="1" name=""/>
-        <p:cNvGrpSpPr/>
-        <p:nvPr/>
-      </p:nvGrpSpPr>
-      <p:grpSpPr>
-        <a:xfrm>
-          <a:off x="0" y="0"/>
-          <a:ext cx="0" cy="0"/>
-          <a:chOff x="0" y="0"/>
-          <a:chExt cx="0" cy="0"/>
-        </a:xfrm>
-      </p:grpSpPr>
-      <p:sp>
-        <p:nvSpPr>
-          <p:cNvPr id="2" name="Date Placeholder 1">
-            <a:extLst>
-              <a:ext uri="{FF2B5EF4-FFF2-40B4-BE49-F238E27FC236}">
-                <a16:creationId xmlns:a16="http://schemas.microsoft.com/office/drawing/2014/main" id="{91D9DC3A-3F54-0611-3317-C49801F039CA}"/>
-              </a:ext>
-            </a:extLst>
-          </p:cNvPr>
-          <p:cNvSpPr>
-            <a:spLocks noGrp="1"/>
-          </p:cNvSpPr>
-          <p:nvPr>
-            <p:ph type="dt" sz="half" idx="10"/>
-          </p:nvPr>
-        </p:nvSpPr>
-        <p:spPr/>
-        <p:txBody>
-          <a:bodyPr/>
-          <a:lstStyle/>
-          <a:p>
-            <a:fld id="{36250D35-438B-41E9-BDE2-B658D3957A6D}" type="datetimeFigureOut">
-              <a:rPr lang="en-GB" smtClean="0"/>
-              <a:t>12/09/2025</a:t>
-            </a:fld>
-            <a:endParaRPr lang="en-GB"/>
-          </a:p>
-        </p:txBody>
-      </p:sp>
-      <p:sp>
-        <p:nvSpPr>
-          <p:cNvPr id="3" name="Footer Placeholder 2">
-            <a:extLst>
-              <a:ext uri="{FF2B5EF4-FFF2-40B4-BE49-F238E27FC236}">
-                <a16:creationId xmlns:a16="http://schemas.microsoft.com/office/drawing/2014/main" id="{5350CAFA-BD19-6981-ED22-DFE7AC26313F}"/>
-              </a:ext>
-            </a:extLst>
-          </p:cNvPr>
-          <p:cNvSpPr>
-            <a:spLocks noGrp="1"/>
-          </p:cNvSpPr>
-          <p:nvPr>
-            <p:ph type="ftr" sz="quarter" idx="11"/>
-          </p:nvPr>
-        </p:nvSpPr>
-        <p:spPr/>
-        <p:txBody>
-          <a:bodyPr/>
-          <a:lstStyle/>
-          <a:p>
-            <a:endParaRPr lang="en-GB"/>
-          </a:p>
-        </p:txBody>
-      </p:sp>
-      <p:sp>
-        <p:nvSpPr>
-          <p:cNvPr id="4" name="Slide Number Placeholder 3">
-            <a:extLst>
-              <a:ext uri="{FF2B5EF4-FFF2-40B4-BE49-F238E27FC236}">
-                <a16:creationId xmlns:a16="http://schemas.microsoft.com/office/drawing/2014/main" id="{892074CD-15AF-764E-F5BD-E8BD7A148CAD}"/>
-              </a:ext>
-            </a:extLst>
-          </p:cNvPr>
-          <p:cNvSpPr>
-            <a:spLocks noGrp="1"/>
-          </p:cNvSpPr>
-          <p:nvPr>
-            <p:ph type="sldNum" sz="quarter" idx="12"/>
-          </p:nvPr>
-        </p:nvSpPr>
-        <p:spPr/>
-        <p:txBody>
-          <a:bodyPr/>
-          <a:lstStyle/>
-          <a:p>
-            <a:fld id="{882737FA-DC85-4AD9-8658-285F461F85AF}" type="slidenum">
-              <a:rPr lang="en-GB" smtClean="0"/>
-              <a:t>‹#›</a:t>
-            </a:fld>
-            <a:endParaRPr lang="en-GB"/>
-          </a:p>
-        </p:txBody>
-      </p:sp>
-    </p:spTree>
-    <p:extLst>
-      <p:ext uri="{BB962C8B-B14F-4D97-AF65-F5344CB8AC3E}">
-        <p14:creationId xmlns:p14="http://schemas.microsoft.com/office/powerpoint/2010/main" val="3535649428"/>
-      </p:ext>
-    </p:extLst>
-  </p:cSld>
-  <p:clrMapOvr>
-    <a:masterClrMapping/>
-  </p:clrMapOvr>
-</p:sldLayout>
-</file>
-
-<file path=ppt/slideLayouts/slideLayout35.xml><?xml version="1.0" encoding="utf-8"?>
-<p:sldLayout xmlns:a="http://schemas.openxmlformats.org/drawingml/2006/main" xmlns:r="http://schemas.openxmlformats.org/officeDocument/2006/relationships" xmlns:p="http://schemas.openxmlformats.org/presentationml/2006/main" type="objTx" preserve="1">
-  <p:cSld name="Content with Caption">
-    <p:spTree>
-      <p:nvGrpSpPr>
-        <p:cNvPr id="1" name=""/>
-        <p:cNvGrpSpPr/>
-        <p:nvPr/>
-      </p:nvGrpSpPr>
-      <p:grpSpPr>
-        <a:xfrm>
-          <a:off x="0" y="0"/>
-          <a:ext cx="0" cy="0"/>
-          <a:chOff x="0" y="0"/>
-          <a:chExt cx="0" cy="0"/>
-        </a:xfrm>
-      </p:grpSpPr>
-      <p:sp>
-        <p:nvSpPr>
-          <p:cNvPr id="2" name="Title 1">
-            <a:extLst>
-              <a:ext uri="{FF2B5EF4-FFF2-40B4-BE49-F238E27FC236}">
-                <a16:creationId xmlns:a16="http://schemas.microsoft.com/office/drawing/2014/main" id="{B5902E6D-A82A-8BA3-0560-71926EB921C8}"/>
-              </a:ext>
-            </a:extLst>
-          </p:cNvPr>
-          <p:cNvSpPr>
-            <a:spLocks noGrp="1"/>
-          </p:cNvSpPr>
-          <p:nvPr>
-            <p:ph type="title"/>
-          </p:nvPr>
-        </p:nvSpPr>
-        <p:spPr>
-          <a:xfrm>
-            <a:off x="839788" y="457200"/>
-            <a:ext cx="3932237" cy="1600200"/>
-          </a:xfrm>
-        </p:spPr>
-        <p:txBody>
-          <a:bodyPr anchor="b"/>
-          <a:lstStyle>
-            <a:lvl1pPr>
-              <a:defRPr sz="3200"/>
-            </a:lvl1pPr>
-          </a:lstStyle>
-          <a:p>
-            <a:r>
-              <a:rPr lang="en-US"/>
-              <a:t>Click to edit Master title style</a:t>
-            </a:r>
-            <a:endParaRPr lang="en-GB"/>
-          </a:p>
-        </p:txBody>
-      </p:sp>
-      <p:sp>
-        <p:nvSpPr>
-          <p:cNvPr id="3" name="Content Placeholder 2">
-            <a:extLst>
-              <a:ext uri="{FF2B5EF4-FFF2-40B4-BE49-F238E27FC236}">
-                <a16:creationId xmlns:a16="http://schemas.microsoft.com/office/drawing/2014/main" id="{EC79078C-1469-D2BF-A072-8F61002630E6}"/>
-              </a:ext>
-            </a:extLst>
-          </p:cNvPr>
-          <p:cNvSpPr>
-            <a:spLocks noGrp="1"/>
-          </p:cNvSpPr>
-          <p:nvPr>
-            <p:ph idx="1"/>
-          </p:nvPr>
-        </p:nvSpPr>
-        <p:spPr>
-          <a:xfrm>
-            <a:off x="5183188" y="987425"/>
-            <a:ext cx="6172200" cy="4873625"/>
-          </a:xfrm>
-        </p:spPr>
-        <p:txBody>
-          <a:bodyPr/>
-          <a:lstStyle>
-            <a:lvl1pPr>
-              <a:defRPr sz="3200"/>
-            </a:lvl1pPr>
-            <a:lvl2pPr>
-              <a:defRPr sz="2800"/>
-            </a:lvl2pPr>
-            <a:lvl3pPr>
-              <a:defRPr sz="2400"/>
-            </a:lvl3pPr>
-            <a:lvl4pPr>
-              <a:defRPr sz="2000"/>
-            </a:lvl4pPr>
-            <a:lvl5pPr>
-              <a:defRPr sz="2000"/>
-            </a:lvl5pPr>
-            <a:lvl6pPr>
-              <a:defRPr sz="2000"/>
-            </a:lvl6pPr>
-            <a:lvl7pPr>
-              <a:defRPr sz="2000"/>
-            </a:lvl7pPr>
-            <a:lvl8pPr>
-              <a:defRPr sz="2000"/>
-            </a:lvl8pPr>
-            <a:lvl9pPr>
-              <a:defRPr sz="2000"/>
-            </a:lvl9pPr>
-          </a:lstStyle>
-          <a:p>
-            <a:pPr lvl="0"/>
-            <a:r>
-              <a:rPr lang="en-US"/>
-              <a:t>Click to edit Master text styles</a:t>
-            </a:r>
-          </a:p>
-          <a:p>
-            <a:pPr lvl="1"/>
-            <a:r>
-              <a:rPr lang="en-US"/>
-              <a:t>Second level</a:t>
-            </a:r>
-          </a:p>
-          <a:p>
-            <a:pPr lvl="2"/>
-            <a:r>
-              <a:rPr lang="en-US"/>
-              <a:t>Third level</a:t>
-            </a:r>
-          </a:p>
-          <a:p>
-            <a:pPr lvl="3"/>
-            <a:r>
-              <a:rPr lang="en-US"/>
-              <a:t>Fourth level</a:t>
-            </a:r>
-          </a:p>
-          <a:p>
-            <a:pPr lvl="4"/>
-            <a:r>
-              <a:rPr lang="en-US"/>
-              <a:t>Fifth level</a:t>
-            </a:r>
-            <a:endParaRPr lang="en-GB"/>
-          </a:p>
-        </p:txBody>
-      </p:sp>
-      <p:sp>
-        <p:nvSpPr>
-          <p:cNvPr id="4" name="Text Placeholder 3">
-            <a:extLst>
-              <a:ext uri="{FF2B5EF4-FFF2-40B4-BE49-F238E27FC236}">
-                <a16:creationId xmlns:a16="http://schemas.microsoft.com/office/drawing/2014/main" id="{F373EA80-6412-ACE8-D811-334339625820}"/>
-              </a:ext>
-            </a:extLst>
-          </p:cNvPr>
-          <p:cNvSpPr>
-            <a:spLocks noGrp="1"/>
-          </p:cNvSpPr>
-          <p:nvPr>
-            <p:ph type="body" sz="half" idx="2"/>
-          </p:nvPr>
-        </p:nvSpPr>
-        <p:spPr>
-          <a:xfrm>
-            <a:off x="839788" y="2057400"/>
-            <a:ext cx="3932237" cy="3811588"/>
-          </a:xfrm>
-        </p:spPr>
-        <p:txBody>
-          <a:bodyPr/>
-          <a:lstStyle>
-            <a:lvl1pPr marL="0" indent="0">
-              <a:buNone/>
-              <a:defRPr sz="1600"/>
-            </a:lvl1pPr>
-            <a:lvl2pPr marL="457200" indent="0">
-              <a:buNone/>
-              <a:defRPr sz="1400"/>
-            </a:lvl2pPr>
-            <a:lvl3pPr marL="914400" indent="0">
-              <a:buNone/>
-              <a:defRPr sz="1200"/>
-            </a:lvl3pPr>
-            <a:lvl4pPr marL="1371600" indent="0">
-              <a:buNone/>
-              <a:defRPr sz="1000"/>
-            </a:lvl4pPr>
-            <a:lvl5pPr marL="1828800" indent="0">
-              <a:buNone/>
-              <a:defRPr sz="1000"/>
-            </a:lvl5pPr>
-            <a:lvl6pPr marL="2286000" indent="0">
-              <a:buNone/>
-              <a:defRPr sz="1000"/>
-            </a:lvl6pPr>
-            <a:lvl7pPr marL="2743200" indent="0">
-              <a:buNone/>
-              <a:defRPr sz="1000"/>
-            </a:lvl7pPr>
-            <a:lvl8pPr marL="3200400" indent="0">
-              <a:buNone/>
-              <a:defRPr sz="1000"/>
-            </a:lvl8pPr>
-            <a:lvl9pPr marL="3657600" indent="0">
-              <a:buNone/>
-              <a:defRPr sz="1000"/>
-            </a:lvl9pPr>
-          </a:lstStyle>
-          <a:p>
-            <a:pPr lvl="0"/>
-            <a:r>
-              <a:rPr lang="en-US"/>
-              <a:t>Click to edit Master text styles</a:t>
-            </a:r>
-          </a:p>
-        </p:txBody>
-      </p:sp>
-      <p:sp>
-        <p:nvSpPr>
-          <p:cNvPr id="5" name="Date Placeholder 4">
-            <a:extLst>
-              <a:ext uri="{FF2B5EF4-FFF2-40B4-BE49-F238E27FC236}">
-                <a16:creationId xmlns:a16="http://schemas.microsoft.com/office/drawing/2014/main" id="{517FF30D-C7B8-5602-06AA-0263AC6FF373}"/>
-              </a:ext>
-            </a:extLst>
-          </p:cNvPr>
-          <p:cNvSpPr>
-            <a:spLocks noGrp="1"/>
-          </p:cNvSpPr>
-          <p:nvPr>
-            <p:ph type="dt" sz="half" idx="10"/>
-          </p:nvPr>
-        </p:nvSpPr>
-        <p:spPr/>
-        <p:txBody>
-          <a:bodyPr/>
-          <a:lstStyle/>
-          <a:p>
-            <a:fld id="{36250D35-438B-41E9-BDE2-B658D3957A6D}" type="datetimeFigureOut">
-              <a:rPr lang="en-GB" smtClean="0"/>
-              <a:t>12/09/2025</a:t>
-            </a:fld>
-            <a:endParaRPr lang="en-GB"/>
-          </a:p>
-        </p:txBody>
-      </p:sp>
-      <p:sp>
-        <p:nvSpPr>
-          <p:cNvPr id="6" name="Footer Placeholder 5">
-            <a:extLst>
-              <a:ext uri="{FF2B5EF4-FFF2-40B4-BE49-F238E27FC236}">
-                <a16:creationId xmlns:a16="http://schemas.microsoft.com/office/drawing/2014/main" id="{3D1B410B-AA7D-9BBB-7F2B-0631F3F6BFDC}"/>
-              </a:ext>
-            </a:extLst>
-          </p:cNvPr>
-          <p:cNvSpPr>
-            <a:spLocks noGrp="1"/>
-          </p:cNvSpPr>
-          <p:nvPr>
-            <p:ph type="ftr" sz="quarter" idx="11"/>
-          </p:nvPr>
-        </p:nvSpPr>
-        <p:spPr/>
-        <p:txBody>
-          <a:bodyPr/>
-          <a:lstStyle/>
-          <a:p>
-            <a:endParaRPr lang="en-GB"/>
-          </a:p>
-        </p:txBody>
-      </p:sp>
-      <p:sp>
-        <p:nvSpPr>
-          <p:cNvPr id="7" name="Slide Number Placeholder 6">
-            <a:extLst>
-              <a:ext uri="{FF2B5EF4-FFF2-40B4-BE49-F238E27FC236}">
-                <a16:creationId xmlns:a16="http://schemas.microsoft.com/office/drawing/2014/main" id="{5F17505F-FE68-2B85-392C-80CF58E93D49}"/>
-              </a:ext>
-            </a:extLst>
-          </p:cNvPr>
-          <p:cNvSpPr>
-            <a:spLocks noGrp="1"/>
-          </p:cNvSpPr>
-          <p:nvPr>
-            <p:ph type="sldNum" sz="quarter" idx="12"/>
-          </p:nvPr>
-        </p:nvSpPr>
-        <p:spPr/>
-        <p:txBody>
-          <a:bodyPr/>
-          <a:lstStyle/>
-          <a:p>
-            <a:fld id="{882737FA-DC85-4AD9-8658-285F461F85AF}" type="slidenum">
-              <a:rPr lang="en-GB" smtClean="0"/>
-              <a:t>‹#›</a:t>
-            </a:fld>
-            <a:endParaRPr lang="en-GB"/>
-          </a:p>
-        </p:txBody>
-      </p:sp>
-    </p:spTree>
-    <p:extLst>
-      <p:ext uri="{BB962C8B-B14F-4D97-AF65-F5344CB8AC3E}">
-        <p14:creationId xmlns:p14="http://schemas.microsoft.com/office/powerpoint/2010/main" val="2040710303"/>
-      </p:ext>
-    </p:extLst>
-  </p:cSld>
-  <p:clrMapOvr>
-    <a:masterClrMapping/>
-  </p:clrMapOvr>
-</p:sldLayout>
-</file>
-
-<file path=ppt/slideLayouts/slideLayout36.xml><?xml version="1.0" encoding="utf-8"?>
-<p:sldLayout xmlns:a="http://schemas.openxmlformats.org/drawingml/2006/main" xmlns:r="http://schemas.openxmlformats.org/officeDocument/2006/relationships" xmlns:p="http://schemas.openxmlformats.org/presentationml/2006/main" type="picTx" preserve="1">
-  <p:cSld name="Picture with Caption">
-    <p:spTree>
-      <p:nvGrpSpPr>
-        <p:cNvPr id="1" name=""/>
-        <p:cNvGrpSpPr/>
-        <p:nvPr/>
-      </p:nvGrpSpPr>
-      <p:grpSpPr>
-        <a:xfrm>
-          <a:off x="0" y="0"/>
-          <a:ext cx="0" cy="0"/>
-          <a:chOff x="0" y="0"/>
-          <a:chExt cx="0" cy="0"/>
-        </a:xfrm>
-      </p:grpSpPr>
-      <p:sp>
-        <p:nvSpPr>
-          <p:cNvPr id="2" name="Title 1">
-            <a:extLst>
-              <a:ext uri="{FF2B5EF4-FFF2-40B4-BE49-F238E27FC236}">
-                <a16:creationId xmlns:a16="http://schemas.microsoft.com/office/drawing/2014/main" id="{39F1654D-AB82-3D93-4226-5A1947DE6537}"/>
-              </a:ext>
-            </a:extLst>
-          </p:cNvPr>
-          <p:cNvSpPr>
-            <a:spLocks noGrp="1"/>
-          </p:cNvSpPr>
-          <p:nvPr>
-            <p:ph type="title"/>
-          </p:nvPr>
-        </p:nvSpPr>
-        <p:spPr>
-          <a:xfrm>
-            <a:off x="839788" y="457200"/>
-            <a:ext cx="3932237" cy="1600200"/>
-          </a:xfrm>
-        </p:spPr>
-        <p:txBody>
-          <a:bodyPr anchor="b"/>
-          <a:lstStyle>
-            <a:lvl1pPr>
-              <a:defRPr sz="3200"/>
-            </a:lvl1pPr>
-          </a:lstStyle>
-          <a:p>
-            <a:r>
-              <a:rPr lang="en-US"/>
-              <a:t>Click to edit Master title style</a:t>
-            </a:r>
-            <a:endParaRPr lang="en-GB"/>
-          </a:p>
-        </p:txBody>
-      </p:sp>
-      <p:sp>
-        <p:nvSpPr>
-          <p:cNvPr id="3" name="Picture Placeholder 2">
-            <a:extLst>
-              <a:ext uri="{FF2B5EF4-FFF2-40B4-BE49-F238E27FC236}">
-                <a16:creationId xmlns:a16="http://schemas.microsoft.com/office/drawing/2014/main" id="{D8E22ACC-3DF6-3848-9276-35881A7437E7}"/>
-              </a:ext>
-            </a:extLst>
-          </p:cNvPr>
-          <p:cNvSpPr>
-            <a:spLocks noGrp="1"/>
-          </p:cNvSpPr>
-          <p:nvPr>
-            <p:ph type="pic" idx="1"/>
-          </p:nvPr>
-        </p:nvSpPr>
-        <p:spPr>
-          <a:xfrm>
-            <a:off x="5183188" y="987425"/>
-            <a:ext cx="6172200" cy="4873625"/>
-          </a:xfrm>
-        </p:spPr>
-        <p:txBody>
-          <a:bodyPr/>
-          <a:lstStyle>
-            <a:lvl1pPr marL="0" indent="0">
-              <a:buNone/>
-              <a:defRPr sz="3200"/>
-            </a:lvl1pPr>
-            <a:lvl2pPr marL="457200" indent="0">
-              <a:buNone/>
-              <a:defRPr sz="2800"/>
-            </a:lvl2pPr>
-            <a:lvl3pPr marL="914400" indent="0">
-              <a:buNone/>
-              <a:defRPr sz="2400"/>
-            </a:lvl3pPr>
-            <a:lvl4pPr marL="1371600" indent="0">
-              <a:buNone/>
-              <a:defRPr sz="2000"/>
-            </a:lvl4pPr>
-            <a:lvl5pPr marL="1828800" indent="0">
-              <a:buNone/>
-              <a:defRPr sz="2000"/>
-            </a:lvl5pPr>
-            <a:lvl6pPr marL="2286000" indent="0">
-              <a:buNone/>
-              <a:defRPr sz="2000"/>
-            </a:lvl6pPr>
-            <a:lvl7pPr marL="2743200" indent="0">
-              <a:buNone/>
-              <a:defRPr sz="2000"/>
-            </a:lvl7pPr>
-            <a:lvl8pPr marL="3200400" indent="0">
-              <a:buNone/>
-              <a:defRPr sz="2000"/>
-            </a:lvl8pPr>
-            <a:lvl9pPr marL="3657600" indent="0">
-              <a:buNone/>
-              <a:defRPr sz="2000"/>
-            </a:lvl9pPr>
-          </a:lstStyle>
-          <a:p>
-            <a:endParaRPr lang="en-GB"/>
-          </a:p>
-        </p:txBody>
-      </p:sp>
-      <p:sp>
-        <p:nvSpPr>
-          <p:cNvPr id="4" name="Text Placeholder 3">
-            <a:extLst>
-              <a:ext uri="{FF2B5EF4-FFF2-40B4-BE49-F238E27FC236}">
-                <a16:creationId xmlns:a16="http://schemas.microsoft.com/office/drawing/2014/main" id="{2976DDCA-7C0D-C5D9-9F4A-9A1354DCA005}"/>
-              </a:ext>
-            </a:extLst>
-          </p:cNvPr>
-          <p:cNvSpPr>
-            <a:spLocks noGrp="1"/>
-          </p:cNvSpPr>
-          <p:nvPr>
-            <p:ph type="body" sz="half" idx="2"/>
-          </p:nvPr>
-        </p:nvSpPr>
-        <p:spPr>
-          <a:xfrm>
-            <a:off x="839788" y="2057400"/>
-            <a:ext cx="3932237" cy="3811588"/>
-          </a:xfrm>
-        </p:spPr>
-        <p:txBody>
-          <a:bodyPr/>
-          <a:lstStyle>
-            <a:lvl1pPr marL="0" indent="0">
-              <a:buNone/>
-              <a:defRPr sz="1600"/>
-            </a:lvl1pPr>
-            <a:lvl2pPr marL="457200" indent="0">
-              <a:buNone/>
-              <a:defRPr sz="1400"/>
-            </a:lvl2pPr>
-            <a:lvl3pPr marL="914400" indent="0">
-              <a:buNone/>
-              <a:defRPr sz="1200"/>
-            </a:lvl3pPr>
-            <a:lvl4pPr marL="1371600" indent="0">
-              <a:buNone/>
-              <a:defRPr sz="1000"/>
-            </a:lvl4pPr>
-            <a:lvl5pPr marL="1828800" indent="0">
-              <a:buNone/>
-              <a:defRPr sz="1000"/>
-            </a:lvl5pPr>
-            <a:lvl6pPr marL="2286000" indent="0">
-              <a:buNone/>
-              <a:defRPr sz="1000"/>
-            </a:lvl6pPr>
-            <a:lvl7pPr marL="2743200" indent="0">
-              <a:buNone/>
-              <a:defRPr sz="1000"/>
-            </a:lvl7pPr>
-            <a:lvl8pPr marL="3200400" indent="0">
-              <a:buNone/>
-              <a:defRPr sz="1000"/>
-            </a:lvl8pPr>
-            <a:lvl9pPr marL="3657600" indent="0">
-              <a:buNone/>
-              <a:defRPr sz="1000"/>
-            </a:lvl9pPr>
-          </a:lstStyle>
-          <a:p>
-            <a:pPr lvl="0"/>
-            <a:r>
-              <a:rPr lang="en-US"/>
-              <a:t>Click to edit Master text styles</a:t>
-            </a:r>
-          </a:p>
-        </p:txBody>
-      </p:sp>
-      <p:sp>
-        <p:nvSpPr>
-          <p:cNvPr id="5" name="Date Placeholder 4">
-            <a:extLst>
-              <a:ext uri="{FF2B5EF4-FFF2-40B4-BE49-F238E27FC236}">
-                <a16:creationId xmlns:a16="http://schemas.microsoft.com/office/drawing/2014/main" id="{85A2877E-8FB2-4871-E329-6CC0723F1AE8}"/>
-              </a:ext>
-            </a:extLst>
-          </p:cNvPr>
-          <p:cNvSpPr>
-            <a:spLocks noGrp="1"/>
-          </p:cNvSpPr>
-          <p:nvPr>
-            <p:ph type="dt" sz="half" idx="10"/>
-          </p:nvPr>
-        </p:nvSpPr>
-        <p:spPr/>
-        <p:txBody>
-          <a:bodyPr/>
-          <a:lstStyle/>
-          <a:p>
-            <a:fld id="{36250D35-438B-41E9-BDE2-B658D3957A6D}" type="datetimeFigureOut">
-              <a:rPr lang="en-GB" smtClean="0"/>
-              <a:t>12/09/2025</a:t>
-            </a:fld>
-            <a:endParaRPr lang="en-GB"/>
-          </a:p>
-        </p:txBody>
-      </p:sp>
-      <p:sp>
-        <p:nvSpPr>
-          <p:cNvPr id="6" name="Footer Placeholder 5">
-            <a:extLst>
-              <a:ext uri="{FF2B5EF4-FFF2-40B4-BE49-F238E27FC236}">
-                <a16:creationId xmlns:a16="http://schemas.microsoft.com/office/drawing/2014/main" id="{B3FA6EC6-EFCF-F787-FC2D-F308FD10CDF1}"/>
-              </a:ext>
-            </a:extLst>
-          </p:cNvPr>
-          <p:cNvSpPr>
-            <a:spLocks noGrp="1"/>
-          </p:cNvSpPr>
-          <p:nvPr>
-            <p:ph type="ftr" sz="quarter" idx="11"/>
-          </p:nvPr>
-        </p:nvSpPr>
-        <p:spPr/>
-        <p:txBody>
-          <a:bodyPr/>
-          <a:lstStyle/>
-          <a:p>
-            <a:endParaRPr lang="en-GB"/>
-          </a:p>
-        </p:txBody>
-      </p:sp>
-      <p:sp>
-        <p:nvSpPr>
-          <p:cNvPr id="7" name="Slide Number Placeholder 6">
-            <a:extLst>
-              <a:ext uri="{FF2B5EF4-FFF2-40B4-BE49-F238E27FC236}">
-                <a16:creationId xmlns:a16="http://schemas.microsoft.com/office/drawing/2014/main" id="{69019D46-3DDA-5003-74FA-098422CC2B4A}"/>
-              </a:ext>
-            </a:extLst>
-          </p:cNvPr>
-          <p:cNvSpPr>
-            <a:spLocks noGrp="1"/>
-          </p:cNvSpPr>
-          <p:nvPr>
-            <p:ph type="sldNum" sz="quarter" idx="12"/>
-          </p:nvPr>
-        </p:nvSpPr>
-        <p:spPr/>
-        <p:txBody>
-          <a:bodyPr/>
-          <a:lstStyle/>
-          <a:p>
-            <a:fld id="{882737FA-DC85-4AD9-8658-285F461F85AF}" type="slidenum">
-              <a:rPr lang="en-GB" smtClean="0"/>
-              <a:t>‹#›</a:t>
-            </a:fld>
-            <a:endParaRPr lang="en-GB"/>
-          </a:p>
-        </p:txBody>
-      </p:sp>
-    </p:spTree>
-    <p:extLst>
-      <p:ext uri="{BB962C8B-B14F-4D97-AF65-F5344CB8AC3E}">
-        <p14:creationId xmlns:p14="http://schemas.microsoft.com/office/powerpoint/2010/main" val="3948391708"/>
-      </p:ext>
-    </p:extLst>
-  </p:cSld>
-  <p:clrMapOvr>
-    <a:masterClrMapping/>
-  </p:clrMapOvr>
-</p:sldLayout>
-</file>
-
-<file path=ppt/slideLayouts/slideLayout37.xml><?xml version="1.0" encoding="utf-8"?>
-<p:sldLayout xmlns:a="http://schemas.openxmlformats.org/drawingml/2006/main" xmlns:r="http://schemas.openxmlformats.org/officeDocument/2006/relationships" xmlns:p="http://schemas.openxmlformats.org/presentationml/2006/main" type="vertTx" preserve="1">
-  <p:cSld name="Title and Vertical Text">
-    <p:spTree>
-      <p:nvGrpSpPr>
-        <p:cNvPr id="1" name=""/>
-        <p:cNvGrpSpPr/>
-        <p:nvPr/>
-      </p:nvGrpSpPr>
-      <p:grpSpPr>
-        <a:xfrm>
-          <a:off x="0" y="0"/>
-          <a:ext cx="0" cy="0"/>
-          <a:chOff x="0" y="0"/>
-          <a:chExt cx="0" cy="0"/>
-        </a:xfrm>
-      </p:grpSpPr>
-      <p:sp>
-        <p:nvSpPr>
-          <p:cNvPr id="2" name="Title 1">
-            <a:extLst>
-              <a:ext uri="{FF2B5EF4-FFF2-40B4-BE49-F238E27FC236}">
-                <a16:creationId xmlns:a16="http://schemas.microsoft.com/office/drawing/2014/main" id="{5FE7CBEF-2C29-2195-5859-2079329C49F5}"/>
-              </a:ext>
-            </a:extLst>
-          </p:cNvPr>
-          <p:cNvSpPr>
-            <a:spLocks noGrp="1"/>
-          </p:cNvSpPr>
-          <p:nvPr>
-            <p:ph type="title"/>
-          </p:nvPr>
-        </p:nvSpPr>
-        <p:spPr/>
-        <p:txBody>
-          <a:bodyPr/>
-          <a:lstStyle/>
-          <a:p>
-            <a:r>
-              <a:rPr lang="en-US"/>
-              <a:t>Click to edit Master title style</a:t>
-            </a:r>
-            <a:endParaRPr lang="en-GB"/>
-          </a:p>
-        </p:txBody>
-      </p:sp>
-      <p:sp>
-        <p:nvSpPr>
-          <p:cNvPr id="3" name="Vertical Text Placeholder 2">
-            <a:extLst>
-              <a:ext uri="{FF2B5EF4-FFF2-40B4-BE49-F238E27FC236}">
-                <a16:creationId xmlns:a16="http://schemas.microsoft.com/office/drawing/2014/main" id="{13AE69C9-00FE-D689-796F-1D774D7B5039}"/>
-              </a:ext>
-            </a:extLst>
-          </p:cNvPr>
-          <p:cNvSpPr>
-            <a:spLocks noGrp="1"/>
-          </p:cNvSpPr>
-          <p:nvPr>
-            <p:ph type="body" orient="vert" idx="1"/>
-          </p:nvPr>
-        </p:nvSpPr>
-        <p:spPr/>
-        <p:txBody>
-          <a:bodyPr vert="eaVert"/>
-          <a:lstStyle/>
-          <a:p>
-            <a:pPr lvl="0"/>
-            <a:r>
-              <a:rPr lang="en-US"/>
-              <a:t>Click to edit Master text styles</a:t>
-            </a:r>
-          </a:p>
-          <a:p>
-            <a:pPr lvl="1"/>
-            <a:r>
-              <a:rPr lang="en-US"/>
-              <a:t>Second level</a:t>
-            </a:r>
-          </a:p>
-          <a:p>
-            <a:pPr lvl="2"/>
-            <a:r>
-              <a:rPr lang="en-US"/>
-              <a:t>Third level</a:t>
-            </a:r>
-          </a:p>
-          <a:p>
-            <a:pPr lvl="3"/>
-            <a:r>
-              <a:rPr lang="en-US"/>
-              <a:t>Fourth level</a:t>
-            </a:r>
-          </a:p>
-          <a:p>
-            <a:pPr lvl="4"/>
-            <a:r>
-              <a:rPr lang="en-US"/>
-              <a:t>Fifth level</a:t>
-            </a:r>
-            <a:endParaRPr lang="en-GB"/>
-          </a:p>
-        </p:txBody>
-      </p:sp>
-      <p:sp>
-        <p:nvSpPr>
-          <p:cNvPr id="4" name="Date Placeholder 3">
-            <a:extLst>
-              <a:ext uri="{FF2B5EF4-FFF2-40B4-BE49-F238E27FC236}">
-                <a16:creationId xmlns:a16="http://schemas.microsoft.com/office/drawing/2014/main" id="{249D476F-16BD-C3F7-2759-3317F4DB710D}"/>
-              </a:ext>
-            </a:extLst>
-          </p:cNvPr>
-          <p:cNvSpPr>
-            <a:spLocks noGrp="1"/>
-          </p:cNvSpPr>
-          <p:nvPr>
-            <p:ph type="dt" sz="half" idx="10"/>
-          </p:nvPr>
-        </p:nvSpPr>
-        <p:spPr/>
-        <p:txBody>
-          <a:bodyPr/>
-          <a:lstStyle/>
-          <a:p>
-            <a:fld id="{36250D35-438B-41E9-BDE2-B658D3957A6D}" type="datetimeFigureOut">
-              <a:rPr lang="en-GB" smtClean="0"/>
-              <a:t>12/09/2025</a:t>
-            </a:fld>
-            <a:endParaRPr lang="en-GB"/>
-          </a:p>
-        </p:txBody>
-      </p:sp>
-      <p:sp>
-        <p:nvSpPr>
-          <p:cNvPr id="5" name="Footer Placeholder 4">
-            <a:extLst>
-              <a:ext uri="{FF2B5EF4-FFF2-40B4-BE49-F238E27FC236}">
-                <a16:creationId xmlns:a16="http://schemas.microsoft.com/office/drawing/2014/main" id="{96A6C5D4-A396-224F-4018-AC23AE163130}"/>
-              </a:ext>
-            </a:extLst>
-          </p:cNvPr>
-          <p:cNvSpPr>
-            <a:spLocks noGrp="1"/>
-          </p:cNvSpPr>
-          <p:nvPr>
-            <p:ph type="ftr" sz="quarter" idx="11"/>
-          </p:nvPr>
-        </p:nvSpPr>
-        <p:spPr/>
-        <p:txBody>
-          <a:bodyPr/>
-          <a:lstStyle/>
-          <a:p>
-            <a:endParaRPr lang="en-GB"/>
-          </a:p>
-        </p:txBody>
-      </p:sp>
-      <p:sp>
-        <p:nvSpPr>
-          <p:cNvPr id="6" name="Slide Number Placeholder 5">
-            <a:extLst>
-              <a:ext uri="{FF2B5EF4-FFF2-40B4-BE49-F238E27FC236}">
-                <a16:creationId xmlns:a16="http://schemas.microsoft.com/office/drawing/2014/main" id="{5B7675AD-221A-CDEE-A91C-C119C8B08FB8}"/>
-              </a:ext>
-            </a:extLst>
-          </p:cNvPr>
-          <p:cNvSpPr>
-            <a:spLocks noGrp="1"/>
-          </p:cNvSpPr>
-          <p:nvPr>
-            <p:ph type="sldNum" sz="quarter" idx="12"/>
-          </p:nvPr>
-        </p:nvSpPr>
-        <p:spPr/>
-        <p:txBody>
-          <a:bodyPr/>
-          <a:lstStyle/>
-          <a:p>
-            <a:fld id="{882737FA-DC85-4AD9-8658-285F461F85AF}" type="slidenum">
-              <a:rPr lang="en-GB" smtClean="0"/>
-              <a:t>‹#›</a:t>
-            </a:fld>
-            <a:endParaRPr lang="en-GB"/>
-          </a:p>
-        </p:txBody>
-      </p:sp>
-    </p:spTree>
-    <p:extLst>
-      <p:ext uri="{BB962C8B-B14F-4D97-AF65-F5344CB8AC3E}">
-        <p14:creationId xmlns:p14="http://schemas.microsoft.com/office/powerpoint/2010/main" val="2865956551"/>
-      </p:ext>
-    </p:extLst>
-  </p:cSld>
-  <p:clrMapOvr>
-    <a:masterClrMapping/>
-  </p:clrMapOvr>
-</p:sldLayout>
-</file>
-
-<file path=ppt/slideLayouts/slideLayout38.xml><?xml version="1.0" encoding="utf-8"?>
-<p:sldLayout xmlns:a="http://schemas.openxmlformats.org/drawingml/2006/main" xmlns:r="http://schemas.openxmlformats.org/officeDocument/2006/relationships" xmlns:p="http://schemas.openxmlformats.org/presentationml/2006/main" type="vertTitleAndTx" preserve="1">
-  <p:cSld name="Vertical Title and Text">
-    <p:spTree>
-      <p:nvGrpSpPr>
-        <p:cNvPr id="1" name=""/>
-        <p:cNvGrpSpPr/>
-        <p:nvPr/>
-      </p:nvGrpSpPr>
-      <p:grpSpPr>
-        <a:xfrm>
-          <a:off x="0" y="0"/>
-          <a:ext cx="0" cy="0"/>
-          <a:chOff x="0" y="0"/>
-          <a:chExt cx="0" cy="0"/>
-        </a:xfrm>
-      </p:grpSpPr>
-      <p:sp>
-        <p:nvSpPr>
-          <p:cNvPr id="2" name="Vertical Title 1">
-            <a:extLst>
-              <a:ext uri="{FF2B5EF4-FFF2-40B4-BE49-F238E27FC236}">
-                <a16:creationId xmlns:a16="http://schemas.microsoft.com/office/drawing/2014/main" id="{5F2A764F-1F01-2EA9-D592-BA22EEC5F46B}"/>
-              </a:ext>
-            </a:extLst>
-          </p:cNvPr>
-          <p:cNvSpPr>
-            <a:spLocks noGrp="1"/>
-          </p:cNvSpPr>
-          <p:nvPr>
-            <p:ph type="title" orient="vert"/>
-          </p:nvPr>
-        </p:nvSpPr>
-        <p:spPr>
-          <a:xfrm>
-            <a:off x="8724900" y="365125"/>
-            <a:ext cx="2628900" cy="5811838"/>
-          </a:xfrm>
-        </p:spPr>
-        <p:txBody>
-          <a:bodyPr vert="eaVert"/>
-          <a:lstStyle/>
-          <a:p>
-            <a:r>
-              <a:rPr lang="en-US"/>
-              <a:t>Click to edit Master title style</a:t>
-            </a:r>
-            <a:endParaRPr lang="en-GB"/>
-          </a:p>
-        </p:txBody>
-      </p:sp>
-      <p:sp>
-        <p:nvSpPr>
-          <p:cNvPr id="3" name="Vertical Text Placeholder 2">
-            <a:extLst>
-              <a:ext uri="{FF2B5EF4-FFF2-40B4-BE49-F238E27FC236}">
-                <a16:creationId xmlns:a16="http://schemas.microsoft.com/office/drawing/2014/main" id="{0038B344-C7F3-CCD8-6544-30D38AC016CB}"/>
-              </a:ext>
-            </a:extLst>
-          </p:cNvPr>
-          <p:cNvSpPr>
-            <a:spLocks noGrp="1"/>
-          </p:cNvSpPr>
-          <p:nvPr>
-            <p:ph type="body" orient="vert" idx="1"/>
-          </p:nvPr>
-        </p:nvSpPr>
-        <p:spPr>
-          <a:xfrm>
-            <a:off x="838200" y="365125"/>
-            <a:ext cx="7734300" cy="5811838"/>
-          </a:xfrm>
-        </p:spPr>
-        <p:txBody>
-          <a:bodyPr vert="eaVert"/>
-          <a:lstStyle/>
-          <a:p>
-            <a:pPr lvl="0"/>
-            <a:r>
-              <a:rPr lang="en-US"/>
-              <a:t>Click to edit Master text styles</a:t>
-            </a:r>
-          </a:p>
-          <a:p>
-            <a:pPr lvl="1"/>
-            <a:r>
-              <a:rPr lang="en-US"/>
-              <a:t>Second level</a:t>
-            </a:r>
-          </a:p>
-          <a:p>
-            <a:pPr lvl="2"/>
-            <a:r>
-              <a:rPr lang="en-US"/>
-              <a:t>Third level</a:t>
-            </a:r>
-          </a:p>
-          <a:p>
-            <a:pPr lvl="3"/>
-            <a:r>
-              <a:rPr lang="en-US"/>
-              <a:t>Fourth level</a:t>
-            </a:r>
-          </a:p>
-          <a:p>
-            <a:pPr lvl="4"/>
-            <a:r>
-              <a:rPr lang="en-US"/>
-              <a:t>Fifth level</a:t>
-            </a:r>
-            <a:endParaRPr lang="en-GB"/>
-          </a:p>
-        </p:txBody>
-      </p:sp>
-      <p:sp>
-        <p:nvSpPr>
-          <p:cNvPr id="4" name="Date Placeholder 3">
-            <a:extLst>
-              <a:ext uri="{FF2B5EF4-FFF2-40B4-BE49-F238E27FC236}">
-                <a16:creationId xmlns:a16="http://schemas.microsoft.com/office/drawing/2014/main" id="{E03015E0-93D3-33D2-DB08-B070BD79D953}"/>
-              </a:ext>
-            </a:extLst>
-          </p:cNvPr>
-          <p:cNvSpPr>
-            <a:spLocks noGrp="1"/>
-          </p:cNvSpPr>
-          <p:nvPr>
-            <p:ph type="dt" sz="half" idx="10"/>
-          </p:nvPr>
-        </p:nvSpPr>
-        <p:spPr/>
-        <p:txBody>
-          <a:bodyPr/>
-          <a:lstStyle/>
-          <a:p>
-            <a:fld id="{36250D35-438B-41E9-BDE2-B658D3957A6D}" type="datetimeFigureOut">
-              <a:rPr lang="en-GB" smtClean="0"/>
-              <a:t>12/09/2025</a:t>
-            </a:fld>
-            <a:endParaRPr lang="en-GB"/>
-          </a:p>
-        </p:txBody>
-      </p:sp>
-      <p:sp>
-        <p:nvSpPr>
-          <p:cNvPr id="5" name="Footer Placeholder 4">
-            <a:extLst>
-              <a:ext uri="{FF2B5EF4-FFF2-40B4-BE49-F238E27FC236}">
-                <a16:creationId xmlns:a16="http://schemas.microsoft.com/office/drawing/2014/main" id="{9ABEB90B-A9F3-D06C-3832-188BCF3DB94E}"/>
-              </a:ext>
-            </a:extLst>
-          </p:cNvPr>
-          <p:cNvSpPr>
-            <a:spLocks noGrp="1"/>
-          </p:cNvSpPr>
-          <p:nvPr>
-            <p:ph type="ftr" sz="quarter" idx="11"/>
-          </p:nvPr>
-        </p:nvSpPr>
-        <p:spPr/>
-        <p:txBody>
-          <a:bodyPr/>
-          <a:lstStyle/>
-          <a:p>
-            <a:endParaRPr lang="en-GB"/>
-          </a:p>
-        </p:txBody>
-      </p:sp>
-      <p:sp>
-        <p:nvSpPr>
-          <p:cNvPr id="6" name="Slide Number Placeholder 5">
-            <a:extLst>
-              <a:ext uri="{FF2B5EF4-FFF2-40B4-BE49-F238E27FC236}">
-                <a16:creationId xmlns:a16="http://schemas.microsoft.com/office/drawing/2014/main" id="{FF76F569-773A-4F95-EB89-8DDFD7B1C883}"/>
-              </a:ext>
-            </a:extLst>
-          </p:cNvPr>
-          <p:cNvSpPr>
-            <a:spLocks noGrp="1"/>
-          </p:cNvSpPr>
-          <p:nvPr>
-            <p:ph type="sldNum" sz="quarter" idx="12"/>
-          </p:nvPr>
-        </p:nvSpPr>
-        <p:spPr/>
-        <p:txBody>
-          <a:bodyPr/>
-          <a:lstStyle/>
-          <a:p>
-            <a:fld id="{882737FA-DC85-4AD9-8658-285F461F85AF}" type="slidenum">
-              <a:rPr lang="en-GB" smtClean="0"/>
-              <a:t>‹#›</a:t>
-            </a:fld>
-            <a:endParaRPr lang="en-GB"/>
-          </a:p>
-        </p:txBody>
-      </p:sp>
-    </p:spTree>
-    <p:extLst>
-      <p:ext uri="{BB962C8B-B14F-4D97-AF65-F5344CB8AC3E}">
-        <p14:creationId xmlns:p14="http://schemas.microsoft.com/office/powerpoint/2010/main" val="4075316961"/>
       </p:ext>
     </p:extLst>
   </p:cSld>
@@ -8120,7 +5466,7 @@
           <a:p>
             <a:fld id="{DF89F9ED-2410-4CD1-B5CD-D275AA293E22}" type="datetimeFigureOut">
               <a:rPr lang="LID4096" smtClean="0"/>
-              <a:t>09/12/2025</a:t>
+              <a:t>04/20/2026</a:t>
             </a:fld>
             <a:endParaRPr lang="LID4096"/>
           </a:p>
@@ -8535,7 +5881,7 @@
           <a:p>
             <a:fld id="{DF89F9ED-2410-4CD1-B5CD-D275AA293E22}" type="datetimeFigureOut">
               <a:rPr lang="LID4096" smtClean="0"/>
-              <a:t>09/12/2025</a:t>
+              <a:t>04/20/2026</a:t>
             </a:fld>
             <a:endParaRPr lang="LID4096"/>
           </a:p>
@@ -8677,7 +6023,7 @@
           <a:p>
             <a:fld id="{DF89F9ED-2410-4CD1-B5CD-D275AA293E22}" type="datetimeFigureOut">
               <a:rPr lang="LID4096" smtClean="0"/>
-              <a:t>09/12/2025</a:t>
+              <a:t>04/20/2026</a:t>
             </a:fld>
             <a:endParaRPr lang="LID4096"/>
           </a:p>
@@ -8790,7 +6136,7 @@
           <a:p>
             <a:fld id="{DF89F9ED-2410-4CD1-B5CD-D275AA293E22}" type="datetimeFigureOut">
               <a:rPr lang="LID4096" smtClean="0"/>
-              <a:t>09/12/2025</a:t>
+              <a:t>04/20/2026</a:t>
             </a:fld>
             <a:endParaRPr lang="LID4096"/>
           </a:p>
@@ -9103,7 +6449,7 @@
           <a:p>
             <a:fld id="{DF89F9ED-2410-4CD1-B5CD-D275AA293E22}" type="datetimeFigureOut">
               <a:rPr lang="LID4096" smtClean="0"/>
-              <a:t>09/12/2025</a:t>
+              <a:t>04/20/2026</a:t>
             </a:fld>
             <a:endParaRPr lang="LID4096"/>
           </a:p>
@@ -9392,7 +6738,7 @@
           <a:p>
             <a:fld id="{DF89F9ED-2410-4CD1-B5CD-D275AA293E22}" type="datetimeFigureOut">
               <a:rPr lang="LID4096" smtClean="0"/>
-              <a:t>09/12/2025</a:t>
+              <a:t>04/20/2026</a:t>
             </a:fld>
             <a:endParaRPr lang="LID4096"/>
           </a:p>
@@ -9635,7 +6981,7 @@
           <a:p>
             <a:fld id="{DF89F9ED-2410-4CD1-B5CD-D275AA293E22}" type="datetimeFigureOut">
               <a:rPr lang="LID4096" smtClean="0"/>
-              <a:t>09/12/2025</a:t>
+              <a:t>04/20/2026</a:t>
             </a:fld>
             <a:endParaRPr lang="LID4096"/>
           </a:p>
@@ -10203,7 +7549,7 @@
             <a:fld id="{B61BEF0D-F0BB-DE4B-95CE-6DB70DBA9567}" type="datetimeFigureOut">
               <a:rPr lang="en-US"/>
               <a:pPr/>
-              <a:t>9/12/2025</a:t>
+              <a:t>4/20/2026</a:t>
             </a:fld>
             <a:endParaRPr lang="en-US"/>
           </a:p>
@@ -10301,10 +7647,10 @@
           <p:nvPr userDrawn="1"/>
         </p:nvPicPr>
         <p:blipFill>
-          <a:blip r:embed="rId18">
+          <a:blip>
             <a:extLst>
               <a:ext uri="{96DAC541-7B7A-43D3-8B79-37D633B846F1}">
-                <asvg:svgBlip xmlns:asvg="http://schemas.microsoft.com/office/drawing/2016/SVG/main" r:embed="rId19"/>
+                <asvg:svgBlip xmlns:asvg="http://schemas.microsoft.com/office/drawing/2016/SVG/main" r:embed="rId18"/>
               </a:ext>
             </a:extLst>
           </a:blip>
@@ -10747,576 +8093,6 @@
 </p:sldMaster>
 </file>
 
-<file path=ppt/slideMasters/slideMaster3.xml><?xml version="1.0" encoding="utf-8"?>
-<p:sldMaster xmlns:a="http://schemas.openxmlformats.org/drawingml/2006/main" xmlns:r="http://schemas.openxmlformats.org/officeDocument/2006/relationships" xmlns:p="http://schemas.openxmlformats.org/presentationml/2006/main">
-  <p:cSld>
-    <p:bg>
-      <p:bgRef idx="1001">
-        <a:schemeClr val="bg1"/>
-      </p:bgRef>
-    </p:bg>
-    <p:spTree>
-      <p:nvGrpSpPr>
-        <p:cNvPr id="1" name=""/>
-        <p:cNvGrpSpPr/>
-        <p:nvPr/>
-      </p:nvGrpSpPr>
-      <p:grpSpPr>
-        <a:xfrm>
-          <a:off x="0" y="0"/>
-          <a:ext cx="0" cy="0"/>
-          <a:chOff x="0" y="0"/>
-          <a:chExt cx="0" cy="0"/>
-        </a:xfrm>
-      </p:grpSpPr>
-      <p:sp>
-        <p:nvSpPr>
-          <p:cNvPr id="2" name="Title Placeholder 1">
-            <a:extLst>
-              <a:ext uri="{FF2B5EF4-FFF2-40B4-BE49-F238E27FC236}">
-                <a16:creationId xmlns:a16="http://schemas.microsoft.com/office/drawing/2014/main" id="{A7A3200B-A090-85C9-5E14-78354449998B}"/>
-              </a:ext>
-            </a:extLst>
-          </p:cNvPr>
-          <p:cNvSpPr>
-            <a:spLocks noGrp="1"/>
-          </p:cNvSpPr>
-          <p:nvPr>
-            <p:ph type="title"/>
-          </p:nvPr>
-        </p:nvSpPr>
-        <p:spPr>
-          <a:xfrm>
-            <a:off x="838200" y="365125"/>
-            <a:ext cx="10515600" cy="1325563"/>
-          </a:xfrm>
-          <a:prstGeom prst="rect">
-            <a:avLst/>
-          </a:prstGeom>
-        </p:spPr>
-        <p:txBody>
-          <a:bodyPr vert="horz" lIns="91440" tIns="45720" rIns="91440" bIns="45720" rtlCol="0" anchor="ctr">
-            <a:normAutofit/>
-          </a:bodyPr>
-          <a:lstStyle/>
-          <a:p>
-            <a:r>
-              <a:rPr lang="en-US"/>
-              <a:t>Click to edit Master title style</a:t>
-            </a:r>
-            <a:endParaRPr lang="en-GB"/>
-          </a:p>
-        </p:txBody>
-      </p:sp>
-      <p:sp>
-        <p:nvSpPr>
-          <p:cNvPr id="3" name="Text Placeholder 2">
-            <a:extLst>
-              <a:ext uri="{FF2B5EF4-FFF2-40B4-BE49-F238E27FC236}">
-                <a16:creationId xmlns:a16="http://schemas.microsoft.com/office/drawing/2014/main" id="{140AA6D9-C16B-92C8-4AF5-F493E0E0DB56}"/>
-              </a:ext>
-            </a:extLst>
-          </p:cNvPr>
-          <p:cNvSpPr>
-            <a:spLocks noGrp="1"/>
-          </p:cNvSpPr>
-          <p:nvPr>
-            <p:ph type="body" idx="1"/>
-          </p:nvPr>
-        </p:nvSpPr>
-        <p:spPr>
-          <a:xfrm>
-            <a:off x="838200" y="1825625"/>
-            <a:ext cx="10515600" cy="4351338"/>
-          </a:xfrm>
-          <a:prstGeom prst="rect">
-            <a:avLst/>
-          </a:prstGeom>
-        </p:spPr>
-        <p:txBody>
-          <a:bodyPr vert="horz" lIns="91440" tIns="45720" rIns="91440" bIns="45720" rtlCol="0">
-            <a:normAutofit/>
-          </a:bodyPr>
-          <a:lstStyle/>
-          <a:p>
-            <a:pPr lvl="0"/>
-            <a:r>
-              <a:rPr lang="en-US"/>
-              <a:t>Click to edit Master text styles</a:t>
-            </a:r>
-          </a:p>
-          <a:p>
-            <a:pPr lvl="1"/>
-            <a:r>
-              <a:rPr lang="en-US"/>
-              <a:t>Second level</a:t>
-            </a:r>
-          </a:p>
-          <a:p>
-            <a:pPr lvl="2"/>
-            <a:r>
-              <a:rPr lang="en-US"/>
-              <a:t>Third level</a:t>
-            </a:r>
-          </a:p>
-          <a:p>
-            <a:pPr lvl="3"/>
-            <a:r>
-              <a:rPr lang="en-US"/>
-              <a:t>Fourth level</a:t>
-            </a:r>
-          </a:p>
-          <a:p>
-            <a:pPr lvl="4"/>
-            <a:r>
-              <a:rPr lang="en-US"/>
-              <a:t>Fifth level</a:t>
-            </a:r>
-            <a:endParaRPr lang="en-GB"/>
-          </a:p>
-        </p:txBody>
-      </p:sp>
-      <p:sp>
-        <p:nvSpPr>
-          <p:cNvPr id="4" name="Date Placeholder 3">
-            <a:extLst>
-              <a:ext uri="{FF2B5EF4-FFF2-40B4-BE49-F238E27FC236}">
-                <a16:creationId xmlns:a16="http://schemas.microsoft.com/office/drawing/2014/main" id="{766F8D57-9C3D-9E5B-00F4-55BB8B64F4FB}"/>
-              </a:ext>
-            </a:extLst>
-          </p:cNvPr>
-          <p:cNvSpPr>
-            <a:spLocks noGrp="1"/>
-          </p:cNvSpPr>
-          <p:nvPr>
-            <p:ph type="dt" sz="half" idx="2"/>
-          </p:nvPr>
-        </p:nvSpPr>
-        <p:spPr>
-          <a:xfrm>
-            <a:off x="838200" y="6356350"/>
-            <a:ext cx="2743200" cy="365125"/>
-          </a:xfrm>
-          <a:prstGeom prst="rect">
-            <a:avLst/>
-          </a:prstGeom>
-        </p:spPr>
-        <p:txBody>
-          <a:bodyPr vert="horz" lIns="91440" tIns="45720" rIns="91440" bIns="45720" rtlCol="0" anchor="ctr"/>
-          <a:lstStyle>
-            <a:lvl1pPr algn="l">
-              <a:defRPr sz="1200">
-                <a:solidFill>
-                  <a:schemeClr val="tx1">
-                    <a:tint val="82000"/>
-                  </a:schemeClr>
-                </a:solidFill>
-              </a:defRPr>
-            </a:lvl1pPr>
-          </a:lstStyle>
-          <a:p>
-            <a:fld id="{36250D35-438B-41E9-BDE2-B658D3957A6D}" type="datetimeFigureOut">
-              <a:rPr lang="en-GB" smtClean="0"/>
-              <a:t>12/09/2025</a:t>
-            </a:fld>
-            <a:endParaRPr lang="en-GB"/>
-          </a:p>
-        </p:txBody>
-      </p:sp>
-      <p:sp>
-        <p:nvSpPr>
-          <p:cNvPr id="5" name="Footer Placeholder 4">
-            <a:extLst>
-              <a:ext uri="{FF2B5EF4-FFF2-40B4-BE49-F238E27FC236}">
-                <a16:creationId xmlns:a16="http://schemas.microsoft.com/office/drawing/2014/main" id="{AEAD242F-1B49-03F3-36E5-BD0F1992AE98}"/>
-              </a:ext>
-            </a:extLst>
-          </p:cNvPr>
-          <p:cNvSpPr>
-            <a:spLocks noGrp="1"/>
-          </p:cNvSpPr>
-          <p:nvPr>
-            <p:ph type="ftr" sz="quarter" idx="3"/>
-          </p:nvPr>
-        </p:nvSpPr>
-        <p:spPr>
-          <a:xfrm>
-            <a:off x="4038600" y="6356350"/>
-            <a:ext cx="4114800" cy="365125"/>
-          </a:xfrm>
-          <a:prstGeom prst="rect">
-            <a:avLst/>
-          </a:prstGeom>
-        </p:spPr>
-        <p:txBody>
-          <a:bodyPr vert="horz" lIns="91440" tIns="45720" rIns="91440" bIns="45720" rtlCol="0" anchor="ctr"/>
-          <a:lstStyle>
-            <a:lvl1pPr algn="ctr">
-              <a:defRPr sz="1200">
-                <a:solidFill>
-                  <a:schemeClr val="tx1">
-                    <a:tint val="82000"/>
-                  </a:schemeClr>
-                </a:solidFill>
-              </a:defRPr>
-            </a:lvl1pPr>
-          </a:lstStyle>
-          <a:p>
-            <a:endParaRPr lang="en-GB"/>
-          </a:p>
-        </p:txBody>
-      </p:sp>
-      <p:sp>
-        <p:nvSpPr>
-          <p:cNvPr id="6" name="Slide Number Placeholder 5">
-            <a:extLst>
-              <a:ext uri="{FF2B5EF4-FFF2-40B4-BE49-F238E27FC236}">
-                <a16:creationId xmlns:a16="http://schemas.microsoft.com/office/drawing/2014/main" id="{6CB3D2E4-1EAD-7876-75D0-65C1319B7AFD}"/>
-              </a:ext>
-            </a:extLst>
-          </p:cNvPr>
-          <p:cNvSpPr>
-            <a:spLocks noGrp="1"/>
-          </p:cNvSpPr>
-          <p:nvPr>
-            <p:ph type="sldNum" sz="quarter" idx="4"/>
-          </p:nvPr>
-        </p:nvSpPr>
-        <p:spPr>
-          <a:xfrm>
-            <a:off x="8610600" y="6356350"/>
-            <a:ext cx="2743200" cy="365125"/>
-          </a:xfrm>
-          <a:prstGeom prst="rect">
-            <a:avLst/>
-          </a:prstGeom>
-        </p:spPr>
-        <p:txBody>
-          <a:bodyPr vert="horz" lIns="91440" tIns="45720" rIns="91440" bIns="45720" rtlCol="0" anchor="ctr"/>
-          <a:lstStyle>
-            <a:lvl1pPr algn="r">
-              <a:defRPr sz="1200">
-                <a:solidFill>
-                  <a:schemeClr val="tx1">
-                    <a:tint val="82000"/>
-                  </a:schemeClr>
-                </a:solidFill>
-              </a:defRPr>
-            </a:lvl1pPr>
-          </a:lstStyle>
-          <a:p>
-            <a:fld id="{882737FA-DC85-4AD9-8658-285F461F85AF}" type="slidenum">
-              <a:rPr lang="en-GB" smtClean="0"/>
-              <a:t>‹#›</a:t>
-            </a:fld>
-            <a:endParaRPr lang="en-GB"/>
-          </a:p>
-        </p:txBody>
-      </p:sp>
-    </p:spTree>
-    <p:extLst>
-      <p:ext uri="{BB962C8B-B14F-4D97-AF65-F5344CB8AC3E}">
-        <p14:creationId xmlns:p14="http://schemas.microsoft.com/office/powerpoint/2010/main" val="3570604679"/>
-      </p:ext>
-    </p:extLst>
-  </p:cSld>
-  <p:clrMap bg1="lt1" tx1="dk1" bg2="lt2" tx2="dk2" accent1="accent1" accent2="accent2" accent3="accent3" accent4="accent4" accent5="accent5" accent6="accent6" hlink="hlink" folHlink="folHlink"/>
-  <p:sldLayoutIdLst>
-    <p:sldLayoutId id="2147483678" r:id="rId1"/>
-    <p:sldLayoutId id="2147483679" r:id="rId2"/>
-    <p:sldLayoutId id="2147483680" r:id="rId3"/>
-    <p:sldLayoutId id="2147483681" r:id="rId4"/>
-    <p:sldLayoutId id="2147483682" r:id="rId5"/>
-    <p:sldLayoutId id="2147483683" r:id="rId6"/>
-    <p:sldLayoutId id="2147483684" r:id="rId7"/>
-    <p:sldLayoutId id="2147483685" r:id="rId8"/>
-    <p:sldLayoutId id="2147483686" r:id="rId9"/>
-    <p:sldLayoutId id="2147483687" r:id="rId10"/>
-    <p:sldLayoutId id="2147483688" r:id="rId11"/>
-  </p:sldLayoutIdLst>
-  <p:txStyles>
-    <p:titleStyle>
-      <a:lvl1pPr algn="l" defTabSz="914400" rtl="0" eaLnBrk="1" latinLnBrk="0" hangingPunct="1">
-        <a:lnSpc>
-          <a:spcPct val="90000"/>
-        </a:lnSpc>
-        <a:spcBef>
-          <a:spcPct val="0"/>
-        </a:spcBef>
-        <a:buNone/>
-        <a:defRPr sz="4400" kern="1200">
-          <a:solidFill>
-            <a:schemeClr val="tx1"/>
-          </a:solidFill>
-          <a:latin typeface="+mj-lt"/>
-          <a:ea typeface="+mj-ea"/>
-          <a:cs typeface="+mj-cs"/>
-        </a:defRPr>
-      </a:lvl1pPr>
-    </p:titleStyle>
-    <p:bodyStyle>
-      <a:lvl1pPr marL="228600" indent="-228600" algn="l" defTabSz="914400" rtl="0" eaLnBrk="1" latinLnBrk="0" hangingPunct="1">
-        <a:lnSpc>
-          <a:spcPct val="90000"/>
-        </a:lnSpc>
-        <a:spcBef>
-          <a:spcPts val="1000"/>
-        </a:spcBef>
-        <a:buFont typeface="Arial" panose="020B0604020202020204" pitchFamily="34" charset="0"/>
-        <a:buChar char="•"/>
-        <a:defRPr sz="2800" kern="1200">
-          <a:solidFill>
-            <a:schemeClr val="tx1"/>
-          </a:solidFill>
-          <a:latin typeface="+mn-lt"/>
-          <a:ea typeface="+mn-ea"/>
-          <a:cs typeface="+mn-cs"/>
-        </a:defRPr>
-      </a:lvl1pPr>
-      <a:lvl2pPr marL="685800" indent="-228600" algn="l" defTabSz="914400" rtl="0" eaLnBrk="1" latinLnBrk="0" hangingPunct="1">
-        <a:lnSpc>
-          <a:spcPct val="90000"/>
-        </a:lnSpc>
-        <a:spcBef>
-          <a:spcPts val="500"/>
-        </a:spcBef>
-        <a:buFont typeface="Arial" panose="020B0604020202020204" pitchFamily="34" charset="0"/>
-        <a:buChar char="•"/>
-        <a:defRPr sz="2400" kern="1200">
-          <a:solidFill>
-            <a:schemeClr val="tx1"/>
-          </a:solidFill>
-          <a:latin typeface="+mn-lt"/>
-          <a:ea typeface="+mn-ea"/>
-          <a:cs typeface="+mn-cs"/>
-        </a:defRPr>
-      </a:lvl2pPr>
-      <a:lvl3pPr marL="1143000" indent="-228600" algn="l" defTabSz="914400" rtl="0" eaLnBrk="1" latinLnBrk="0" hangingPunct="1">
-        <a:lnSpc>
-          <a:spcPct val="90000"/>
-        </a:lnSpc>
-        <a:spcBef>
-          <a:spcPts val="500"/>
-        </a:spcBef>
-        <a:buFont typeface="Arial" panose="020B0604020202020204" pitchFamily="34" charset="0"/>
-        <a:buChar char="•"/>
-        <a:defRPr sz="2000" kern="1200">
-          <a:solidFill>
-            <a:schemeClr val="tx1"/>
-          </a:solidFill>
-          <a:latin typeface="+mn-lt"/>
-          <a:ea typeface="+mn-ea"/>
-          <a:cs typeface="+mn-cs"/>
-        </a:defRPr>
-      </a:lvl3pPr>
-      <a:lvl4pPr marL="1600200" indent="-228600" algn="l" defTabSz="914400" rtl="0" eaLnBrk="1" latinLnBrk="0" hangingPunct="1">
-        <a:lnSpc>
-          <a:spcPct val="90000"/>
-        </a:lnSpc>
-        <a:spcBef>
-          <a:spcPts val="500"/>
-        </a:spcBef>
-        <a:buFont typeface="Arial" panose="020B0604020202020204" pitchFamily="34" charset="0"/>
-        <a:buChar char="•"/>
-        <a:defRPr sz="1800" kern="1200">
-          <a:solidFill>
-            <a:schemeClr val="tx1"/>
-          </a:solidFill>
-          <a:latin typeface="+mn-lt"/>
-          <a:ea typeface="+mn-ea"/>
-          <a:cs typeface="+mn-cs"/>
-        </a:defRPr>
-      </a:lvl4pPr>
-      <a:lvl5pPr marL="2057400" indent="-228600" algn="l" defTabSz="914400" rtl="0" eaLnBrk="1" latinLnBrk="0" hangingPunct="1">
-        <a:lnSpc>
-          <a:spcPct val="90000"/>
-        </a:lnSpc>
-        <a:spcBef>
-          <a:spcPts val="500"/>
-        </a:spcBef>
-        <a:buFont typeface="Arial" panose="020B0604020202020204" pitchFamily="34" charset="0"/>
-        <a:buChar char="•"/>
-        <a:defRPr sz="1800" kern="1200">
-          <a:solidFill>
-            <a:schemeClr val="tx1"/>
-          </a:solidFill>
-          <a:latin typeface="+mn-lt"/>
-          <a:ea typeface="+mn-ea"/>
-          <a:cs typeface="+mn-cs"/>
-        </a:defRPr>
-      </a:lvl5pPr>
-      <a:lvl6pPr marL="2514600" indent="-228600" algn="l" defTabSz="914400" rtl="0" eaLnBrk="1" latinLnBrk="0" hangingPunct="1">
-        <a:lnSpc>
-          <a:spcPct val="90000"/>
-        </a:lnSpc>
-        <a:spcBef>
-          <a:spcPts val="500"/>
-        </a:spcBef>
-        <a:buFont typeface="Arial" panose="020B0604020202020204" pitchFamily="34" charset="0"/>
-        <a:buChar char="•"/>
-        <a:defRPr sz="1800" kern="1200">
-          <a:solidFill>
-            <a:schemeClr val="tx1"/>
-          </a:solidFill>
-          <a:latin typeface="+mn-lt"/>
-          <a:ea typeface="+mn-ea"/>
-          <a:cs typeface="+mn-cs"/>
-        </a:defRPr>
-      </a:lvl6pPr>
-      <a:lvl7pPr marL="2971800" indent="-228600" algn="l" defTabSz="914400" rtl="0" eaLnBrk="1" latinLnBrk="0" hangingPunct="1">
-        <a:lnSpc>
-          <a:spcPct val="90000"/>
-        </a:lnSpc>
-        <a:spcBef>
-          <a:spcPts val="500"/>
-        </a:spcBef>
-        <a:buFont typeface="Arial" panose="020B0604020202020204" pitchFamily="34" charset="0"/>
-        <a:buChar char="•"/>
-        <a:defRPr sz="1800" kern="1200">
-          <a:solidFill>
-            <a:schemeClr val="tx1"/>
-          </a:solidFill>
-          <a:latin typeface="+mn-lt"/>
-          <a:ea typeface="+mn-ea"/>
-          <a:cs typeface="+mn-cs"/>
-        </a:defRPr>
-      </a:lvl7pPr>
-      <a:lvl8pPr marL="3429000" indent="-228600" algn="l" defTabSz="914400" rtl="0" eaLnBrk="1" latinLnBrk="0" hangingPunct="1">
-        <a:lnSpc>
-          <a:spcPct val="90000"/>
-        </a:lnSpc>
-        <a:spcBef>
-          <a:spcPts val="500"/>
-        </a:spcBef>
-        <a:buFont typeface="Arial" panose="020B0604020202020204" pitchFamily="34" charset="0"/>
-        <a:buChar char="•"/>
-        <a:defRPr sz="1800" kern="1200">
-          <a:solidFill>
-            <a:schemeClr val="tx1"/>
-          </a:solidFill>
-          <a:latin typeface="+mn-lt"/>
-          <a:ea typeface="+mn-ea"/>
-          <a:cs typeface="+mn-cs"/>
-        </a:defRPr>
-      </a:lvl8pPr>
-      <a:lvl9pPr marL="3886200" indent="-228600" algn="l" defTabSz="914400" rtl="0" eaLnBrk="1" latinLnBrk="0" hangingPunct="1">
-        <a:lnSpc>
-          <a:spcPct val="90000"/>
-        </a:lnSpc>
-        <a:spcBef>
-          <a:spcPts val="500"/>
-        </a:spcBef>
-        <a:buFont typeface="Arial" panose="020B0604020202020204" pitchFamily="34" charset="0"/>
-        <a:buChar char="•"/>
-        <a:defRPr sz="1800" kern="1200">
-          <a:solidFill>
-            <a:schemeClr val="tx1"/>
-          </a:solidFill>
-          <a:latin typeface="+mn-lt"/>
-          <a:ea typeface="+mn-ea"/>
-          <a:cs typeface="+mn-cs"/>
-        </a:defRPr>
-      </a:lvl9pPr>
-    </p:bodyStyle>
-    <p:otherStyle>
-      <a:defPPr>
-        <a:defRPr lang="en-US"/>
-      </a:defPPr>
-      <a:lvl1pPr marL="0" algn="l" defTabSz="914400" rtl="0" eaLnBrk="1" latinLnBrk="0" hangingPunct="1">
-        <a:defRPr sz="1800" kern="1200">
-          <a:solidFill>
-            <a:schemeClr val="tx1"/>
-          </a:solidFill>
-          <a:latin typeface="+mn-lt"/>
-          <a:ea typeface="+mn-ea"/>
-          <a:cs typeface="+mn-cs"/>
-        </a:defRPr>
-      </a:lvl1pPr>
-      <a:lvl2pPr marL="457200" algn="l" defTabSz="914400" rtl="0" eaLnBrk="1" latinLnBrk="0" hangingPunct="1">
-        <a:defRPr sz="1800" kern="1200">
-          <a:solidFill>
-            <a:schemeClr val="tx1"/>
-          </a:solidFill>
-          <a:latin typeface="+mn-lt"/>
-          <a:ea typeface="+mn-ea"/>
-          <a:cs typeface="+mn-cs"/>
-        </a:defRPr>
-      </a:lvl2pPr>
-      <a:lvl3pPr marL="914400" algn="l" defTabSz="914400" rtl="0" eaLnBrk="1" latinLnBrk="0" hangingPunct="1">
-        <a:defRPr sz="1800" kern="1200">
-          <a:solidFill>
-            <a:schemeClr val="tx1"/>
-          </a:solidFill>
-          <a:latin typeface="+mn-lt"/>
-          <a:ea typeface="+mn-ea"/>
-          <a:cs typeface="+mn-cs"/>
-        </a:defRPr>
-      </a:lvl3pPr>
-      <a:lvl4pPr marL="1371600" algn="l" defTabSz="914400" rtl="0" eaLnBrk="1" latinLnBrk="0" hangingPunct="1">
-        <a:defRPr sz="1800" kern="1200">
-          <a:solidFill>
-            <a:schemeClr val="tx1"/>
-          </a:solidFill>
-          <a:latin typeface="+mn-lt"/>
-          <a:ea typeface="+mn-ea"/>
-          <a:cs typeface="+mn-cs"/>
-        </a:defRPr>
-      </a:lvl4pPr>
-      <a:lvl5pPr marL="1828800" algn="l" defTabSz="914400" rtl="0" eaLnBrk="1" latinLnBrk="0" hangingPunct="1">
-        <a:defRPr sz="1800" kern="1200">
-          <a:solidFill>
-            <a:schemeClr val="tx1"/>
-          </a:solidFill>
-          <a:latin typeface="+mn-lt"/>
-          <a:ea typeface="+mn-ea"/>
-          <a:cs typeface="+mn-cs"/>
-        </a:defRPr>
-      </a:lvl5pPr>
-      <a:lvl6pPr marL="2286000" algn="l" defTabSz="914400" rtl="0" eaLnBrk="1" latinLnBrk="0" hangingPunct="1">
-        <a:defRPr sz="1800" kern="1200">
-          <a:solidFill>
-            <a:schemeClr val="tx1"/>
-          </a:solidFill>
-          <a:latin typeface="+mn-lt"/>
-          <a:ea typeface="+mn-ea"/>
-          <a:cs typeface="+mn-cs"/>
-        </a:defRPr>
-      </a:lvl6pPr>
-      <a:lvl7pPr marL="2743200" algn="l" defTabSz="914400" rtl="0" eaLnBrk="1" latinLnBrk="0" hangingPunct="1">
-        <a:defRPr sz="1800" kern="1200">
-          <a:solidFill>
-            <a:schemeClr val="tx1"/>
-          </a:solidFill>
-          <a:latin typeface="+mn-lt"/>
-          <a:ea typeface="+mn-ea"/>
-          <a:cs typeface="+mn-cs"/>
-        </a:defRPr>
-      </a:lvl7pPr>
-      <a:lvl8pPr marL="3200400" algn="l" defTabSz="914400" rtl="0" eaLnBrk="1" latinLnBrk="0" hangingPunct="1">
-        <a:defRPr sz="1800" kern="1200">
-          <a:solidFill>
-            <a:schemeClr val="tx1"/>
-          </a:solidFill>
-          <a:latin typeface="+mn-lt"/>
-          <a:ea typeface="+mn-ea"/>
-          <a:cs typeface="+mn-cs"/>
-        </a:defRPr>
-      </a:lvl8pPr>
-      <a:lvl9pPr marL="3657600" algn="l" defTabSz="914400" rtl="0" eaLnBrk="1" latinLnBrk="0" hangingPunct="1">
-        <a:defRPr sz="1800" kern="1200">
-          <a:solidFill>
-            <a:schemeClr val="tx1"/>
-          </a:solidFill>
-          <a:latin typeface="+mn-lt"/>
-          <a:ea typeface="+mn-ea"/>
-          <a:cs typeface="+mn-cs"/>
-        </a:defRPr>
-      </a:lvl9pPr>
-    </p:otherStyle>
-  </p:txStyles>
-</p:sldMaster>
-</file>
-
 <file path=ppt/slides/slide1.xml><?xml version="1.0" encoding="utf-8"?>
 <p:sld xmlns:a="http://schemas.openxmlformats.org/drawingml/2006/main" xmlns:r="http://schemas.openxmlformats.org/officeDocument/2006/relationships" xmlns:p="http://schemas.openxmlformats.org/presentationml/2006/main">
   <p:cSld>
@@ -11463,320 +8239,6 @@
 </p:sld>
 </file>
 
-<file path=ppt/slides/slide10.xml><?xml version="1.0" encoding="utf-8"?>
-<p:sld xmlns:a="http://schemas.openxmlformats.org/drawingml/2006/main" xmlns:r="http://schemas.openxmlformats.org/officeDocument/2006/relationships" xmlns:p="http://schemas.openxmlformats.org/presentationml/2006/main">
-  <p:cSld>
-    <p:spTree>
-      <p:nvGrpSpPr>
-        <p:cNvPr id="1" name=""/>
-        <p:cNvGrpSpPr/>
-        <p:nvPr/>
-      </p:nvGrpSpPr>
-      <p:grpSpPr>
-        <a:xfrm>
-          <a:off x="0" y="0"/>
-          <a:ext cx="0" cy="0"/>
-          <a:chOff x="0" y="0"/>
-          <a:chExt cx="0" cy="0"/>
-        </a:xfrm>
-      </p:grpSpPr>
-      <p:pic>
-        <p:nvPicPr>
-          <p:cNvPr id="3" name="Picture 2" descr="A group of logos on a white background&#10;&#10;AI-generated content may be incorrect.">
-            <a:extLst>
-              <a:ext uri="{FF2B5EF4-FFF2-40B4-BE49-F238E27FC236}">
-                <a16:creationId xmlns:a16="http://schemas.microsoft.com/office/drawing/2014/main" id="{A078A602-BC7E-9251-368C-903E58F03BC6}"/>
-              </a:ext>
-            </a:extLst>
-          </p:cNvPr>
-          <p:cNvPicPr>
-            <a:picLocks noChangeAspect="1"/>
-          </p:cNvPicPr>
-          <p:nvPr/>
-        </p:nvPicPr>
-        <p:blipFill>
-          <a:blip r:embed="rId2">
-            <a:extLst>
-              <a:ext uri="{28A0092B-C50C-407E-A947-70E740481C1C}">
-                <a14:useLocalDpi xmlns:a14="http://schemas.microsoft.com/office/drawing/2010/main" val="0"/>
-              </a:ext>
-            </a:extLst>
-          </a:blip>
-          <a:stretch>
-            <a:fillRect/>
-          </a:stretch>
-        </p:blipFill>
-        <p:spPr>
-          <a:xfrm>
-            <a:off x="0" y="0"/>
-            <a:ext cx="12192000" cy="6858000"/>
-          </a:xfrm>
-          <a:prstGeom prst="rect">
-            <a:avLst/>
-          </a:prstGeom>
-        </p:spPr>
-      </p:pic>
-    </p:spTree>
-    <p:extLst>
-      <p:ext uri="{BB962C8B-B14F-4D97-AF65-F5344CB8AC3E}">
-        <p14:creationId xmlns:p14="http://schemas.microsoft.com/office/powerpoint/2010/main" val="360305890"/>
-      </p:ext>
-    </p:extLst>
-  </p:cSld>
-  <p:clrMapOvr>
-    <a:masterClrMapping/>
-  </p:clrMapOvr>
-</p:sld>
-</file>
-
-<file path=ppt/slides/slide11.xml><?xml version="1.0" encoding="utf-8"?>
-<p:sld xmlns:a="http://schemas.openxmlformats.org/drawingml/2006/main" xmlns:r="http://schemas.openxmlformats.org/officeDocument/2006/relationships" xmlns:p="http://schemas.openxmlformats.org/presentationml/2006/main">
-  <p:cSld>
-    <p:spTree>
-      <p:nvGrpSpPr>
-        <p:cNvPr id="1" name=""/>
-        <p:cNvGrpSpPr/>
-        <p:nvPr/>
-      </p:nvGrpSpPr>
-      <p:grpSpPr>
-        <a:xfrm>
-          <a:off x="0" y="0"/>
-          <a:ext cx="0" cy="0"/>
-          <a:chOff x="0" y="0"/>
-          <a:chExt cx="0" cy="0"/>
-        </a:xfrm>
-      </p:grpSpPr>
-      <p:pic>
-        <p:nvPicPr>
-          <p:cNvPr id="10" name="Picture 9" descr="A cow wearing sunglasses&#10;&#10;AI-generated content may be incorrect.">
-            <a:extLst>
-              <a:ext uri="{FF2B5EF4-FFF2-40B4-BE49-F238E27FC236}">
-                <a16:creationId xmlns:a16="http://schemas.microsoft.com/office/drawing/2014/main" id="{6DF4EDEF-746A-9FB0-25CD-78DE660D3430}"/>
-              </a:ext>
-            </a:extLst>
-          </p:cNvPr>
-          <p:cNvPicPr>
-            <a:picLocks noChangeAspect="1"/>
-          </p:cNvPicPr>
-          <p:nvPr/>
-        </p:nvPicPr>
-        <p:blipFill>
-          <a:blip r:embed="rId2">
-            <a:extLst>
-              <a:ext uri="{28A0092B-C50C-407E-A947-70E740481C1C}">
-                <a14:useLocalDpi xmlns:a14="http://schemas.microsoft.com/office/drawing/2010/main" val="0"/>
-              </a:ext>
-            </a:extLst>
-          </a:blip>
-          <a:stretch>
-            <a:fillRect/>
-          </a:stretch>
-        </p:blipFill>
-        <p:spPr>
-          <a:xfrm>
-            <a:off x="0" y="0"/>
-            <a:ext cx="12192000" cy="6858000"/>
-          </a:xfrm>
-          <a:prstGeom prst="rect">
-            <a:avLst/>
-          </a:prstGeom>
-        </p:spPr>
-      </p:pic>
-    </p:spTree>
-    <p:extLst>
-      <p:ext uri="{BB962C8B-B14F-4D97-AF65-F5344CB8AC3E}">
-        <p14:creationId xmlns:p14="http://schemas.microsoft.com/office/powerpoint/2010/main" val="2144819915"/>
-      </p:ext>
-    </p:extLst>
-  </p:cSld>
-  <p:clrMapOvr>
-    <a:masterClrMapping/>
-  </p:clrMapOvr>
-</p:sld>
-</file>
-
-<file path=ppt/slides/slide12.xml><?xml version="1.0" encoding="utf-8"?>
-<p:sld xmlns:a="http://schemas.openxmlformats.org/drawingml/2006/main" xmlns:r="http://schemas.openxmlformats.org/officeDocument/2006/relationships" xmlns:p="http://schemas.openxmlformats.org/presentationml/2006/main">
-  <p:cSld>
-    <p:spTree>
-      <p:nvGrpSpPr>
-        <p:cNvPr id="1" name=""/>
-        <p:cNvGrpSpPr/>
-        <p:nvPr/>
-      </p:nvGrpSpPr>
-      <p:grpSpPr>
-        <a:xfrm>
-          <a:off x="0" y="0"/>
-          <a:ext cx="0" cy="0"/>
-          <a:chOff x="0" y="0"/>
-          <a:chExt cx="0" cy="0"/>
-        </a:xfrm>
-      </p:grpSpPr>
-      <p:pic>
-        <p:nvPicPr>
-          <p:cNvPr id="3" name="Picture 2" descr="A blue map with white text&#10;&#10;AI-generated content may be incorrect.">
-            <a:extLst>
-              <a:ext uri="{FF2B5EF4-FFF2-40B4-BE49-F238E27FC236}">
-                <a16:creationId xmlns:a16="http://schemas.microsoft.com/office/drawing/2014/main" id="{4CA774EC-8E4C-70D5-FA67-037F602B3F35}"/>
-              </a:ext>
-            </a:extLst>
-          </p:cNvPr>
-          <p:cNvPicPr>
-            <a:picLocks noChangeAspect="1"/>
-          </p:cNvPicPr>
-          <p:nvPr/>
-        </p:nvPicPr>
-        <p:blipFill>
-          <a:blip r:embed="rId2">
-            <a:extLst>
-              <a:ext uri="{28A0092B-C50C-407E-A947-70E740481C1C}">
-                <a14:useLocalDpi xmlns:a14="http://schemas.microsoft.com/office/drawing/2010/main" val="0"/>
-              </a:ext>
-            </a:extLst>
-          </a:blip>
-          <a:stretch>
-            <a:fillRect/>
-          </a:stretch>
-        </p:blipFill>
-        <p:spPr>
-          <a:xfrm>
-            <a:off x="0" y="0"/>
-            <a:ext cx="12192000" cy="6858000"/>
-          </a:xfrm>
-          <a:prstGeom prst="rect">
-            <a:avLst/>
-          </a:prstGeom>
-        </p:spPr>
-      </p:pic>
-    </p:spTree>
-    <p:extLst>
-      <p:ext uri="{BB962C8B-B14F-4D97-AF65-F5344CB8AC3E}">
-        <p14:creationId xmlns:p14="http://schemas.microsoft.com/office/powerpoint/2010/main" val="258995175"/>
-      </p:ext>
-    </p:extLst>
-  </p:cSld>
-  <p:clrMapOvr>
-    <a:masterClrMapping/>
-  </p:clrMapOvr>
-</p:sld>
-</file>
-
-<file path=ppt/slides/slide13.xml><?xml version="1.0" encoding="utf-8"?>
-<p:sld xmlns:a="http://schemas.openxmlformats.org/drawingml/2006/main" xmlns:r="http://schemas.openxmlformats.org/officeDocument/2006/relationships" xmlns:p="http://schemas.openxmlformats.org/presentationml/2006/main">
-  <p:cSld>
-    <p:spTree>
-      <p:nvGrpSpPr>
-        <p:cNvPr id="1" name=""/>
-        <p:cNvGrpSpPr/>
-        <p:nvPr/>
-      </p:nvGrpSpPr>
-      <p:grpSpPr>
-        <a:xfrm>
-          <a:off x="0" y="0"/>
-          <a:ext cx="0" cy="0"/>
-          <a:chOff x="0" y="0"/>
-          <a:chExt cx="0" cy="0"/>
-        </a:xfrm>
-      </p:grpSpPr>
-      <p:sp>
-        <p:nvSpPr>
-          <p:cNvPr id="2" name="Title 1">
-            <a:extLst>
-              <a:ext uri="{FF2B5EF4-FFF2-40B4-BE49-F238E27FC236}">
-                <a16:creationId xmlns:a16="http://schemas.microsoft.com/office/drawing/2014/main" id="{133DF088-3A05-F62B-9249-2C136CA01544}"/>
-              </a:ext>
-            </a:extLst>
-          </p:cNvPr>
-          <p:cNvSpPr>
-            <a:spLocks noGrp="1"/>
-          </p:cNvSpPr>
-          <p:nvPr>
-            <p:ph type="title"/>
-          </p:nvPr>
-        </p:nvSpPr>
-        <p:spPr/>
-        <p:txBody>
-          <a:bodyPr/>
-          <a:lstStyle/>
-          <a:p>
-            <a:endParaRPr lang="en-GB"/>
-          </a:p>
-        </p:txBody>
-      </p:sp>
-      <p:sp>
-        <p:nvSpPr>
-          <p:cNvPr id="3" name="Content Placeholder 2">
-            <a:extLst>
-              <a:ext uri="{FF2B5EF4-FFF2-40B4-BE49-F238E27FC236}">
-                <a16:creationId xmlns:a16="http://schemas.microsoft.com/office/drawing/2014/main" id="{5C991EB7-0A1A-2421-AE65-E43831A063E7}"/>
-              </a:ext>
-            </a:extLst>
-          </p:cNvPr>
-          <p:cNvSpPr>
-            <a:spLocks noGrp="1"/>
-          </p:cNvSpPr>
-          <p:nvPr>
-            <p:ph idx="1"/>
-          </p:nvPr>
-        </p:nvSpPr>
-        <p:spPr/>
-        <p:txBody>
-          <a:bodyPr/>
-          <a:lstStyle/>
-          <a:p>
-            <a:endParaRPr lang="en-GB"/>
-          </a:p>
-        </p:txBody>
-      </p:sp>
-      <p:pic>
-        <p:nvPicPr>
-          <p:cNvPr id="6" name="Picture 5" descr="A qr code on a blue background&#10;&#10;AI-generated content may be incorrect.">
-            <a:extLst>
-              <a:ext uri="{FF2B5EF4-FFF2-40B4-BE49-F238E27FC236}">
-                <a16:creationId xmlns:a16="http://schemas.microsoft.com/office/drawing/2014/main" id="{8075FE51-F9AC-6F8D-1466-57E356A3E8BC}"/>
-              </a:ext>
-            </a:extLst>
-          </p:cNvPr>
-          <p:cNvPicPr>
-            <a:picLocks noChangeAspect="1"/>
-          </p:cNvPicPr>
-          <p:nvPr/>
-        </p:nvPicPr>
-        <p:blipFill>
-          <a:blip r:embed="rId2">
-            <a:extLst>
-              <a:ext uri="{28A0092B-C50C-407E-A947-70E740481C1C}">
-                <a14:useLocalDpi xmlns:a14="http://schemas.microsoft.com/office/drawing/2010/main" val="0"/>
-              </a:ext>
-            </a:extLst>
-          </a:blip>
-          <a:stretch>
-            <a:fillRect/>
-          </a:stretch>
-        </p:blipFill>
-        <p:spPr>
-          <a:xfrm>
-            <a:off x="0" y="0"/>
-            <a:ext cx="12192000" cy="6858000"/>
-          </a:xfrm>
-          <a:prstGeom prst="rect">
-            <a:avLst/>
-          </a:prstGeom>
-        </p:spPr>
-      </p:pic>
-    </p:spTree>
-    <p:extLst>
-      <p:ext uri="{BB962C8B-B14F-4D97-AF65-F5344CB8AC3E}">
-        <p14:creationId xmlns:p14="http://schemas.microsoft.com/office/powerpoint/2010/main" val="1961775137"/>
-      </p:ext>
-    </p:extLst>
-  </p:cSld>
-  <p:clrMapOvr>
-    <a:masterClrMapping/>
-  </p:clrMapOvr>
-</p:sld>
-</file>
-
 <file path=ppt/slides/slide2.xml><?xml version="1.0" encoding="utf-8"?>
 <p:sld xmlns:a="http://schemas.openxmlformats.org/drawingml/2006/main" xmlns:r="http://schemas.openxmlformats.org/officeDocument/2006/relationships" xmlns:p="http://schemas.openxmlformats.org/presentationml/2006/main">
   <p:cSld>
@@ -11948,10 +8410,10 @@
       </p:grpSpPr>
       <p:pic>
         <p:nvPicPr>
-          <p:cNvPr id="3" name="Picture 2" descr="A group of logos on a white background&#10;&#10;AI-generated content may be incorrect.">
+          <p:cNvPr id="4" name="Picture 3" descr="A picture containing person, looking, cellphone, phone&#10;&#10;Description automatically generated">
             <a:extLst>
               <a:ext uri="{FF2B5EF4-FFF2-40B4-BE49-F238E27FC236}">
-                <a16:creationId xmlns:a16="http://schemas.microsoft.com/office/drawing/2014/main" id="{A078A602-BC7E-9251-368C-903E58F03BC6}"/>
+                <a16:creationId xmlns:a16="http://schemas.microsoft.com/office/drawing/2014/main" id="{891EB2BC-E034-D456-D531-ADC2ED9E132E}"/>
               </a:ext>
             </a:extLst>
           </p:cNvPr>
@@ -11960,58 +8422,21 @@
           </p:cNvPicPr>
           <p:nvPr/>
         </p:nvPicPr>
-        <p:blipFill>
-          <a:blip r:embed="rId2">
-            <a:extLst>
-              <a:ext uri="{28A0092B-C50C-407E-A947-70E740481C1C}">
-                <a14:useLocalDpi xmlns:a14="http://schemas.microsoft.com/office/drawing/2010/main" val="0"/>
-              </a:ext>
-            </a:extLst>
-          </a:blip>
-          <a:stretch>
-            <a:fillRect/>
-          </a:stretch>
+        <p:blipFill rotWithShape="1">
+          <a:blip r:embed="rId2"/>
+          <a:srcRect l="40596"/>
+          <a:stretch/>
         </p:blipFill>
         <p:spPr>
           <a:xfrm>
-            <a:off x="0" y="0"/>
-            <a:ext cx="12192000" cy="6858000"/>
+            <a:off x="7922083" y="0"/>
+            <a:ext cx="4269917" cy="6858000"/>
           </a:xfrm>
           <a:prstGeom prst="rect">
             <a:avLst/>
           </a:prstGeom>
         </p:spPr>
       </p:pic>
-    </p:spTree>
-    <p:extLst>
-      <p:ext uri="{BB962C8B-B14F-4D97-AF65-F5344CB8AC3E}">
-        <p14:creationId xmlns:p14="http://schemas.microsoft.com/office/powerpoint/2010/main" val="3136983065"/>
-      </p:ext>
-    </p:extLst>
-  </p:cSld>
-  <p:clrMapOvr>
-    <a:masterClrMapping/>
-  </p:clrMapOvr>
-</p:sld>
-</file>
-
-<file path=ppt/slides/slide4.xml><?xml version="1.0" encoding="utf-8"?>
-<p:sld xmlns:a="http://schemas.openxmlformats.org/drawingml/2006/main" xmlns:r="http://schemas.openxmlformats.org/officeDocument/2006/relationships" xmlns:p="http://schemas.openxmlformats.org/presentationml/2006/main">
-  <p:cSld>
-    <p:spTree>
-      <p:nvGrpSpPr>
-        <p:cNvPr id="1" name=""/>
-        <p:cNvGrpSpPr/>
-        <p:nvPr/>
-      </p:nvGrpSpPr>
-      <p:grpSpPr>
-        <a:xfrm>
-          <a:off x="0" y="0"/>
-          <a:ext cx="0" cy="0"/>
-          <a:chOff x="0" y="0"/>
-          <a:chExt cx="0" cy="0"/>
-        </a:xfrm>
-      </p:grpSpPr>
       <p:sp>
         <p:nvSpPr>
           <p:cNvPr id="2" name="Rubrik 1"/>
@@ -12096,53 +8521,6 @@
           </a:p>
         </p:txBody>
       </p:sp>
-      <p:pic>
-        <p:nvPicPr>
-          <p:cNvPr id="3074" name="Picture 2" descr="It's SQL Friday">
-            <a:extLst>
-              <a:ext uri="{FF2B5EF4-FFF2-40B4-BE49-F238E27FC236}">
-                <a16:creationId xmlns:a16="http://schemas.microsoft.com/office/drawing/2014/main" id="{55C1E9F1-1FC2-A8A4-2E27-8848A1CD7AD8}"/>
-              </a:ext>
-            </a:extLst>
-          </p:cNvPr>
-          <p:cNvPicPr>
-            <a:picLocks noChangeAspect="1" noChangeArrowheads="1"/>
-          </p:cNvPicPr>
-          <p:nvPr/>
-        </p:nvPicPr>
-        <p:blipFill>
-          <a:blip r:embed="rId2">
-            <a:extLst>
-              <a:ext uri="{28A0092B-C50C-407E-A947-70E740481C1C}">
-                <a14:useLocalDpi xmlns:a14="http://schemas.microsoft.com/office/drawing/2010/main" val="0"/>
-              </a:ext>
-            </a:extLst>
-          </a:blip>
-          <a:srcRect/>
-          <a:stretch>
-            <a:fillRect/>
-          </a:stretch>
-        </p:blipFill>
-        <p:spPr bwMode="auto">
-          <a:xfrm>
-            <a:off x="8042553" y="816638"/>
-            <a:ext cx="2857500" cy="2228850"/>
-          </a:xfrm>
-          <a:prstGeom prst="rect">
-            <a:avLst/>
-          </a:prstGeom>
-          <a:noFill/>
-          <a:extLst>
-            <a:ext uri="{909E8E84-426E-40DD-AFC4-6F175D3DCCD1}">
-              <a14:hiddenFill xmlns:a14="http://schemas.microsoft.com/office/drawing/2010/main">
-                <a:solidFill>
-                  <a:srgbClr val="FFFFFF"/>
-                </a:solidFill>
-              </a14:hiddenFill>
-            </a:ext>
-          </a:extLst>
-        </p:spPr>
-      </p:pic>
       <p:pic>
         <p:nvPicPr>
           <p:cNvPr id="3076" name="Picture 4">
@@ -12172,7 +8550,7 @@
         </p:blipFill>
         <p:spPr bwMode="auto">
           <a:xfrm>
-            <a:off x="8042553" y="3429000"/>
+            <a:off x="7922083" y="6153150"/>
             <a:ext cx="1724025" cy="704850"/>
           </a:xfrm>
           <a:prstGeom prst="rect">
@@ -12203,7 +8581,7 @@
 </p:sld>
 </file>
 
-<file path=ppt/slides/slide5.xml><?xml version="1.0" encoding="utf-8"?>
+<file path=ppt/slides/slide4.xml><?xml version="1.0" encoding="utf-8"?>
 <p:sld xmlns:a="http://schemas.openxmlformats.org/drawingml/2006/main" xmlns:r="http://schemas.openxmlformats.org/officeDocument/2006/relationships" xmlns:p="http://schemas.openxmlformats.org/presentationml/2006/main">
   <p:cSld>
     <p:spTree>
@@ -12737,7 +9115,7 @@
 </p:sld>
 </file>
 
-<file path=ppt/slides/slide6.xml><?xml version="1.0" encoding="utf-8"?>
+<file path=ppt/slides/slide5.xml><?xml version="1.0" encoding="utf-8"?>
 <p:sld xmlns:a="http://schemas.openxmlformats.org/drawingml/2006/main" xmlns:r="http://schemas.openxmlformats.org/officeDocument/2006/relationships" xmlns:p="http://schemas.openxmlformats.org/presentationml/2006/main">
   <p:cSld>
     <p:spTree>
@@ -13131,7 +9509,7 @@
 </p:sld>
 </file>
 
-<file path=ppt/slides/slide7.xml><?xml version="1.0" encoding="utf-8"?>
+<file path=ppt/slides/slide6.xml><?xml version="1.0" encoding="utf-8"?>
 <p:sld xmlns:a="http://schemas.openxmlformats.org/drawingml/2006/main" xmlns:r="http://schemas.openxmlformats.org/officeDocument/2006/relationships" xmlns:p="http://schemas.openxmlformats.org/presentationml/2006/main">
   <p:cSld>
     <p:spTree>
@@ -13563,7 +9941,7 @@
 </p:sld>
 </file>
 
-<file path=ppt/slides/slide8.xml><?xml version="1.0" encoding="utf-8"?>
+<file path=ppt/slides/slide7.xml><?xml version="1.0" encoding="utf-8"?>
 <p:sld xmlns:a="http://schemas.openxmlformats.org/drawingml/2006/main" xmlns:r="http://schemas.openxmlformats.org/officeDocument/2006/relationships" xmlns:p="http://schemas.openxmlformats.org/presentationml/2006/main">
   <p:cSld>
     <p:spTree>
@@ -13667,7 +10045,7 @@
 </p:sld>
 </file>
 
-<file path=ppt/slides/slide9.xml><?xml version="1.0" encoding="utf-8"?>
+<file path=ppt/slides/slide8.xml><?xml version="1.0" encoding="utf-8"?>
 <p:sld xmlns:a="http://schemas.openxmlformats.org/drawingml/2006/main" xmlns:r="http://schemas.openxmlformats.org/officeDocument/2006/relationships" xmlns:p="http://schemas.openxmlformats.org/presentationml/2006/main">
   <p:cSld>
     <p:spTree>
@@ -14338,319 +10716,4 @@
     </a:ext>
   </a:extLst>
 </a:theme>
-</file>
-
-<file path=ppt/theme/theme3.xml><?xml version="1.0" encoding="utf-8"?>
-<a:theme xmlns:a="http://schemas.openxmlformats.org/drawingml/2006/main" name="1_Office Theme">
-  <a:themeElements>
-    <a:clrScheme name="Office">
-      <a:dk1>
-        <a:sysClr val="windowText" lastClr="000000"/>
-      </a:dk1>
-      <a:lt1>
-        <a:sysClr val="window" lastClr="FFFFFF"/>
-      </a:lt1>
-      <a:dk2>
-        <a:srgbClr val="0E2841"/>
-      </a:dk2>
-      <a:lt2>
-        <a:srgbClr val="E8E8E8"/>
-      </a:lt2>
-      <a:accent1>
-        <a:srgbClr val="156082"/>
-      </a:accent1>
-      <a:accent2>
-        <a:srgbClr val="E97132"/>
-      </a:accent2>
-      <a:accent3>
-        <a:srgbClr val="196B24"/>
-      </a:accent3>
-      <a:accent4>
-        <a:srgbClr val="0F9ED5"/>
-      </a:accent4>
-      <a:accent5>
-        <a:srgbClr val="A02B93"/>
-      </a:accent5>
-      <a:accent6>
-        <a:srgbClr val="4EA72E"/>
-      </a:accent6>
-      <a:hlink>
-        <a:srgbClr val="467886"/>
-      </a:hlink>
-      <a:folHlink>
-        <a:srgbClr val="96607D"/>
-      </a:folHlink>
-    </a:clrScheme>
-    <a:fontScheme name="Office">
-      <a:majorFont>
-        <a:latin typeface="Aptos Display" panose="02110004020202020204"/>
-        <a:ea typeface=""/>
-        <a:cs typeface=""/>
-        <a:font script="Jpan" typeface="游ゴシック Light"/>
-        <a:font script="Hang" typeface="맑은 고딕"/>
-        <a:font script="Hans" typeface="等线 Light"/>
-        <a:font script="Hant" typeface="新細明體"/>
-        <a:font script="Arab" typeface="Times New Roman"/>
-        <a:font script="Hebr" typeface="Times New Roman"/>
-        <a:font script="Thai" typeface="Angsana New"/>
-        <a:font script="Ethi" typeface="Nyala"/>
-        <a:font script="Beng" typeface="Vrinda"/>
-        <a:font script="Gujr" typeface="Shruti"/>
-        <a:font script="Khmr" typeface="MoolBoran"/>
-        <a:font script="Knda" typeface="Tunga"/>
-        <a:font script="Guru" typeface="Raavi"/>
-        <a:font script="Cans" typeface="Euphemia"/>
-        <a:font script="Cher" typeface="Plantagenet Cherokee"/>
-        <a:font script="Yiii" typeface="Microsoft Yi Baiti"/>
-        <a:font script="Tibt" typeface="Microsoft Himalaya"/>
-        <a:font script="Thaa" typeface="MV Boli"/>
-        <a:font script="Deva" typeface="Mangal"/>
-        <a:font script="Telu" typeface="Gautami"/>
-        <a:font script="Taml" typeface="Latha"/>
-        <a:font script="Syrc" typeface="Estrangelo Edessa"/>
-        <a:font script="Orya" typeface="Kalinga"/>
-        <a:font script="Mlym" typeface="Kartika"/>
-        <a:font script="Laoo" typeface="DokChampa"/>
-        <a:font script="Sinh" typeface="Iskoola Pota"/>
-        <a:font script="Mong" typeface="Mongolian Baiti"/>
-        <a:font script="Viet" typeface="Times New Roman"/>
-        <a:font script="Uigh" typeface="Microsoft Uighur"/>
-        <a:font script="Geor" typeface="Sylfaen"/>
-        <a:font script="Armn" typeface="Arial"/>
-        <a:font script="Bugi" typeface="Leelawadee UI"/>
-        <a:font script="Bopo" typeface="Microsoft JhengHei"/>
-        <a:font script="Java" typeface="Javanese Text"/>
-        <a:font script="Lisu" typeface="Segoe UI"/>
-        <a:font script="Mymr" typeface="Myanmar Text"/>
-        <a:font script="Nkoo" typeface="Ebrima"/>
-        <a:font script="Olck" typeface="Nirmala UI"/>
-        <a:font script="Osma" typeface="Ebrima"/>
-        <a:font script="Phag" typeface="Phagspa"/>
-        <a:font script="Syrn" typeface="Estrangelo Edessa"/>
-        <a:font script="Syrj" typeface="Estrangelo Edessa"/>
-        <a:font script="Syre" typeface="Estrangelo Edessa"/>
-        <a:font script="Sora" typeface="Nirmala UI"/>
-        <a:font script="Tale" typeface="Microsoft Tai Le"/>
-        <a:font script="Talu" typeface="Microsoft New Tai Lue"/>
-        <a:font script="Tfng" typeface="Ebrima"/>
-      </a:majorFont>
-      <a:minorFont>
-        <a:latin typeface="Aptos" panose="02110004020202020204"/>
-        <a:ea typeface=""/>
-        <a:cs typeface=""/>
-        <a:font script="Jpan" typeface="游ゴシック"/>
-        <a:font script="Hang" typeface="맑은 고딕"/>
-        <a:font script="Hans" typeface="等线"/>
-        <a:font script="Hant" typeface="新細明體"/>
-        <a:font script="Arab" typeface="Arial"/>
-        <a:font script="Hebr" typeface="Arial"/>
-        <a:font script="Thai" typeface="Cordia New"/>
-        <a:font script="Ethi" typeface="Nyala"/>
-        <a:font script="Beng" typeface="Vrinda"/>
-        <a:font script="Gujr" typeface="Shruti"/>
-        <a:font script="Khmr" typeface="DaunPenh"/>
-        <a:font script="Knda" typeface="Tunga"/>
-        <a:font script="Guru" typeface="Raavi"/>
-        <a:font script="Cans" typeface="Euphemia"/>
-        <a:font script="Cher" typeface="Plantagenet Cherokee"/>
-        <a:font script="Yiii" typeface="Microsoft Yi Baiti"/>
-        <a:font script="Tibt" typeface="Microsoft Himalaya"/>
-        <a:font script="Thaa" typeface="MV Boli"/>
-        <a:font script="Deva" typeface="Mangal"/>
-        <a:font script="Telu" typeface="Gautami"/>
-        <a:font script="Taml" typeface="Latha"/>
-        <a:font script="Syrc" typeface="Estrangelo Edessa"/>
-        <a:font script="Orya" typeface="Kalinga"/>
-        <a:font script="Mlym" typeface="Kartika"/>
-        <a:font script="Laoo" typeface="DokChampa"/>
-        <a:font script="Sinh" typeface="Iskoola Pota"/>
-        <a:font script="Mong" typeface="Mongolian Baiti"/>
-        <a:font script="Viet" typeface="Arial"/>
-        <a:font script="Uigh" typeface="Microsoft Uighur"/>
-        <a:font script="Geor" typeface="Sylfaen"/>
-        <a:font script="Armn" typeface="Arial"/>
-        <a:font script="Bugi" typeface="Leelawadee UI"/>
-        <a:font script="Bopo" typeface="Microsoft JhengHei"/>
-        <a:font script="Java" typeface="Javanese Text"/>
-        <a:font script="Lisu" typeface="Segoe UI"/>
-        <a:font script="Mymr" typeface="Myanmar Text"/>
-        <a:font script="Nkoo" typeface="Ebrima"/>
-        <a:font script="Olck" typeface="Nirmala UI"/>
-        <a:font script="Osma" typeface="Ebrima"/>
-        <a:font script="Phag" typeface="Phagspa"/>
-        <a:font script="Syrn" typeface="Estrangelo Edessa"/>
-        <a:font script="Syrj" typeface="Estrangelo Edessa"/>
-        <a:font script="Syre" typeface="Estrangelo Edessa"/>
-        <a:font script="Sora" typeface="Nirmala UI"/>
-        <a:font script="Tale" typeface="Microsoft Tai Le"/>
-        <a:font script="Talu" typeface="Microsoft New Tai Lue"/>
-        <a:font script="Tfng" typeface="Ebrima"/>
-      </a:minorFont>
-    </a:fontScheme>
-    <a:fmtScheme name="Office">
-      <a:fillStyleLst>
-        <a:solidFill>
-          <a:schemeClr val="phClr"/>
-        </a:solidFill>
-        <a:gradFill rotWithShape="1">
-          <a:gsLst>
-            <a:gs pos="0">
-              <a:schemeClr val="phClr">
-                <a:lumMod val="110000"/>
-                <a:satMod val="105000"/>
-                <a:tint val="67000"/>
-              </a:schemeClr>
-            </a:gs>
-            <a:gs pos="50000">
-              <a:schemeClr val="phClr">
-                <a:lumMod val="105000"/>
-                <a:satMod val="103000"/>
-                <a:tint val="73000"/>
-              </a:schemeClr>
-            </a:gs>
-            <a:gs pos="100000">
-              <a:schemeClr val="phClr">
-                <a:lumMod val="105000"/>
-                <a:satMod val="109000"/>
-                <a:tint val="81000"/>
-              </a:schemeClr>
-            </a:gs>
-          </a:gsLst>
-          <a:lin ang="5400000" scaled="0"/>
-        </a:gradFill>
-        <a:gradFill rotWithShape="1">
-          <a:gsLst>
-            <a:gs pos="0">
-              <a:schemeClr val="phClr">
-                <a:satMod val="103000"/>
-                <a:lumMod val="102000"/>
-                <a:tint val="94000"/>
-              </a:schemeClr>
-            </a:gs>
-            <a:gs pos="50000">
-              <a:schemeClr val="phClr">
-                <a:satMod val="110000"/>
-                <a:lumMod val="100000"/>
-                <a:shade val="100000"/>
-              </a:schemeClr>
-            </a:gs>
-            <a:gs pos="100000">
-              <a:schemeClr val="phClr">
-                <a:lumMod val="99000"/>
-                <a:satMod val="120000"/>
-                <a:shade val="78000"/>
-              </a:schemeClr>
-            </a:gs>
-          </a:gsLst>
-          <a:lin ang="5400000" scaled="0"/>
-        </a:gradFill>
-      </a:fillStyleLst>
-      <a:lnStyleLst>
-        <a:ln w="12700" cap="flat" cmpd="sng" algn="ctr">
-          <a:solidFill>
-            <a:schemeClr val="phClr"/>
-          </a:solidFill>
-          <a:prstDash val="solid"/>
-          <a:miter lim="800000"/>
-        </a:ln>
-        <a:ln w="19050" cap="flat" cmpd="sng" algn="ctr">
-          <a:solidFill>
-            <a:schemeClr val="phClr"/>
-          </a:solidFill>
-          <a:prstDash val="solid"/>
-          <a:miter lim="800000"/>
-        </a:ln>
-        <a:ln w="25400" cap="flat" cmpd="sng" algn="ctr">
-          <a:solidFill>
-            <a:schemeClr val="phClr"/>
-          </a:solidFill>
-          <a:prstDash val="solid"/>
-          <a:miter lim="800000"/>
-        </a:ln>
-      </a:lnStyleLst>
-      <a:effectStyleLst>
-        <a:effectStyle>
-          <a:effectLst/>
-        </a:effectStyle>
-        <a:effectStyle>
-          <a:effectLst/>
-        </a:effectStyle>
-        <a:effectStyle>
-          <a:effectLst>
-            <a:outerShdw blurRad="57150" dist="19050" dir="5400000" algn="ctr" rotWithShape="0">
-              <a:srgbClr val="000000">
-                <a:alpha val="63000"/>
-              </a:srgbClr>
-            </a:outerShdw>
-          </a:effectLst>
-        </a:effectStyle>
-      </a:effectStyleLst>
-      <a:bgFillStyleLst>
-        <a:solidFill>
-          <a:schemeClr val="phClr"/>
-        </a:solidFill>
-        <a:solidFill>
-          <a:schemeClr val="phClr">
-            <a:tint val="95000"/>
-            <a:satMod val="170000"/>
-          </a:schemeClr>
-        </a:solidFill>
-        <a:gradFill rotWithShape="1">
-          <a:gsLst>
-            <a:gs pos="0">
-              <a:schemeClr val="phClr">
-                <a:tint val="93000"/>
-                <a:satMod val="150000"/>
-                <a:shade val="98000"/>
-                <a:lumMod val="102000"/>
-              </a:schemeClr>
-            </a:gs>
-            <a:gs pos="50000">
-              <a:schemeClr val="phClr">
-                <a:tint val="98000"/>
-                <a:satMod val="130000"/>
-                <a:shade val="90000"/>
-                <a:lumMod val="103000"/>
-              </a:schemeClr>
-            </a:gs>
-            <a:gs pos="100000">
-              <a:schemeClr val="phClr">
-                <a:shade val="63000"/>
-                <a:satMod val="120000"/>
-              </a:schemeClr>
-            </a:gs>
-          </a:gsLst>
-          <a:lin ang="5400000" scaled="0"/>
-        </a:gradFill>
-      </a:bgFillStyleLst>
-    </a:fmtScheme>
-  </a:themeElements>
-  <a:objectDefaults>
-    <a:lnDef>
-      <a:spPr/>
-      <a:bodyPr/>
-      <a:lstStyle/>
-      <a:style>
-        <a:lnRef idx="2">
-          <a:schemeClr val="accent1"/>
-        </a:lnRef>
-        <a:fillRef idx="0">
-          <a:schemeClr val="accent1"/>
-        </a:fillRef>
-        <a:effectRef idx="1">
-          <a:schemeClr val="accent1"/>
-        </a:effectRef>
-        <a:fontRef idx="minor">
-          <a:schemeClr val="tx1"/>
-        </a:fontRef>
-      </a:style>
-    </a:lnDef>
-  </a:objectDefaults>
-  <a:extraClrSchemeLst/>
-  <a:extLst>
-    <a:ext uri="{05A4C25C-085E-4340-85A3-A5531E510DB2}">
-      <thm15:themeFamily xmlns:thm15="http://schemas.microsoft.com/office/thememl/2012/main" name="Office Theme" id="{2E142A2C-CD16-42D6-873A-C26D2A0506FA}" vid="{1BDDFF52-6CD6-40A5-AB3C-68EB2F1E4D0A}"/>
-    </a:ext>
-  </a:extLst>
-</a:theme>
 </file>
</xml_diff>